<commit_message>
Convert PPT presentation from Arabic to English
Co-authored-by: Razan-Eldaif <183640167+Razan-Eldaif@users.noreply.github.com>
</commit_message>
<xml_diff>
--- a/Software_Testing_Diploma_Beginners.pptx
+++ b/Software_Testing_Diploma_Beginners.pptx
@@ -3314,17 +3314,19 @@
       </p:sp>
       <p:sp>
         <p:nvSpPr>
-          <p:cNvPr id="7" name="Rectangle 6"/>
+          <p:cNvPr id="7" name="Rounded Rectangle 6"/>
           <p:cNvSpPr/>
           <p:nvPr/>
         </p:nvSpPr>
         <p:spPr>
           <a:xfrm>
-            <a:off x="1097280" y="1463040"/>
-            <a:ext cx="1645920" cy="50800"/>
-          </a:xfrm>
-          <a:prstGeom prst="rect">
-            <a:avLst/>
+            <a:off x="1097280" y="1005840"/>
+            <a:ext cx="1371600" cy="347472"/>
+          </a:xfrm>
+          <a:prstGeom prst="roundRect">
+            <a:avLst>
+              <a:gd name="adj" fmla="val 8000"/>
+            </a:avLst>
           </a:prstGeom>
           <a:solidFill>
             <a:srgbClr val="06B6D4"/>
@@ -3357,19 +3359,51 @@
       </p:sp>
       <p:sp>
         <p:nvSpPr>
-          <p:cNvPr id="8" name="Rounded Rectangle 7"/>
+          <p:cNvPr id="8" name="TextBox 7"/>
+          <p:cNvSpPr txBox="1"/>
+          <p:nvPr/>
+        </p:nvSpPr>
+        <p:spPr>
+          <a:xfrm>
+            <a:off x="1115568" y="1024128"/>
+            <a:ext cx="1353312" cy="320040"/>
+          </a:xfrm>
+          <a:prstGeom prst="rect">
+            <a:avLst/>
+          </a:prstGeom>
+          <a:noFill/>
+        </p:spPr>
+        <p:txBody>
+          <a:bodyPr wrap="square">
+            <a:spAutoFit/>
+          </a:bodyPr>
+          <a:lstStyle/>
+          <a:p>
+            <a:pPr algn="ctr"/>
+            <a:r>
+              <a:rPr sz="1000" b="1" i="0">
+                <a:solidFill>
+                  <a:srgbClr val="0A1F44"/>
+                </a:solidFill>
+              </a:rPr>
+              <a:t>✦  NEW 2025</a:t>
+            </a:r>
+          </a:p>
+        </p:txBody>
+      </p:sp>
+      <p:sp>
+        <p:nvSpPr>
+          <p:cNvPr id="9" name="Rectangle 8"/>
           <p:cNvSpPr/>
           <p:nvPr/>
         </p:nvSpPr>
         <p:spPr>
           <a:xfrm>
-            <a:off x="1097280" y="1005840"/>
-            <a:ext cx="1280160" cy="347472"/>
-          </a:xfrm>
-          <a:prstGeom prst="roundRect">
-            <a:avLst>
-              <a:gd name="adj" fmla="val 8000"/>
-            </a:avLst>
+            <a:off x="1097280" y="1481328"/>
+            <a:ext cx="1828800" cy="50800"/>
+          </a:xfrm>
+          <a:prstGeom prst="rect">
+            <a:avLst/>
           </a:prstGeom>
           <a:solidFill>
             <a:srgbClr val="06B6D4"/>
@@ -3402,40 +3436,6 @@
       </p:sp>
       <p:sp>
         <p:nvSpPr>
-          <p:cNvPr id="9" name="TextBox 8"/>
-          <p:cNvSpPr txBox="1"/>
-          <p:nvPr/>
-        </p:nvSpPr>
-        <p:spPr>
-          <a:xfrm>
-            <a:off x="1115568" y="1024128"/>
-            <a:ext cx="1261872" cy="320040"/>
-          </a:xfrm>
-          <a:prstGeom prst="rect">
-            <a:avLst/>
-          </a:prstGeom>
-          <a:noFill/>
-        </p:spPr>
-        <p:txBody>
-          <a:bodyPr wrap="square">
-            <a:spAutoFit/>
-          </a:bodyPr>
-          <a:lstStyle/>
-          <a:p>
-            <a:pPr algn="ctr"/>
-            <a:r>
-              <a:rPr sz="1000" b="1" i="0">
-                <a:solidFill>
-                  <a:srgbClr val="0A1F44"/>
-                </a:solidFill>
-              </a:rPr>
-              <a:t>✦  NEW 2025</a:t>
-            </a:r>
-          </a:p>
-        </p:txBody>
-      </p:sp>
-      <p:sp>
-        <p:nvSpPr>
           <p:cNvPr id="10" name="TextBox 9"/>
           <p:cNvSpPr txBox="1"/>
           <p:nvPr/>
@@ -3443,7 +3443,7 @@
         <p:spPr>
           <a:xfrm>
             <a:off x="1097280" y="1691640"/>
-            <a:ext cx="7315200" cy="822960"/>
+            <a:ext cx="8229600" cy="841248"/>
           </a:xfrm>
           <a:prstGeom prst="rect">
             <a:avLst/>
@@ -3463,7 +3463,7 @@
                   <a:srgbClr val="FFFFFF"/>
                 </a:solidFill>
               </a:rPr>
-              <a:t>دبلومة</a:t>
+              <a:t>Software Testing</a:t>
             </a:r>
           </a:p>
         </p:txBody>
@@ -3476,8 +3476,8 @@
         </p:nvSpPr>
         <p:spPr>
           <a:xfrm>
-            <a:off x="1097280" y="2331720"/>
-            <a:ext cx="8229600" cy="914400"/>
+            <a:off x="1097280" y="2487168"/>
+            <a:ext cx="8229600" cy="841248"/>
           </a:xfrm>
           <a:prstGeom prst="rect">
             <a:avLst/>
@@ -3497,7 +3497,7 @@
                   <a:srgbClr val="06B6D4"/>
                 </a:solidFill>
               </a:rPr>
-              <a:t>اختبار البرمجيات</a:t>
+              <a:t>Diploma</a:t>
             </a:r>
           </a:p>
         </p:txBody>
@@ -3510,8 +3510,8 @@
         </p:nvSpPr>
         <p:spPr>
           <a:xfrm>
-            <a:off x="1097280" y="3063240"/>
-            <a:ext cx="7315200" cy="822960"/>
+            <a:off x="1097280" y="3273552"/>
+            <a:ext cx="8229600" cy="749808"/>
           </a:xfrm>
           <a:prstGeom prst="rect">
             <a:avLst/>
@@ -3531,7 +3531,7 @@
                   <a:srgbClr val="FFFFFF"/>
                 </a:solidFill>
               </a:rPr>
-              <a:t>للمبتدئين</a:t>
+              <a:t>for Beginners</a:t>
             </a:r>
           </a:p>
         </p:txBody>
@@ -3544,8 +3544,8 @@
         </p:nvSpPr>
         <p:spPr>
           <a:xfrm>
-            <a:off x="1097280" y="3886200"/>
-            <a:ext cx="8229600" cy="457200"/>
+            <a:off x="1097280" y="4114800"/>
+            <a:ext cx="8686800" cy="457200"/>
           </a:xfrm>
           <a:prstGeom prst="rect">
             <a:avLst/>
@@ -3560,12 +3560,12 @@
           <a:p>
             <a:pPr algn="l"/>
             <a:r>
-              <a:rPr sz="1800" b="0" i="0">
+              <a:rPr sz="1700" b="0" i="0">
                 <a:solidFill>
                   <a:srgbClr val="9CA3AF"/>
                 </a:solidFill>
               </a:rPr>
-              <a:t>Software Testing Diploma  —  Beginners Track</a:t>
+              <a:t>Launch your QA career with a structured, hands-on 2-month program</a:t>
             </a:r>
           </a:p>
         </p:txBody>
@@ -3578,7 +3578,7 @@
         </p:nvSpPr>
         <p:spPr>
           <a:xfrm>
-            <a:off x="1097280" y="4754880"/>
+            <a:off x="1097280" y="4773168"/>
             <a:ext cx="2468880" cy="1371600"/>
           </a:xfrm>
           <a:prstGeom prst="roundRect">
@@ -3623,7 +3623,7 @@
         </p:nvSpPr>
         <p:spPr>
           <a:xfrm>
-            <a:off x="1207008" y="4828032"/>
+            <a:off x="1207008" y="4846320"/>
             <a:ext cx="457200" cy="457200"/>
           </a:xfrm>
           <a:prstGeom prst="rect">
@@ -3657,7 +3657,7 @@
         </p:nvSpPr>
         <p:spPr>
           <a:xfrm>
-            <a:off x="1207008" y="5230368"/>
+            <a:off x="1207008" y="5248656"/>
             <a:ext cx="2194560" cy="384048"/>
           </a:xfrm>
           <a:prstGeom prst="rect">
@@ -3678,7 +3678,7 @@
                   <a:srgbClr val="06B6D4"/>
                 </a:solidFill>
               </a:rPr>
-              <a:t>شهرين</a:t>
+              <a:t>2 Months</a:t>
             </a:r>
           </a:p>
         </p:txBody>
@@ -3691,8 +3691,8 @@
         </p:nvSpPr>
         <p:spPr>
           <a:xfrm>
-            <a:off x="1207008" y="5596128"/>
-            <a:ext cx="2194560" cy="347472"/>
+            <a:off x="1207008" y="5641848"/>
+            <a:ext cx="2194560" cy="320040"/>
           </a:xfrm>
           <a:prstGeom prst="rect">
             <a:avLst/>
@@ -3712,7 +3712,7 @@
                   <a:srgbClr val="9CA3AF"/>
                 </a:solidFill>
               </a:rPr>
-              <a:t>مدة البرنامج</a:t>
+              <a:t>Duration</a:t>
             </a:r>
           </a:p>
         </p:txBody>
@@ -3725,7 +3725,7 @@
         </p:nvSpPr>
         <p:spPr>
           <a:xfrm>
-            <a:off x="3840480" y="4754880"/>
+            <a:off x="3840480" y="4773168"/>
             <a:ext cx="2468880" cy="1371600"/>
           </a:xfrm>
           <a:prstGeom prst="roundRect">
@@ -3770,7 +3770,7 @@
         </p:nvSpPr>
         <p:spPr>
           <a:xfrm>
-            <a:off x="3950208" y="4828032"/>
+            <a:off x="3950208" y="4846320"/>
             <a:ext cx="457200" cy="457200"/>
           </a:xfrm>
           <a:prstGeom prst="rect">
@@ -3791,7 +3791,7 @@
                   <a:srgbClr val="FFFFFF"/>
                 </a:solidFill>
               </a:rPr>
-              <a:t>��</a:t>
+              <a:t>📚</a:t>
             </a:r>
           </a:p>
         </p:txBody>
@@ -3804,7 +3804,7 @@
         </p:nvSpPr>
         <p:spPr>
           <a:xfrm>
-            <a:off x="3950208" y="5230368"/>
+            <a:off x="3950208" y="5248656"/>
             <a:ext cx="2194560" cy="384048"/>
           </a:xfrm>
           <a:prstGeom prst="rect">
@@ -3825,7 +3825,7 @@
                   <a:srgbClr val="06B6D4"/>
                 </a:solidFill>
               </a:rPr>
-              <a:t>12 محاضرة</a:t>
+              <a:t>12 Lectures</a:t>
             </a:r>
           </a:p>
         </p:txBody>
@@ -3838,8 +3838,8 @@
         </p:nvSpPr>
         <p:spPr>
           <a:xfrm>
-            <a:off x="3950208" y="5596128"/>
-            <a:ext cx="2194560" cy="347472"/>
+            <a:off x="3950208" y="5641848"/>
+            <a:ext cx="2194560" cy="320040"/>
           </a:xfrm>
           <a:prstGeom prst="rect">
             <a:avLst/>
@@ -3859,7 +3859,7 @@
                   <a:srgbClr val="9CA3AF"/>
                 </a:solidFill>
               </a:rPr>
-              <a:t>المحتوى</a:t>
+              <a:t>Content</a:t>
             </a:r>
           </a:p>
         </p:txBody>
@@ -3872,7 +3872,7 @@
         </p:nvSpPr>
         <p:spPr>
           <a:xfrm>
-            <a:off x="6583680" y="4754880"/>
+            <a:off x="6583680" y="4773168"/>
             <a:ext cx="2468880" cy="1371600"/>
           </a:xfrm>
           <a:prstGeom prst="roundRect">
@@ -3917,7 +3917,7 @@
         </p:nvSpPr>
         <p:spPr>
           <a:xfrm>
-            <a:off x="6693408" y="4828032"/>
+            <a:off x="6693408" y="4846320"/>
             <a:ext cx="457200" cy="457200"/>
           </a:xfrm>
           <a:prstGeom prst="rect">
@@ -3951,7 +3951,7 @@
         </p:nvSpPr>
         <p:spPr>
           <a:xfrm>
-            <a:off x="6693408" y="5230368"/>
+            <a:off x="6693408" y="5248656"/>
             <a:ext cx="2194560" cy="384048"/>
           </a:xfrm>
           <a:prstGeom prst="rect">
@@ -3972,7 +3972,7 @@
                   <a:srgbClr val="06B6D4"/>
                 </a:solidFill>
               </a:rPr>
-              <a:t>مبتدئ → محترف</a:t>
+              <a:t>Beginner → Pro</a:t>
             </a:r>
           </a:p>
         </p:txBody>
@@ -3985,8 +3985,8 @@
         </p:nvSpPr>
         <p:spPr>
           <a:xfrm>
-            <a:off x="6693408" y="5596128"/>
-            <a:ext cx="2194560" cy="347472"/>
+            <a:off x="6693408" y="5641848"/>
+            <a:ext cx="2194560" cy="320040"/>
           </a:xfrm>
           <a:prstGeom prst="rect">
             <a:avLst/>
@@ -4006,7 +4006,7 @@
                   <a:srgbClr val="9CA3AF"/>
                 </a:solidFill>
               </a:rPr>
-              <a:t>المستوى</a:t>
+              <a:t>Level</a:t>
             </a:r>
           </a:p>
         </p:txBody>
@@ -4019,7 +4019,7 @@
         </p:nvSpPr>
         <p:spPr>
           <a:xfrm>
-            <a:off x="9326880" y="4754880"/>
+            <a:off x="9326880" y="4773168"/>
             <a:ext cx="2468880" cy="1371600"/>
           </a:xfrm>
           <a:prstGeom prst="roundRect">
@@ -4064,7 +4064,7 @@
         </p:nvSpPr>
         <p:spPr>
           <a:xfrm>
-            <a:off x="9436608" y="4828032"/>
+            <a:off x="9436608" y="4846320"/>
             <a:ext cx="457200" cy="457200"/>
           </a:xfrm>
           <a:prstGeom prst="rect">
@@ -4098,7 +4098,7 @@
         </p:nvSpPr>
         <p:spPr>
           <a:xfrm>
-            <a:off x="9436608" y="5230368"/>
+            <a:off x="9436608" y="5248656"/>
             <a:ext cx="2194560" cy="384048"/>
           </a:xfrm>
           <a:prstGeom prst="rect">
@@ -4119,7 +4119,7 @@
                   <a:srgbClr val="06B6D4"/>
                 </a:solidFill>
               </a:rPr>
-              <a:t>شهادة إتمام</a:t>
+              <a:t>Certificate</a:t>
             </a:r>
           </a:p>
         </p:txBody>
@@ -4132,8 +4132,8 @@
         </p:nvSpPr>
         <p:spPr>
           <a:xfrm>
-            <a:off x="9436608" y="5596128"/>
-            <a:ext cx="2194560" cy="347472"/>
+            <a:off x="9436608" y="5641848"/>
+            <a:ext cx="2194560" cy="320040"/>
           </a:xfrm>
           <a:prstGeom prst="rect">
             <a:avLst/>
@@ -4153,7 +4153,7 @@
                   <a:srgbClr val="9CA3AF"/>
                 </a:solidFill>
               </a:rPr>
-              <a:t>المخرجات</a:t>
+              <a:t>Outcome</a:t>
             </a:r>
           </a:p>
         </p:txBody>
@@ -4182,12 +4182,12 @@
           <a:p>
             <a:pPr algn="l"/>
             <a:r>
-              <a:rPr sz="1200" b="0" i="1">
+              <a:rPr sz="1100" b="0" i="1">
                 <a:solidFill>
                   <a:srgbClr val="9CA3AF"/>
                 </a:solidFill>
               </a:rPr>
-              <a:t>اكتسب مهارات QA الاحترافية في أسرع وقت — خطوتك الأولى نحو وظيفة اختبار البرمجيات</a:t>
+              <a:t>Master QA fundamentals, industry tools, and automation — your first step toward a professional testing career.</a:t>
             </a:r>
           </a:p>
         </p:txBody>
@@ -4499,7 +4499,7 @@
                   <a:srgbClr val="0A1F44"/>
                 </a:solidFill>
               </a:rPr>
-              <a:t>✦  التسجيل مفتوح الآن — Registration Open Now  ✦</a:t>
+              <a:t>✦  Registration Is Now Open  ✦</a:t>
             </a:r>
           </a:p>
         </p:txBody>
@@ -4528,12 +4528,12 @@
           <a:p>
             <a:pPr algn="ctr"/>
             <a:r>
-              <a:rPr sz="4800" b="1" i="0">
+              <a:rPr sz="4600" b="1" i="0">
                 <a:solidFill>
                   <a:srgbClr val="FFFFFF"/>
                 </a:solidFill>
               </a:rPr>
-              <a:t>ابدأ رحلتك في</a:t>
+              <a:t>Start Your Journey in</a:t>
             </a:r>
           </a:p>
         </p:txBody>
@@ -4562,12 +4562,12 @@
           <a:p>
             <a:pPr algn="ctr"/>
             <a:r>
-              <a:rPr sz="4800" b="1" i="0">
+              <a:rPr sz="4600" b="1" i="0">
                 <a:solidFill>
                   <a:srgbClr val="06B6D4"/>
                 </a:solidFill>
               </a:rPr>
-              <a:t>اختبار البرمجيات اليوم!</a:t>
+              <a:t>Software Testing Today!</a:t>
             </a:r>
           </a:p>
         </p:txBody>
@@ -4601,7 +4601,7 @@
                   <a:srgbClr val="9CA3AF"/>
                 </a:solidFill>
               </a:rPr>
-              <a:t>دبلومة اختبار البرمجيات للمبتدئين  —  8 أسابيع  •  12 محاضرة  •  مشروع تخرج</a:t>
+              <a:t>Software Testing Diploma for Beginners  —  8 Weeks  •  12 Lectures  •  Capstone Project</a:t>
             </a:r>
           </a:p>
         </p:txBody>
@@ -4614,7 +4614,7 @@
         </p:nvSpPr>
         <p:spPr>
           <a:xfrm>
-            <a:off x="-4264243441524" y="3886200"/>
+            <a:off x="1431036" y="3886200"/>
             <a:ext cx="2194560" cy="1280160"/>
           </a:xfrm>
           <a:prstGeom prst="roundRect">
@@ -4659,7 +4659,7 @@
         </p:nvSpPr>
         <p:spPr>
           <a:xfrm>
-            <a:off x="-4264243441524" y="3950208"/>
+            <a:off x="1431036" y="3950208"/>
             <a:ext cx="2194560" cy="621792"/>
           </a:xfrm>
           <a:prstGeom prst="rect">
@@ -4693,7 +4693,7 @@
         </p:nvSpPr>
         <p:spPr>
           <a:xfrm>
-            <a:off x="-4264243441524" y="4553712"/>
+            <a:off x="1431036" y="4553712"/>
             <a:ext cx="2194560" cy="384048"/>
           </a:xfrm>
           <a:prstGeom prst="rect">
@@ -4714,7 +4714,7 @@
                   <a:srgbClr val="FFFFFF"/>
                 </a:solidFill>
               </a:rPr>
-              <a:t>محاضرة</a:t>
+              <a:t>Lectures</a:t>
             </a:r>
           </a:p>
         </p:txBody>
@@ -4727,7 +4727,7 @@
         </p:nvSpPr>
         <p:spPr>
           <a:xfrm>
-            <a:off x="-4264240972644" y="3886200"/>
+            <a:off x="3899916" y="3886200"/>
             <a:ext cx="2194560" cy="1280160"/>
           </a:xfrm>
           <a:prstGeom prst="roundRect">
@@ -4772,7 +4772,7 @@
         </p:nvSpPr>
         <p:spPr>
           <a:xfrm>
-            <a:off x="-4264240972644" y="3950208"/>
+            <a:off x="3899916" y="3950208"/>
             <a:ext cx="2194560" cy="621792"/>
           </a:xfrm>
           <a:prstGeom prst="rect">
@@ -4806,7 +4806,7 @@
         </p:nvSpPr>
         <p:spPr>
           <a:xfrm>
-            <a:off x="-4264240972644" y="4553712"/>
+            <a:off x="3899916" y="4553712"/>
             <a:ext cx="2194560" cy="384048"/>
           </a:xfrm>
           <a:prstGeom prst="rect">
@@ -4827,7 +4827,7 @@
                   <a:srgbClr val="FFFFFF"/>
                 </a:solidFill>
               </a:rPr>
-              <a:t>أسابيع</a:t>
+              <a:t>Weeks</a:t>
             </a:r>
           </a:p>
         </p:txBody>
@@ -4840,7 +4840,7 @@
         </p:nvSpPr>
         <p:spPr>
           <a:xfrm>
-            <a:off x="-4264238503764" y="3886200"/>
+            <a:off x="6368796" y="3886200"/>
             <a:ext cx="2194560" cy="1280160"/>
           </a:xfrm>
           <a:prstGeom prst="roundRect">
@@ -4885,7 +4885,7 @@
         </p:nvSpPr>
         <p:spPr>
           <a:xfrm>
-            <a:off x="-4264238503764" y="3950208"/>
+            <a:off x="6368796" y="3950208"/>
             <a:ext cx="2194560" cy="621792"/>
           </a:xfrm>
           <a:prstGeom prst="rect">
@@ -4919,7 +4919,7 @@
         </p:nvSpPr>
         <p:spPr>
           <a:xfrm>
-            <a:off x="-4264238503764" y="4553712"/>
+            <a:off x="6368796" y="4553712"/>
             <a:ext cx="2194560" cy="384048"/>
           </a:xfrm>
           <a:prstGeom prst="rect">
@@ -4940,7 +4940,7 @@
                   <a:srgbClr val="FFFFFF"/>
                 </a:solidFill>
               </a:rPr>
-              <a:t>أدوات احترافية</a:t>
+              <a:t>Pro Tools</a:t>
             </a:r>
           </a:p>
         </p:txBody>
@@ -4953,7 +4953,7 @@
         </p:nvSpPr>
         <p:spPr>
           <a:xfrm>
-            <a:off x="-4264236034884" y="3886200"/>
+            <a:off x="8837676" y="3886200"/>
             <a:ext cx="2194560" cy="1280160"/>
           </a:xfrm>
           <a:prstGeom prst="roundRect">
@@ -4998,7 +4998,7 @@
         </p:nvSpPr>
         <p:spPr>
           <a:xfrm>
-            <a:off x="-4264236034884" y="3950208"/>
+            <a:off x="8837676" y="3950208"/>
             <a:ext cx="2194560" cy="621792"/>
           </a:xfrm>
           <a:prstGeom prst="rect">
@@ -5032,7 +5032,7 @@
         </p:nvSpPr>
         <p:spPr>
           <a:xfrm>
-            <a:off x="-4264236034884" y="4553712"/>
+            <a:off x="8837676" y="4553712"/>
             <a:ext cx="2194560" cy="384048"/>
           </a:xfrm>
           <a:prstGeom prst="rect">
@@ -5053,7 +5053,7 @@
                   <a:srgbClr val="FFFFFF"/>
                 </a:solidFill>
               </a:rPr>
-              <a:t>شهادة إتمام</a:t>
+              <a:t>Certificate</a:t>
             </a:r>
           </a:p>
         </p:txBody>
@@ -5127,12 +5127,12 @@
           <a:p>
             <a:pPr algn="ctr"/>
             <a:r>
-              <a:rPr sz="1800" b="1" i="0">
+              <a:rPr sz="2000" b="1" i="0">
                 <a:solidFill>
                   <a:srgbClr val="0A1F44"/>
                 </a:solidFill>
               </a:rPr>
-              <a:t>سجّل الآن  →  Enroll Now</a:t>
+              <a:t>Enroll Now  →</a:t>
             </a:r>
           </a:p>
         </p:txBody>
@@ -5166,7 +5166,7 @@
                   <a:srgbClr val="9CA3AF"/>
                 </a:solidFill>
               </a:rPr>
-              <a:t>للتواصل والاستفسار: info@example.com  |  www.example.com  |  @QADiploma</a:t>
+              <a:t>Contact us:  info@example.com  |  www.example.com  |  @QADiploma</a:t>
             </a:r>
           </a:p>
         </p:txBody>
@@ -5370,7 +5370,7 @@
         <p:spPr>
           <a:xfrm>
             <a:off x="365760" y="320040"/>
-            <a:ext cx="3657600" cy="457200"/>
+            <a:ext cx="3657600" cy="411480"/>
           </a:xfrm>
           <a:prstGeom prst="rect">
             <a:avLst/>
@@ -5385,12 +5385,12 @@
           <a:p>
             <a:pPr algn="l"/>
             <a:r>
-              <a:rPr sz="1300" b="1" i="0">
+              <a:rPr sz="1200" b="1" i="0">
                 <a:solidFill>
                   <a:srgbClr val="06B6D4"/>
                 </a:solidFill>
               </a:rPr>
-              <a:t>عن البرنامج</a:t>
+              <a:t>ABOUT THE PROGRAM</a:t>
             </a:r>
           </a:p>
         </p:txBody>
@@ -5403,8 +5403,8 @@
         </p:nvSpPr>
         <p:spPr>
           <a:xfrm>
-            <a:off x="365760" y="777240"/>
-            <a:ext cx="3657600" cy="640080"/>
+            <a:off x="365760" y="749808"/>
+            <a:ext cx="3657600" cy="914400"/>
           </a:xfrm>
           <a:prstGeom prst="rect">
             <a:avLst/>
@@ -5419,12 +5419,13 @@
           <a:p>
             <a:pPr algn="l"/>
             <a:r>
-              <a:rPr sz="3000" b="1" i="0">
+              <a:rPr sz="2800" b="1" i="0">
                 <a:solidFill>
                   <a:srgbClr val="FFFFFF"/>
                 </a:solidFill>
               </a:rPr>
-              <a:t>ما الذي ستتعلمه؟</a:t>
+              <a:t>What Will
+You Learn?</a:t>
             </a:r>
           </a:p>
         </p:txBody>
@@ -5437,8 +5438,8 @@
         </p:nvSpPr>
         <p:spPr>
           <a:xfrm>
-            <a:off x="320040" y="1508760"/>
-            <a:ext cx="3657600" cy="2011680"/>
+            <a:off x="320040" y="1783080"/>
+            <a:ext cx="3657600" cy="1737360"/>
           </a:xfrm>
           <a:prstGeom prst="rect">
             <a:avLst/>
@@ -5453,12 +5454,12 @@
           <a:p>
             <a:pPr algn="l"/>
             <a:r>
-              <a:rPr sz="1300" b="0" i="0">
+              <a:rPr sz="1200" b="0" i="0">
                 <a:solidFill>
                   <a:srgbClr val="F3F4F6"/>
                 </a:solidFill>
               </a:rPr>
-              <a:t>برنامج مكثف مدته شهران يأخذك من الصفر إلى مستوى مبتدئ-متقدم في اختبار البرمجيات. ستتعلم الأسس النظرية والتطبيقية لاختبار الجودة، وتتدرب على أدوات احترافية تستخدمها الشركات العالمية.</a:t>
+              <a:t>An intensive 2-month program taking you from zero to a beginner-advanced level in software testing. You will learn both theoretical foundations and practical QA skills, and gain hands-on experience with industry-standard tools used by top companies worldwide.</a:t>
             </a:r>
           </a:p>
         </p:txBody>
@@ -5537,7 +5538,7 @@
                   <a:srgbClr val="FFFFFF"/>
                 </a:solidFill>
               </a:rPr>
-              <a:t>🗓️  شهرين / 12 محاضرة</a:t>
+              <a:t>🗓️  2 Months  /  12 Lectures</a:t>
             </a:r>
           </a:p>
         </p:txBody>
@@ -5616,7 +5617,7 @@
                   <a:srgbClr val="FFFFFF"/>
                 </a:solidFill>
               </a:rPr>
-              <a:t>🖥️  أونلاين + ورش تطبيقية</a:t>
+              <a:t>🖥️  Online + Practical Workshops</a:t>
             </a:r>
           </a:p>
         </p:txBody>
@@ -5695,7 +5696,7 @@
                   <a:srgbClr val="FFFFFF"/>
                 </a:solidFill>
               </a:rPr>
-              <a:t>📜  شهادة + مشروع تخرج</a:t>
+              <a:t>📜  Certificate + Capstone Project</a:t>
             </a:r>
           </a:p>
         </p:txBody>
@@ -5708,7 +5709,7 @@
         </p:nvSpPr>
         <p:spPr>
           <a:xfrm>
-            <a:off x="4572000" y="320040"/>
+            <a:off x="4572000" y="292608"/>
             <a:ext cx="7132320" cy="548640"/>
           </a:xfrm>
           <a:prstGeom prst="rect">
@@ -5729,7 +5730,7 @@
                   <a:srgbClr val="0A1F44"/>
                 </a:solidFill>
               </a:rPr>
-              <a:t>لماذا هذا البرنامج؟</a:t>
+              <a:t>Why This Program?</a:t>
             </a:r>
           </a:p>
         </p:txBody>
@@ -5743,7 +5744,7 @@
         <p:spPr>
           <a:xfrm>
             <a:off x="914400" y="868680"/>
-            <a:ext cx="10360152" cy="38100"/>
+            <a:ext cx="10058400" cy="38100"/>
           </a:xfrm>
           <a:prstGeom prst="rect">
             <a:avLst/>
@@ -5779,20 +5780,22 @@
       </p:sp>
       <p:sp>
         <p:nvSpPr>
-          <p:cNvPr id="17" name="Rectangle 16"/>
+          <p:cNvPr id="17" name="Rounded Rectangle 16"/>
           <p:cNvSpPr/>
           <p:nvPr/>
         </p:nvSpPr>
         <p:spPr>
           <a:xfrm>
-            <a:off x="914400" y="886968"/>
-            <a:ext cx="10058400" cy="38100"/>
-          </a:xfrm>
-          <a:prstGeom prst="rect">
-            <a:avLst/>
-          </a:prstGeom>
-          <a:solidFill>
-            <a:srgbClr val="06B6D4"/>
+            <a:off x="4572000" y="1188720"/>
+            <a:ext cx="3474720" cy="2286000"/>
+          </a:xfrm>
+          <a:prstGeom prst="roundRect">
+            <a:avLst>
+              <a:gd name="adj" fmla="val 8000"/>
+            </a:avLst>
+          </a:prstGeom>
+          <a:solidFill>
+            <a:srgbClr val="FFFFFF"/>
           </a:solidFill>
           <a:ln>
             <a:noFill/>
@@ -5822,22 +5825,20 @@
       </p:sp>
       <p:sp>
         <p:nvSpPr>
-          <p:cNvPr id="18" name="Rounded Rectangle 17"/>
+          <p:cNvPr id="18" name="Rectangle 17"/>
           <p:cNvSpPr/>
           <p:nvPr/>
         </p:nvSpPr>
         <p:spPr>
           <a:xfrm>
             <a:off x="4572000" y="1188720"/>
-            <a:ext cx="3474720" cy="2286000"/>
-          </a:xfrm>
-          <a:prstGeom prst="roundRect">
-            <a:avLst>
-              <a:gd name="adj" fmla="val 8000"/>
-            </a:avLst>
-          </a:prstGeom>
-          <a:solidFill>
-            <a:srgbClr val="FFFFFF"/>
+            <a:ext cx="3474720" cy="109728"/>
+          </a:xfrm>
+          <a:prstGeom prst="rect">
+            <a:avLst/>
+          </a:prstGeom>
+          <a:solidFill>
+            <a:srgbClr val="06B6D4"/>
           </a:solidFill>
           <a:ln>
             <a:noFill/>
@@ -5867,20 +5868,124 @@
       </p:sp>
       <p:sp>
         <p:nvSpPr>
-          <p:cNvPr id="19" name="Rectangle 18"/>
+          <p:cNvPr id="19" name="TextBox 18"/>
+          <p:cNvSpPr txBox="1"/>
+          <p:nvPr/>
+        </p:nvSpPr>
+        <p:spPr>
+          <a:xfrm>
+            <a:off x="4736592" y="1353312"/>
+            <a:ext cx="502920" cy="502920"/>
+          </a:xfrm>
+          <a:prstGeom prst="rect">
+            <a:avLst/>
+          </a:prstGeom>
+          <a:noFill/>
+        </p:spPr>
+        <p:txBody>
+          <a:bodyPr wrap="square">
+            <a:spAutoFit/>
+          </a:bodyPr>
+          <a:lstStyle/>
+          <a:p>
+            <a:pPr algn="l"/>
+            <a:r>
+              <a:rPr sz="2600" b="0" i="0">
+                <a:solidFill>
+                  <a:srgbClr val="06B6D4"/>
+                </a:solidFill>
+              </a:rPr>
+              <a:t>🚀</a:t>
+            </a:r>
+          </a:p>
+        </p:txBody>
+      </p:sp>
+      <p:sp>
+        <p:nvSpPr>
+          <p:cNvPr id="20" name="TextBox 19"/>
+          <p:cNvSpPr txBox="1"/>
+          <p:nvPr/>
+        </p:nvSpPr>
+        <p:spPr>
+          <a:xfrm>
+            <a:off x="4736592" y="1847088"/>
+            <a:ext cx="3200400" cy="411480"/>
+          </a:xfrm>
+          <a:prstGeom prst="rect">
+            <a:avLst/>
+          </a:prstGeom>
+          <a:noFill/>
+        </p:spPr>
+        <p:txBody>
+          <a:bodyPr wrap="square">
+            <a:spAutoFit/>
+          </a:bodyPr>
+          <a:lstStyle/>
+          <a:p>
+            <a:pPr algn="l"/>
+            <a:r>
+              <a:rPr sz="1500" b="1" i="0">
+                <a:solidFill>
+                  <a:srgbClr val="0A1F44"/>
+                </a:solidFill>
+              </a:rPr>
+              <a:t>70% Hands-On Learning</a:t>
+            </a:r>
+          </a:p>
+        </p:txBody>
+      </p:sp>
+      <p:sp>
+        <p:nvSpPr>
+          <p:cNvPr id="21" name="TextBox 20"/>
+          <p:cNvSpPr txBox="1"/>
+          <p:nvPr/>
+        </p:nvSpPr>
+        <p:spPr>
+          <a:xfrm>
+            <a:off x="4736592" y="2267712"/>
+            <a:ext cx="3200400" cy="1005840"/>
+          </a:xfrm>
+          <a:prstGeom prst="rect">
+            <a:avLst/>
+          </a:prstGeom>
+          <a:noFill/>
+        </p:spPr>
+        <p:txBody>
+          <a:bodyPr wrap="square">
+            <a:spAutoFit/>
+          </a:bodyPr>
+          <a:lstStyle/>
+          <a:p>
+            <a:pPr algn="l"/>
+            <a:r>
+              <a:rPr sz="1150" b="0" i="0">
+                <a:solidFill>
+                  <a:srgbClr val="1F2937"/>
+                </a:solidFill>
+              </a:rPr>
+              <a:t>Every lecture includes practical exercises and real-tool training</a:t>
+            </a:r>
+          </a:p>
+        </p:txBody>
+      </p:sp>
+      <p:sp>
+        <p:nvSpPr>
+          <p:cNvPr id="22" name="Rounded Rectangle 21"/>
           <p:cNvSpPr/>
           <p:nvPr/>
         </p:nvSpPr>
         <p:spPr>
           <a:xfrm>
-            <a:off x="4572000" y="1188720"/>
-            <a:ext cx="3474720" cy="109728"/>
-          </a:xfrm>
-          <a:prstGeom prst="rect">
-            <a:avLst/>
-          </a:prstGeom>
-          <a:solidFill>
-            <a:srgbClr val="06B6D4"/>
+            <a:off x="8412480" y="1188720"/>
+            <a:ext cx="3474720" cy="2286000"/>
+          </a:xfrm>
+          <a:prstGeom prst="roundRect">
+            <a:avLst>
+              <a:gd name="adj" fmla="val 8000"/>
+            </a:avLst>
+          </a:prstGeom>
+          <a:solidFill>
+            <a:srgbClr val="FFFFFF"/>
           </a:solidFill>
           <a:ln>
             <a:noFill/>
@@ -5910,124 +6015,20 @@
       </p:sp>
       <p:sp>
         <p:nvSpPr>
-          <p:cNvPr id="20" name="TextBox 19"/>
-          <p:cNvSpPr txBox="1"/>
-          <p:nvPr/>
-        </p:nvSpPr>
-        <p:spPr>
-          <a:xfrm>
-            <a:off x="4736592" y="1353312"/>
-            <a:ext cx="502920" cy="502920"/>
-          </a:xfrm>
-          <a:prstGeom prst="rect">
-            <a:avLst/>
-          </a:prstGeom>
-          <a:noFill/>
-        </p:spPr>
-        <p:txBody>
-          <a:bodyPr wrap="square">
-            <a:spAutoFit/>
-          </a:bodyPr>
-          <a:lstStyle/>
-          <a:p>
-            <a:pPr algn="l"/>
-            <a:r>
-              <a:rPr sz="2600" b="0" i="0">
-                <a:solidFill>
-                  <a:srgbClr val="06B6D4"/>
-                </a:solidFill>
-              </a:rPr>
-              <a:t>🚀</a:t>
-            </a:r>
-          </a:p>
-        </p:txBody>
-      </p:sp>
-      <p:sp>
-        <p:nvSpPr>
-          <p:cNvPr id="21" name="TextBox 20"/>
-          <p:cNvSpPr txBox="1"/>
-          <p:nvPr/>
-        </p:nvSpPr>
-        <p:spPr>
-          <a:xfrm>
-            <a:off x="4736592" y="1847088"/>
-            <a:ext cx="3200400" cy="411480"/>
-          </a:xfrm>
-          <a:prstGeom prst="rect">
-            <a:avLst/>
-          </a:prstGeom>
-          <a:noFill/>
-        </p:spPr>
-        <p:txBody>
-          <a:bodyPr wrap="square">
-            <a:spAutoFit/>
-          </a:bodyPr>
-          <a:lstStyle/>
-          <a:p>
-            <a:pPr algn="l"/>
-            <a:r>
-              <a:rPr sz="1500" b="1" i="0">
-                <a:solidFill>
-                  <a:srgbClr val="0A1F44"/>
-                </a:solidFill>
-              </a:rPr>
-              <a:t>تعلم عملي 70%</a:t>
-            </a:r>
-          </a:p>
-        </p:txBody>
-      </p:sp>
-      <p:sp>
-        <p:nvSpPr>
-          <p:cNvPr id="22" name="TextBox 21"/>
-          <p:cNvSpPr txBox="1"/>
-          <p:nvPr/>
-        </p:nvSpPr>
-        <p:spPr>
-          <a:xfrm>
-            <a:off x="4736592" y="2267712"/>
-            <a:ext cx="3200400" cy="1005840"/>
-          </a:xfrm>
-          <a:prstGeom prst="rect">
-            <a:avLst/>
-          </a:prstGeom>
-          <a:noFill/>
-        </p:spPr>
-        <p:txBody>
-          <a:bodyPr wrap="square">
-            <a:spAutoFit/>
-          </a:bodyPr>
-          <a:lstStyle/>
-          <a:p>
-            <a:pPr algn="l"/>
-            <a:r>
-              <a:rPr sz="1150" b="0" i="0">
-                <a:solidFill>
-                  <a:srgbClr val="1F2937"/>
-                </a:solidFill>
-              </a:rPr>
-              <a:t>كل محاضرة تحتوي على تمارين تطبيقية وتدريبات على أدوات حقيقية</a:t>
-            </a:r>
-          </a:p>
-        </p:txBody>
-      </p:sp>
-      <p:sp>
-        <p:nvSpPr>
-          <p:cNvPr id="23" name="Rounded Rectangle 22"/>
+          <p:cNvPr id="23" name="Rectangle 22"/>
           <p:cNvSpPr/>
           <p:nvPr/>
         </p:nvSpPr>
         <p:spPr>
           <a:xfrm>
             <a:off x="8412480" y="1188720"/>
-            <a:ext cx="3474720" cy="2286000"/>
-          </a:xfrm>
-          <a:prstGeom prst="roundRect">
-            <a:avLst>
-              <a:gd name="adj" fmla="val 8000"/>
-            </a:avLst>
-          </a:prstGeom>
-          <a:solidFill>
-            <a:srgbClr val="FFFFFF"/>
+            <a:ext cx="3474720" cy="109728"/>
+          </a:xfrm>
+          <a:prstGeom prst="rect">
+            <a:avLst/>
+          </a:prstGeom>
+          <a:solidFill>
+            <a:srgbClr val="1A56DB"/>
           </a:solidFill>
           <a:ln>
             <a:noFill/>
@@ -6057,20 +6058,124 @@
       </p:sp>
       <p:sp>
         <p:nvSpPr>
-          <p:cNvPr id="24" name="Rectangle 23"/>
+          <p:cNvPr id="24" name="TextBox 23"/>
+          <p:cNvSpPr txBox="1"/>
+          <p:nvPr/>
+        </p:nvSpPr>
+        <p:spPr>
+          <a:xfrm>
+            <a:off x="8577072" y="1353312"/>
+            <a:ext cx="502920" cy="502920"/>
+          </a:xfrm>
+          <a:prstGeom prst="rect">
+            <a:avLst/>
+          </a:prstGeom>
+          <a:noFill/>
+        </p:spPr>
+        <p:txBody>
+          <a:bodyPr wrap="square">
+            <a:spAutoFit/>
+          </a:bodyPr>
+          <a:lstStyle/>
+          <a:p>
+            <a:pPr algn="l"/>
+            <a:r>
+              <a:rPr sz="2600" b="0" i="0">
+                <a:solidFill>
+                  <a:srgbClr val="1A56DB"/>
+                </a:solidFill>
+              </a:rPr>
+              <a:t>🛠️</a:t>
+            </a:r>
+          </a:p>
+        </p:txBody>
+      </p:sp>
+      <p:sp>
+        <p:nvSpPr>
+          <p:cNvPr id="25" name="TextBox 24"/>
+          <p:cNvSpPr txBox="1"/>
+          <p:nvPr/>
+        </p:nvSpPr>
+        <p:spPr>
+          <a:xfrm>
+            <a:off x="8577072" y="1847088"/>
+            <a:ext cx="3200400" cy="411480"/>
+          </a:xfrm>
+          <a:prstGeom prst="rect">
+            <a:avLst/>
+          </a:prstGeom>
+          <a:noFill/>
+        </p:spPr>
+        <p:txBody>
+          <a:bodyPr wrap="square">
+            <a:spAutoFit/>
+          </a:bodyPr>
+          <a:lstStyle/>
+          <a:p>
+            <a:pPr algn="l"/>
+            <a:r>
+              <a:rPr sz="1500" b="1" i="0">
+                <a:solidFill>
+                  <a:srgbClr val="0A1F44"/>
+                </a:solidFill>
+              </a:rPr>
+              <a:t>Professional Tools</a:t>
+            </a:r>
+          </a:p>
+        </p:txBody>
+      </p:sp>
+      <p:sp>
+        <p:nvSpPr>
+          <p:cNvPr id="26" name="TextBox 25"/>
+          <p:cNvSpPr txBox="1"/>
+          <p:nvPr/>
+        </p:nvSpPr>
+        <p:spPr>
+          <a:xfrm>
+            <a:off x="8577072" y="2267712"/>
+            <a:ext cx="3200400" cy="1005840"/>
+          </a:xfrm>
+          <a:prstGeom prst="rect">
+            <a:avLst/>
+          </a:prstGeom>
+          <a:noFill/>
+        </p:spPr>
+        <p:txBody>
+          <a:bodyPr wrap="square">
+            <a:spAutoFit/>
+          </a:bodyPr>
+          <a:lstStyle/>
+          <a:p>
+            <a:pPr algn="l"/>
+            <a:r>
+              <a:rPr sz="1150" b="0" i="0">
+                <a:solidFill>
+                  <a:srgbClr val="1F2937"/>
+                </a:solidFill>
+              </a:rPr>
+              <a:t>Selenium  •  Postman  •  JMeter  •  Jira  •  GitHub Actions</a:t>
+            </a:r>
+          </a:p>
+        </p:txBody>
+      </p:sp>
+      <p:sp>
+        <p:nvSpPr>
+          <p:cNvPr id="27" name="Rounded Rectangle 26"/>
           <p:cNvSpPr/>
           <p:nvPr/>
         </p:nvSpPr>
         <p:spPr>
           <a:xfrm>
-            <a:off x="8412480" y="1188720"/>
-            <a:ext cx="3474720" cy="109728"/>
-          </a:xfrm>
-          <a:prstGeom prst="rect">
-            <a:avLst/>
-          </a:prstGeom>
-          <a:solidFill>
-            <a:srgbClr val="1A56DB"/>
+            <a:off x="4572000" y="3749039"/>
+            <a:ext cx="3474720" cy="2286000"/>
+          </a:xfrm>
+          <a:prstGeom prst="roundRect">
+            <a:avLst>
+              <a:gd name="adj" fmla="val 8000"/>
+            </a:avLst>
+          </a:prstGeom>
+          <a:solidFill>
+            <a:srgbClr val="FFFFFF"/>
           </a:solidFill>
           <a:ln>
             <a:noFill/>
@@ -6100,124 +6205,20 @@
       </p:sp>
       <p:sp>
         <p:nvSpPr>
-          <p:cNvPr id="25" name="TextBox 24"/>
-          <p:cNvSpPr txBox="1"/>
-          <p:nvPr/>
-        </p:nvSpPr>
-        <p:spPr>
-          <a:xfrm>
-            <a:off x="8577072" y="1353312"/>
-            <a:ext cx="502920" cy="502920"/>
-          </a:xfrm>
-          <a:prstGeom prst="rect">
-            <a:avLst/>
-          </a:prstGeom>
-          <a:noFill/>
-        </p:spPr>
-        <p:txBody>
-          <a:bodyPr wrap="square">
-            <a:spAutoFit/>
-          </a:bodyPr>
-          <a:lstStyle/>
-          <a:p>
-            <a:pPr algn="l"/>
-            <a:r>
-              <a:rPr sz="2600" b="0" i="0">
-                <a:solidFill>
-                  <a:srgbClr val="1A56DB"/>
-                </a:solidFill>
-              </a:rPr>
-              <a:t>🛠️</a:t>
-            </a:r>
-          </a:p>
-        </p:txBody>
-      </p:sp>
-      <p:sp>
-        <p:nvSpPr>
-          <p:cNvPr id="26" name="TextBox 25"/>
-          <p:cNvSpPr txBox="1"/>
-          <p:nvPr/>
-        </p:nvSpPr>
-        <p:spPr>
-          <a:xfrm>
-            <a:off x="8577072" y="1847088"/>
-            <a:ext cx="3200400" cy="411480"/>
-          </a:xfrm>
-          <a:prstGeom prst="rect">
-            <a:avLst/>
-          </a:prstGeom>
-          <a:noFill/>
-        </p:spPr>
-        <p:txBody>
-          <a:bodyPr wrap="square">
-            <a:spAutoFit/>
-          </a:bodyPr>
-          <a:lstStyle/>
-          <a:p>
-            <a:pPr algn="l"/>
-            <a:r>
-              <a:rPr sz="1500" b="1" i="0">
-                <a:solidFill>
-                  <a:srgbClr val="0A1F44"/>
-                </a:solidFill>
-              </a:rPr>
-              <a:t>أدوات احترافية</a:t>
-            </a:r>
-          </a:p>
-        </p:txBody>
-      </p:sp>
-      <p:sp>
-        <p:nvSpPr>
-          <p:cNvPr id="27" name="TextBox 26"/>
-          <p:cNvSpPr txBox="1"/>
-          <p:nvPr/>
-        </p:nvSpPr>
-        <p:spPr>
-          <a:xfrm>
-            <a:off x="8577072" y="2267712"/>
-            <a:ext cx="3200400" cy="1005840"/>
-          </a:xfrm>
-          <a:prstGeom prst="rect">
-            <a:avLst/>
-          </a:prstGeom>
-          <a:noFill/>
-        </p:spPr>
-        <p:txBody>
-          <a:bodyPr wrap="square">
-            <a:spAutoFit/>
-          </a:bodyPr>
-          <a:lstStyle/>
-          <a:p>
-            <a:pPr algn="l"/>
-            <a:r>
-              <a:rPr sz="1150" b="0" i="0">
-                <a:solidFill>
-                  <a:srgbClr val="1F2937"/>
-                </a:solidFill>
-              </a:rPr>
-              <a:t>Selenium • Postman • JMeter • Jira • GitHub Actions</a:t>
-            </a:r>
-          </a:p>
-        </p:txBody>
-      </p:sp>
-      <p:sp>
-        <p:nvSpPr>
-          <p:cNvPr id="28" name="Rounded Rectangle 27"/>
+          <p:cNvPr id="28" name="Rectangle 27"/>
           <p:cNvSpPr/>
           <p:nvPr/>
         </p:nvSpPr>
         <p:spPr>
           <a:xfrm>
             <a:off x="4572000" y="3749039"/>
-            <a:ext cx="3474720" cy="2286000"/>
-          </a:xfrm>
-          <a:prstGeom prst="roundRect">
-            <a:avLst>
-              <a:gd name="adj" fmla="val 8000"/>
-            </a:avLst>
-          </a:prstGeom>
-          <a:solidFill>
-            <a:srgbClr val="FFFFFF"/>
+            <a:ext cx="3474720" cy="109728"/>
+          </a:xfrm>
+          <a:prstGeom prst="rect">
+            <a:avLst/>
+          </a:prstGeom>
+          <a:solidFill>
+            <a:srgbClr val="F59E0B"/>
           </a:solidFill>
           <a:ln>
             <a:noFill/>
@@ -6247,20 +6248,124 @@
       </p:sp>
       <p:sp>
         <p:nvSpPr>
-          <p:cNvPr id="29" name="Rectangle 28"/>
+          <p:cNvPr id="29" name="TextBox 28"/>
+          <p:cNvSpPr txBox="1"/>
+          <p:nvPr/>
+        </p:nvSpPr>
+        <p:spPr>
+          <a:xfrm>
+            <a:off x="4736592" y="3913631"/>
+            <a:ext cx="502920" cy="502920"/>
+          </a:xfrm>
+          <a:prstGeom prst="rect">
+            <a:avLst/>
+          </a:prstGeom>
+          <a:noFill/>
+        </p:spPr>
+        <p:txBody>
+          <a:bodyPr wrap="square">
+            <a:spAutoFit/>
+          </a:bodyPr>
+          <a:lstStyle/>
+          <a:p>
+            <a:pPr algn="l"/>
+            <a:r>
+              <a:rPr sz="2600" b="0" i="0">
+                <a:solidFill>
+                  <a:srgbClr val="F59E0B"/>
+                </a:solidFill>
+              </a:rPr>
+              <a:t>🎓</a:t>
+            </a:r>
+          </a:p>
+        </p:txBody>
+      </p:sp>
+      <p:sp>
+        <p:nvSpPr>
+          <p:cNvPr id="30" name="TextBox 29"/>
+          <p:cNvSpPr txBox="1"/>
+          <p:nvPr/>
+        </p:nvSpPr>
+        <p:spPr>
+          <a:xfrm>
+            <a:off x="4736592" y="4407407"/>
+            <a:ext cx="3200400" cy="411480"/>
+          </a:xfrm>
+          <a:prstGeom prst="rect">
+            <a:avLst/>
+          </a:prstGeom>
+          <a:noFill/>
+        </p:spPr>
+        <p:txBody>
+          <a:bodyPr wrap="square">
+            <a:spAutoFit/>
+          </a:bodyPr>
+          <a:lstStyle/>
+          <a:p>
+            <a:pPr algn="l"/>
+            <a:r>
+              <a:rPr sz="1500" b="1" i="0">
+                <a:solidFill>
+                  <a:srgbClr val="0A1F44"/>
+                </a:solidFill>
+              </a:rPr>
+              <a:t>Structured Curriculum</a:t>
+            </a:r>
+          </a:p>
+        </p:txBody>
+      </p:sp>
+      <p:sp>
+        <p:nvSpPr>
+          <p:cNvPr id="31" name="TextBox 30"/>
+          <p:cNvSpPr txBox="1"/>
+          <p:nvPr/>
+        </p:nvSpPr>
+        <p:spPr>
+          <a:xfrm>
+            <a:off x="4736592" y="4828031"/>
+            <a:ext cx="3200400" cy="1005840"/>
+          </a:xfrm>
+          <a:prstGeom prst="rect">
+            <a:avLst/>
+          </a:prstGeom>
+          <a:noFill/>
+        </p:spPr>
+        <p:txBody>
+          <a:bodyPr wrap="square">
+            <a:spAutoFit/>
+          </a:bodyPr>
+          <a:lstStyle/>
+          <a:p>
+            <a:pPr algn="l"/>
+            <a:r>
+              <a:rPr sz="1150" b="0" i="0">
+                <a:solidFill>
+                  <a:srgbClr val="1F2937"/>
+                </a:solidFill>
+              </a:rPr>
+              <a:t>Content is organized progressively from fundamentals to advanced applications</a:t>
+            </a:r>
+          </a:p>
+        </p:txBody>
+      </p:sp>
+      <p:sp>
+        <p:nvSpPr>
+          <p:cNvPr id="32" name="Rounded Rectangle 31"/>
           <p:cNvSpPr/>
           <p:nvPr/>
         </p:nvSpPr>
         <p:spPr>
           <a:xfrm>
-            <a:off x="4572000" y="3749039"/>
-            <a:ext cx="3474720" cy="109728"/>
-          </a:xfrm>
-          <a:prstGeom prst="rect">
-            <a:avLst/>
-          </a:prstGeom>
-          <a:solidFill>
-            <a:srgbClr val="F59E0B"/>
+            <a:off x="8412480" y="3749039"/>
+            <a:ext cx="3474720" cy="2286000"/>
+          </a:xfrm>
+          <a:prstGeom prst="roundRect">
+            <a:avLst>
+              <a:gd name="adj" fmla="val 8000"/>
+            </a:avLst>
+          </a:prstGeom>
+          <a:solidFill>
+            <a:srgbClr val="FFFFFF"/>
           </a:solidFill>
           <a:ln>
             <a:noFill/>
@@ -6290,124 +6395,20 @@
       </p:sp>
       <p:sp>
         <p:nvSpPr>
-          <p:cNvPr id="30" name="TextBox 29"/>
-          <p:cNvSpPr txBox="1"/>
-          <p:nvPr/>
-        </p:nvSpPr>
-        <p:spPr>
-          <a:xfrm>
-            <a:off x="4736592" y="3913631"/>
-            <a:ext cx="502920" cy="502920"/>
-          </a:xfrm>
-          <a:prstGeom prst="rect">
-            <a:avLst/>
-          </a:prstGeom>
-          <a:noFill/>
-        </p:spPr>
-        <p:txBody>
-          <a:bodyPr wrap="square">
-            <a:spAutoFit/>
-          </a:bodyPr>
-          <a:lstStyle/>
-          <a:p>
-            <a:pPr algn="l"/>
-            <a:r>
-              <a:rPr sz="2600" b="0" i="0">
-                <a:solidFill>
-                  <a:srgbClr val="F59E0B"/>
-                </a:solidFill>
-              </a:rPr>
-              <a:t>🎓</a:t>
-            </a:r>
-          </a:p>
-        </p:txBody>
-      </p:sp>
-      <p:sp>
-        <p:nvSpPr>
-          <p:cNvPr id="31" name="TextBox 30"/>
-          <p:cNvSpPr txBox="1"/>
-          <p:nvPr/>
-        </p:nvSpPr>
-        <p:spPr>
-          <a:xfrm>
-            <a:off x="4736592" y="4407407"/>
-            <a:ext cx="3200400" cy="411480"/>
-          </a:xfrm>
-          <a:prstGeom prst="rect">
-            <a:avLst/>
-          </a:prstGeom>
-          <a:noFill/>
-        </p:spPr>
-        <p:txBody>
-          <a:bodyPr wrap="square">
-            <a:spAutoFit/>
-          </a:bodyPr>
-          <a:lstStyle/>
-          <a:p>
-            <a:pPr algn="l"/>
-            <a:r>
-              <a:rPr sz="1500" b="1" i="0">
-                <a:solidFill>
-                  <a:srgbClr val="0A1F44"/>
-                </a:solidFill>
-              </a:rPr>
-              <a:t>منهج منظم</a:t>
-            </a:r>
-          </a:p>
-        </p:txBody>
-      </p:sp>
-      <p:sp>
-        <p:nvSpPr>
-          <p:cNvPr id="32" name="TextBox 31"/>
-          <p:cNvSpPr txBox="1"/>
-          <p:nvPr/>
-        </p:nvSpPr>
-        <p:spPr>
-          <a:xfrm>
-            <a:off x="4736592" y="4828031"/>
-            <a:ext cx="3200400" cy="1005840"/>
-          </a:xfrm>
-          <a:prstGeom prst="rect">
-            <a:avLst/>
-          </a:prstGeom>
-          <a:noFill/>
-        </p:spPr>
-        <p:txBody>
-          <a:bodyPr wrap="square">
-            <a:spAutoFit/>
-          </a:bodyPr>
-          <a:lstStyle/>
-          <a:p>
-            <a:pPr algn="l"/>
-            <a:r>
-              <a:rPr sz="1150" b="0" i="0">
-                <a:solidFill>
-                  <a:srgbClr val="1F2937"/>
-                </a:solidFill>
-              </a:rPr>
-              <a:t>محتوى مرتب تصاعدياً من المفاهيم الأساسية إلى التطبيقات المتقدمة</a:t>
-            </a:r>
-          </a:p>
-        </p:txBody>
-      </p:sp>
-      <p:sp>
-        <p:nvSpPr>
-          <p:cNvPr id="33" name="Rounded Rectangle 32"/>
+          <p:cNvPr id="33" name="Rectangle 32"/>
           <p:cNvSpPr/>
           <p:nvPr/>
         </p:nvSpPr>
         <p:spPr>
           <a:xfrm>
             <a:off x="8412480" y="3749039"/>
-            <a:ext cx="3474720" cy="2286000"/>
-          </a:xfrm>
-          <a:prstGeom prst="roundRect">
-            <a:avLst>
-              <a:gd name="adj" fmla="val 8000"/>
-            </a:avLst>
-          </a:prstGeom>
-          <a:solidFill>
-            <a:srgbClr val="FFFFFF"/>
+            <a:ext cx="3474720" cy="109728"/>
+          </a:xfrm>
+          <a:prstGeom prst="rect">
+            <a:avLst/>
+          </a:prstGeom>
+          <a:solidFill>
+            <a:srgbClr val="059669"/>
           </a:solidFill>
           <a:ln>
             <a:noFill/>
@@ -6437,50 +6438,7 @@
       </p:sp>
       <p:sp>
         <p:nvSpPr>
-          <p:cNvPr id="34" name="Rectangle 33"/>
-          <p:cNvSpPr/>
-          <p:nvPr/>
-        </p:nvSpPr>
-        <p:spPr>
-          <a:xfrm>
-            <a:off x="8412480" y="3749039"/>
-            <a:ext cx="3474720" cy="109728"/>
-          </a:xfrm>
-          <a:prstGeom prst="rect">
-            <a:avLst/>
-          </a:prstGeom>
-          <a:solidFill>
-            <a:srgbClr val="059669"/>
-          </a:solidFill>
-          <a:ln>
-            <a:noFill/>
-          </a:ln>
-        </p:spPr>
-        <p:style>
-          <a:lnRef idx="1">
-            <a:schemeClr val="accent1"/>
-          </a:lnRef>
-          <a:fillRef idx="3">
-            <a:schemeClr val="accent1"/>
-          </a:fillRef>
-          <a:effectRef idx="2">
-            <a:schemeClr val="accent1"/>
-          </a:effectRef>
-          <a:fontRef idx="minor">
-            <a:schemeClr val="lt1"/>
-          </a:fontRef>
-        </p:style>
-        <p:txBody>
-          <a:bodyPr rtlCol="0" anchor="ctr"/>
-          <a:lstStyle/>
-          <a:p>
-            <a:pPr algn="ctr"/>
-          </a:p>
-        </p:txBody>
-      </p:sp>
-      <p:sp>
-        <p:nvSpPr>
-          <p:cNvPr id="35" name="TextBox 34"/>
+          <p:cNvPr id="34" name="TextBox 33"/>
           <p:cNvSpPr txBox="1"/>
           <p:nvPr/>
         </p:nvSpPr>
@@ -6514,7 +6472,7 @@
       </p:sp>
       <p:sp>
         <p:nvSpPr>
-          <p:cNvPr id="36" name="TextBox 35"/>
+          <p:cNvPr id="35" name="TextBox 34"/>
           <p:cNvSpPr txBox="1"/>
           <p:nvPr/>
         </p:nvSpPr>
@@ -6541,14 +6499,14 @@
                   <a:srgbClr val="0A1F44"/>
                 </a:solidFill>
               </a:rPr>
-              <a:t>دعم مسار وظيفي</a:t>
-            </a:r>
-          </a:p>
-        </p:txBody>
-      </p:sp>
-      <p:sp>
-        <p:nvSpPr>
-          <p:cNvPr id="37" name="TextBox 36"/>
+              <a:t>Career Path Support</a:t>
+            </a:r>
+          </a:p>
+        </p:txBody>
+      </p:sp>
+      <p:sp>
+        <p:nvSpPr>
+          <p:cNvPr id="36" name="TextBox 35"/>
           <p:cNvSpPr txBox="1"/>
           <p:nvPr/>
         </p:nvSpPr>
@@ -6575,7 +6533,7 @@
                   <a:srgbClr val="1F2937"/>
                 </a:solidFill>
               </a:rPr>
-              <a:t>إرشاد لبناء CV وإعداد لمقابلات العمل في مجال QA</a:t>
+              <a:t>CV building guidance and interview preparation for QA roles</a:t>
             </a:r>
           </a:p>
         </p:txBody>
@@ -6735,7 +6693,7 @@
         </p:nvSpPr>
         <p:spPr>
           <a:xfrm>
-            <a:off x="365760" y="274320"/>
+            <a:off x="365760" y="256032"/>
             <a:ext cx="11430000" cy="640080"/>
           </a:xfrm>
           <a:prstGeom prst="rect">
@@ -6751,12 +6709,12 @@
           <a:p>
             <a:pPr algn="l"/>
             <a:r>
-              <a:rPr sz="2600" b="1" i="0">
+              <a:rPr sz="2400" b="1" i="0">
                 <a:solidFill>
                   <a:srgbClr val="FFFFFF"/>
                 </a:solidFill>
               </a:rPr>
-              <a:t>🎯  أهداف البرنامج — ماذا ستتقن عند التخرج؟</a:t>
+              <a:t>🎯  Program Objectives — What You Will Master Upon Graduation</a:t>
             </a:r>
           </a:p>
         </p:txBody>
@@ -6957,7 +6915,7 @@
                   <a:srgbClr val="0A1F44"/>
                 </a:solidFill>
               </a:rPr>
-              <a:t>أسس اختبار البرمجيات</a:t>
+              <a:t>Testing Fundamentals</a:t>
             </a:r>
           </a:p>
         </p:txBody>
@@ -6991,7 +6949,7 @@
                   <a:srgbClr val="1F2937"/>
                 </a:solidFill>
               </a:rPr>
-              <a:t>فهم SDLC، STLC، أنواع الاختبارات، ومستوياتها بشكل كامل</a:t>
+              <a:t>Understand SDLC, STLC, testing types and levels in full</a:t>
             </a:r>
           </a:p>
         </p:txBody>
@@ -7192,7 +7150,7 @@
                   <a:srgbClr val="0A1F44"/>
                 </a:solidFill>
               </a:rPr>
-              <a:t>تصميم حالات الاختبار</a:t>
+              <a:t>Test Case Design</a:t>
             </a:r>
           </a:p>
         </p:txBody>
@@ -7226,7 +7184,7 @@
                   <a:srgbClr val="1F2937"/>
                 </a:solidFill>
               </a:rPr>
-              <a:t>كتابة Test Cases و Test Plans احترافية وفق معايير ISTQB</a:t>
+              <a:t>Write professional Test Cases and Test Plans per ISTQB standards</a:t>
             </a:r>
           </a:p>
         </p:txBody>
@@ -7427,7 +7385,7 @@
                   <a:srgbClr val="0A1F44"/>
                 </a:solidFill>
               </a:rPr>
-              <a:t>الاختبار اليدوي</a:t>
+              <a:t>Manual Testing</a:t>
             </a:r>
           </a:p>
         </p:txBody>
@@ -7461,7 +7419,7 @@
                   <a:srgbClr val="1F2937"/>
                 </a:solidFill>
               </a:rPr>
-              <a:t>تنفيذ Functional / Regression / Smoke Testing يدوياً</a:t>
+              <a:t>Execute Functional, Regression, and Smoke Testing manually</a:t>
             </a:r>
           </a:p>
         </p:txBody>
@@ -7662,7 +7620,7 @@
                   <a:srgbClr val="0A1F44"/>
                 </a:solidFill>
               </a:rPr>
-              <a:t>اختبار API</a:t>
+              <a:t>API Testing</a:t>
             </a:r>
           </a:p>
         </p:txBody>
@@ -7696,7 +7654,7 @@
                   <a:srgbClr val="1F2937"/>
                 </a:solidFill>
               </a:rPr>
-              <a:t>اختبار RESTful APIs باستخدام Postman وتوثيق النتائج</a:t>
+              <a:t>Test RESTful APIs using Postman and document results professionally</a:t>
             </a:r>
           </a:p>
         </p:txBody>
@@ -7897,7 +7855,7 @@
                   <a:srgbClr val="0A1F44"/>
                 </a:solidFill>
               </a:rPr>
-              <a:t>اختبار الأداء</a:t>
+              <a:t>Performance Testing</a:t>
             </a:r>
           </a:p>
         </p:txBody>
@@ -7931,7 +7889,7 @@
                   <a:srgbClr val="1F2937"/>
                 </a:solidFill>
               </a:rPr>
-              <a:t>تصميم وتشغيل سيناريوهات Load &amp; Stress Testing باستخدام JMeter</a:t>
+              <a:t>Design and run Load &amp; Stress Testing scenarios using JMeter</a:t>
             </a:r>
           </a:p>
         </p:txBody>
@@ -8132,7 +8090,7 @@
                   <a:srgbClr val="0A1F44"/>
                 </a:solidFill>
               </a:rPr>
-              <a:t>أتمتة الاختبار</a:t>
+              <a:t>Test Automation</a:t>
             </a:r>
           </a:p>
         </p:txBody>
@@ -8166,7 +8124,7 @@
                   <a:srgbClr val="1F2937"/>
                 </a:solidFill>
               </a:rPr>
-              <a:t>كتابة سكريبتات Selenium WebDriver الأساسية بلغة Python</a:t>
+              <a:t>Write basic Selenium WebDriver scripts using Python</a:t>
             </a:r>
           </a:p>
         </p:txBody>
@@ -8367,7 +8325,7 @@
                   <a:srgbClr val="0A1F44"/>
                 </a:solidFill>
               </a:rPr>
-              <a:t>إدارة العيوب</a:t>
+              <a:t>Defect Management</a:t>
             </a:r>
           </a:p>
         </p:txBody>
@@ -8401,7 +8359,7 @@
                   <a:srgbClr val="1F2937"/>
                 </a:solidFill>
               </a:rPr>
-              <a:t>رفع Bug Reports احترافية وتتبع الأخطاء عبر Jira</a:t>
+              <a:t>File professional Bug Reports and track issues using Jira</a:t>
             </a:r>
           </a:p>
         </p:txBody>
@@ -8602,7 +8560,7 @@
                   <a:srgbClr val="0A1F44"/>
                 </a:solidFill>
               </a:rPr>
-              <a:t>التكامل المستمر</a:t>
+              <a:t>CI/CD Integration</a:t>
             </a:r>
           </a:p>
         </p:txBody>
@@ -8636,7 +8594,7 @@
                   <a:srgbClr val="1F2937"/>
                 </a:solidFill>
               </a:rPr>
-              <a:t>فهم CI/CD وربط الاختبارات بـ GitHub Actions</a:t>
+              <a:t>Understand CI/CD pipelines and integrate tests with GitHub Actions</a:t>
             </a:r>
           </a:p>
         </p:txBody>
@@ -8670,7 +8628,7 @@
                   <a:srgbClr val="1A56DB"/>
                 </a:solidFill>
               </a:rPr>
-              <a:t>✅  خريج البرنامج مؤهل للتقديم على وظائف Junior QA Engineer وللحصول على شهادة ISTQB Foundation</a:t>
+              <a:t>✅  Graduates are qualified to apply for Junior QA Engineer roles and sit the ISTQB Foundation Level exam</a:t>
             </a:r>
           </a:p>
         </p:txBody>
@@ -8873,7 +8831,7 @@
         </p:nvSpPr>
         <p:spPr>
           <a:xfrm>
-            <a:off x="365760" y="228600"/>
+            <a:off x="365760" y="201168"/>
             <a:ext cx="10972800" cy="594360"/>
           </a:xfrm>
           <a:prstGeom prst="rect">
@@ -8894,7 +8852,7 @@
                   <a:srgbClr val="FFFFFF"/>
                 </a:solidFill>
               </a:rPr>
-              <a:t>خارطة المحاضرات</a:t>
+              <a:t>Curriculum Roadmap</a:t>
             </a:r>
           </a:p>
         </p:txBody>
@@ -8907,7 +8865,7 @@
         </p:nvSpPr>
         <p:spPr>
           <a:xfrm>
-            <a:off x="365760" y="804672"/>
+            <a:off x="365760" y="777240"/>
             <a:ext cx="10972800" cy="365760"/>
           </a:xfrm>
           <a:prstGeom prst="rect">
@@ -8928,7 +8886,7 @@
                   <a:srgbClr val="9CA3AF"/>
                 </a:solidFill>
               </a:rPr>
-              <a:t>Curriculum Roadmap — 12 Lectures Over 2 Months</a:t>
+              <a:t>12 Lectures Across 2 Months — Foundation Track → Professional Track</a:t>
             </a:r>
           </a:p>
         </p:txBody>
@@ -8941,7 +8899,7 @@
         </p:nvSpPr>
         <p:spPr>
           <a:xfrm>
-            <a:off x="502920" y="1325880"/>
+            <a:off x="502920" y="1298448"/>
             <a:ext cx="5303520" cy="502920"/>
           </a:xfrm>
           <a:prstGeom prst="roundRect">
@@ -8986,7 +8944,7 @@
         </p:nvSpPr>
         <p:spPr>
           <a:xfrm>
-            <a:off x="640080" y="1371600"/>
+            <a:off x="640080" y="1344168"/>
             <a:ext cx="5029200" cy="411480"/>
           </a:xfrm>
           <a:prstGeom prst="rect">
@@ -9007,7 +8965,7 @@
                   <a:srgbClr val="FFFFFF"/>
                 </a:solidFill>
               </a:rPr>
-              <a:t>📅  الشهر الأول — Foundation Track</a:t>
+              <a:t>📅  Month 1 — Foundation Track</a:t>
             </a:r>
           </a:p>
         </p:txBody>
@@ -9020,7 +8978,7 @@
         </p:nvSpPr>
         <p:spPr>
           <a:xfrm>
-            <a:off x="502920" y="1920240"/>
+            <a:off x="502920" y="1901952"/>
             <a:ext cx="5303520" cy="658368"/>
           </a:xfrm>
           <a:prstGeom prst="roundRect">
@@ -9065,7 +9023,7 @@
         </p:nvSpPr>
         <p:spPr>
           <a:xfrm>
-            <a:off x="502920" y="1920240"/>
+            <a:off x="502920" y="1901952"/>
             <a:ext cx="548640" cy="658368"/>
           </a:xfrm>
           <a:prstGeom prst="roundRect">
@@ -9110,7 +9068,7 @@
         </p:nvSpPr>
         <p:spPr>
           <a:xfrm>
-            <a:off x="548640" y="2011680"/>
+            <a:off x="548640" y="1993392"/>
             <a:ext cx="457200" cy="475488"/>
           </a:xfrm>
           <a:prstGeom prst="rect">
@@ -9144,8 +9102,8 @@
         </p:nvSpPr>
         <p:spPr>
           <a:xfrm>
-            <a:off x="1124712" y="1975104"/>
-            <a:ext cx="3474720" cy="347472"/>
+            <a:off x="1124712" y="1956816"/>
+            <a:ext cx="4389120" cy="347472"/>
           </a:xfrm>
           <a:prstGeom prst="rect">
             <a:avLst/>
@@ -9165,7 +9123,7 @@
                   <a:srgbClr val="FFFFFF"/>
                 </a:solidFill>
               </a:rPr>
-              <a:t>مقدمة في اختبار البرمجيات</a:t>
+              <a:t>Introduction to Software Testing</a:t>
             </a:r>
           </a:p>
         </p:txBody>
@@ -9178,8 +9136,8 @@
         </p:nvSpPr>
         <p:spPr>
           <a:xfrm>
-            <a:off x="1124712" y="2304288"/>
-            <a:ext cx="3474720" cy="256032"/>
+            <a:off x="1124712" y="2286000"/>
+            <a:ext cx="4389120" cy="256032"/>
           </a:xfrm>
           <a:prstGeom prst="rect">
             <a:avLst/>
@@ -9212,7 +9170,7 @@
         </p:nvSpPr>
         <p:spPr>
           <a:xfrm>
-            <a:off x="502920" y="2670048"/>
+            <a:off x="502920" y="2651760"/>
             <a:ext cx="5303520" cy="658368"/>
           </a:xfrm>
           <a:prstGeom prst="roundRect">
@@ -9257,7 +9215,7 @@
         </p:nvSpPr>
         <p:spPr>
           <a:xfrm>
-            <a:off x="502920" y="2670048"/>
+            <a:off x="502920" y="2651760"/>
             <a:ext cx="548640" cy="658368"/>
           </a:xfrm>
           <a:prstGeom prst="roundRect">
@@ -9302,7 +9260,7 @@
         </p:nvSpPr>
         <p:spPr>
           <a:xfrm>
-            <a:off x="548640" y="2761488"/>
+            <a:off x="548640" y="2743200"/>
             <a:ext cx="457200" cy="475488"/>
           </a:xfrm>
           <a:prstGeom prst="rect">
@@ -9336,8 +9294,8 @@
         </p:nvSpPr>
         <p:spPr>
           <a:xfrm>
-            <a:off x="1124712" y="2724912"/>
-            <a:ext cx="3474720" cy="347472"/>
+            <a:off x="1124712" y="2706624"/>
+            <a:ext cx="4389120" cy="347472"/>
           </a:xfrm>
           <a:prstGeom prst="rect">
             <a:avLst/>
@@ -9357,7 +9315,7 @@
                   <a:srgbClr val="FFFFFF"/>
                 </a:solidFill>
               </a:rPr>
-              <a:t>أنواع ومستويات الاختبار</a:t>
+              <a:t>Testing Types &amp; Levels</a:t>
             </a:r>
           </a:p>
         </p:txBody>
@@ -9370,8 +9328,8 @@
         </p:nvSpPr>
         <p:spPr>
           <a:xfrm>
-            <a:off x="1124712" y="3054096"/>
-            <a:ext cx="3474720" cy="256032"/>
+            <a:off x="1124712" y="3035808"/>
+            <a:ext cx="4389120" cy="256032"/>
           </a:xfrm>
           <a:prstGeom prst="rect">
             <a:avLst/>
@@ -9391,7 +9349,7 @@
                   <a:srgbClr val="9CA3AF"/>
                 </a:solidFill>
               </a:rPr>
-              <a:t>Testing Types &amp; Levels</a:t>
+              <a:t>Black Box / White Box / Levels</a:t>
             </a:r>
           </a:p>
         </p:txBody>
@@ -9404,7 +9362,7 @@
         </p:nvSpPr>
         <p:spPr>
           <a:xfrm>
-            <a:off x="502920" y="3419856"/>
+            <a:off x="502920" y="3401568"/>
             <a:ext cx="5303520" cy="658368"/>
           </a:xfrm>
           <a:prstGeom prst="roundRect">
@@ -9449,7 +9407,7 @@
         </p:nvSpPr>
         <p:spPr>
           <a:xfrm>
-            <a:off x="502920" y="3419856"/>
+            <a:off x="502920" y="3401568"/>
             <a:ext cx="548640" cy="658368"/>
           </a:xfrm>
           <a:prstGeom prst="roundRect">
@@ -9494,7 +9452,7 @@
         </p:nvSpPr>
         <p:spPr>
           <a:xfrm>
-            <a:off x="548640" y="3511296"/>
+            <a:off x="548640" y="3493008"/>
             <a:ext cx="457200" cy="475488"/>
           </a:xfrm>
           <a:prstGeom prst="rect">
@@ -9528,8 +9486,8 @@
         </p:nvSpPr>
         <p:spPr>
           <a:xfrm>
-            <a:off x="1124712" y="3474720"/>
-            <a:ext cx="3474720" cy="347472"/>
+            <a:off x="1124712" y="3456432"/>
+            <a:ext cx="4389120" cy="347472"/>
           </a:xfrm>
           <a:prstGeom prst="rect">
             <a:avLst/>
@@ -9549,7 +9507,7 @@
                   <a:srgbClr val="FFFFFF"/>
                 </a:solidFill>
               </a:rPr>
-              <a:t>تصميم حالات الاختبار</a:t>
+              <a:t>Test Case Design Techniques</a:t>
             </a:r>
           </a:p>
         </p:txBody>
@@ -9562,8 +9520,8 @@
         </p:nvSpPr>
         <p:spPr>
           <a:xfrm>
-            <a:off x="1124712" y="3803904"/>
-            <a:ext cx="3474720" cy="256032"/>
+            <a:off x="1124712" y="3785616"/>
+            <a:ext cx="4389120" cy="256032"/>
           </a:xfrm>
           <a:prstGeom prst="rect">
             <a:avLst/>
@@ -9583,7 +9541,7 @@
                   <a:srgbClr val="9CA3AF"/>
                 </a:solidFill>
               </a:rPr>
-              <a:t>Test Case Design</a:t>
+              <a:t>Equivalence, BVA, Decision Table</a:t>
             </a:r>
           </a:p>
         </p:txBody>
@@ -9596,7 +9554,7 @@
         </p:nvSpPr>
         <p:spPr>
           <a:xfrm>
-            <a:off x="502920" y="4169664"/>
+            <a:off x="502920" y="4151376"/>
             <a:ext cx="5303520" cy="658368"/>
           </a:xfrm>
           <a:prstGeom prst="roundRect">
@@ -9641,7 +9599,7 @@
         </p:nvSpPr>
         <p:spPr>
           <a:xfrm>
-            <a:off x="502920" y="4169664"/>
+            <a:off x="502920" y="4151376"/>
             <a:ext cx="548640" cy="658368"/>
           </a:xfrm>
           <a:prstGeom prst="roundRect">
@@ -9686,7 +9644,7 @@
         </p:nvSpPr>
         <p:spPr>
           <a:xfrm>
-            <a:off x="548640" y="4261104"/>
+            <a:off x="548640" y="4242816"/>
             <a:ext cx="457200" cy="475488"/>
           </a:xfrm>
           <a:prstGeom prst="rect">
@@ -9720,8 +9678,8 @@
         </p:nvSpPr>
         <p:spPr>
           <a:xfrm>
-            <a:off x="1124712" y="4224528"/>
-            <a:ext cx="3474720" cy="347472"/>
+            <a:off x="1124712" y="4206240"/>
+            <a:ext cx="4389120" cy="347472"/>
           </a:xfrm>
           <a:prstGeom prst="rect">
             <a:avLst/>
@@ -9741,7 +9699,7 @@
                   <a:srgbClr val="FFFFFF"/>
                 </a:solidFill>
               </a:rPr>
-              <a:t>الاختبار اليدوي الوظيفي</a:t>
+              <a:t>Manual Functional Testing</a:t>
             </a:r>
           </a:p>
         </p:txBody>
@@ -9754,8 +9712,8 @@
         </p:nvSpPr>
         <p:spPr>
           <a:xfrm>
-            <a:off x="1124712" y="4553712"/>
-            <a:ext cx="3474720" cy="256032"/>
+            <a:off x="1124712" y="4535424"/>
+            <a:ext cx="4389120" cy="256032"/>
           </a:xfrm>
           <a:prstGeom prst="rect">
             <a:avLst/>
@@ -9775,7 +9733,7 @@
                   <a:srgbClr val="9CA3AF"/>
                 </a:solidFill>
               </a:rPr>
-              <a:t>Manual Functional Testing</a:t>
+              <a:t>Test Plans, Smoke, Regression</a:t>
             </a:r>
           </a:p>
         </p:txBody>
@@ -9788,7 +9746,7 @@
         </p:nvSpPr>
         <p:spPr>
           <a:xfrm>
-            <a:off x="502920" y="4919472"/>
+            <a:off x="502920" y="4901184"/>
             <a:ext cx="5303520" cy="658368"/>
           </a:xfrm>
           <a:prstGeom prst="roundRect">
@@ -9833,7 +9791,7 @@
         </p:nvSpPr>
         <p:spPr>
           <a:xfrm>
-            <a:off x="502920" y="4919472"/>
+            <a:off x="502920" y="4901184"/>
             <a:ext cx="548640" cy="658368"/>
           </a:xfrm>
           <a:prstGeom prst="roundRect">
@@ -9878,7 +9836,7 @@
         </p:nvSpPr>
         <p:spPr>
           <a:xfrm>
-            <a:off x="548640" y="5010912"/>
+            <a:off x="548640" y="4992624"/>
             <a:ext cx="457200" cy="475488"/>
           </a:xfrm>
           <a:prstGeom prst="rect">
@@ -9912,8 +9870,8 @@
         </p:nvSpPr>
         <p:spPr>
           <a:xfrm>
-            <a:off x="1124712" y="4974336"/>
-            <a:ext cx="3474720" cy="347472"/>
+            <a:off x="1124712" y="4956048"/>
+            <a:ext cx="4389120" cy="347472"/>
           </a:xfrm>
           <a:prstGeom prst="rect">
             <a:avLst/>
@@ -9933,7 +9891,7 @@
                   <a:srgbClr val="FFFFFF"/>
                 </a:solidFill>
               </a:rPr>
-              <a:t>اختبار الـ API باستخدام Postman</a:t>
+              <a:t>API Testing with Postman</a:t>
             </a:r>
           </a:p>
         </p:txBody>
@@ -9946,8 +9904,8 @@
         </p:nvSpPr>
         <p:spPr>
           <a:xfrm>
-            <a:off x="1124712" y="5303520"/>
-            <a:ext cx="3474720" cy="256032"/>
+            <a:off x="1124712" y="5285232"/>
+            <a:ext cx="4389120" cy="256032"/>
           </a:xfrm>
           <a:prstGeom prst="rect">
             <a:avLst/>
@@ -9967,7 +9925,7 @@
                   <a:srgbClr val="9CA3AF"/>
                 </a:solidFill>
               </a:rPr>
-              <a:t>API Testing</a:t>
+              <a:t>REST, HTTP Methods, Assertions</a:t>
             </a:r>
           </a:p>
         </p:txBody>
@@ -9980,7 +9938,7 @@
         </p:nvSpPr>
         <p:spPr>
           <a:xfrm>
-            <a:off x="502920" y="5669280"/>
+            <a:off x="502920" y="5650992"/>
             <a:ext cx="5303520" cy="658368"/>
           </a:xfrm>
           <a:prstGeom prst="roundRect">
@@ -10025,7 +9983,7 @@
         </p:nvSpPr>
         <p:spPr>
           <a:xfrm>
-            <a:off x="502920" y="5669280"/>
+            <a:off x="502920" y="5650992"/>
             <a:ext cx="548640" cy="658368"/>
           </a:xfrm>
           <a:prstGeom prst="roundRect">
@@ -10070,7 +10028,7 @@
         </p:nvSpPr>
         <p:spPr>
           <a:xfrm>
-            <a:off x="548640" y="5760720"/>
+            <a:off x="548640" y="5742432"/>
             <a:ext cx="457200" cy="475488"/>
           </a:xfrm>
           <a:prstGeom prst="rect">
@@ -10104,8 +10062,8 @@
         </p:nvSpPr>
         <p:spPr>
           <a:xfrm>
-            <a:off x="1124712" y="5724144"/>
-            <a:ext cx="3474720" cy="347472"/>
+            <a:off x="1124712" y="5705856"/>
+            <a:ext cx="4389120" cy="347472"/>
           </a:xfrm>
           <a:prstGeom prst="rect">
             <a:avLst/>
@@ -10125,7 +10083,7 @@
                   <a:srgbClr val="FFFFFF"/>
                 </a:solidFill>
               </a:rPr>
-              <a:t>إدارة العيوب والتقارير</a:t>
+              <a:t>Defect Management &amp; Reporting</a:t>
             </a:r>
           </a:p>
         </p:txBody>
@@ -10138,8 +10096,8 @@
         </p:nvSpPr>
         <p:spPr>
           <a:xfrm>
-            <a:off x="1124712" y="6053328"/>
-            <a:ext cx="3474720" cy="256032"/>
+            <a:off x="1124712" y="6035040"/>
+            <a:ext cx="4389120" cy="256032"/>
           </a:xfrm>
           <a:prstGeom prst="rect">
             <a:avLst/>
@@ -10159,7 +10117,7 @@
                   <a:srgbClr val="9CA3AF"/>
                 </a:solidFill>
               </a:rPr>
-              <a:t>Bug Reporting &amp; Test Mgmt</a:t>
+              <a:t>Bug Life Cycle, Jira, Severity</a:t>
             </a:r>
           </a:p>
         </p:txBody>
@@ -10172,7 +10130,7 @@
         </p:nvSpPr>
         <p:spPr>
           <a:xfrm>
-            <a:off x="6492240" y="1325880"/>
+            <a:off x="6492240" y="1298448"/>
             <a:ext cx="5303520" cy="502920"/>
           </a:xfrm>
           <a:prstGeom prst="roundRect">
@@ -10217,7 +10175,7 @@
         </p:nvSpPr>
         <p:spPr>
           <a:xfrm>
-            <a:off x="6629400" y="1371600"/>
+            <a:off x="6629400" y="1344168"/>
             <a:ext cx="5029200" cy="411480"/>
           </a:xfrm>
           <a:prstGeom prst="rect">
@@ -10238,7 +10196,7 @@
                   <a:srgbClr val="0A1F44"/>
                 </a:solidFill>
               </a:rPr>
-              <a:t>📅  الشهر الثاني — Professional Track</a:t>
+              <a:t>📅  Month 2 — Professional Track</a:t>
             </a:r>
           </a:p>
         </p:txBody>
@@ -10251,7 +10209,7 @@
         </p:nvSpPr>
         <p:spPr>
           <a:xfrm>
-            <a:off x="6492240" y="1920240"/>
+            <a:off x="6492240" y="1901952"/>
             <a:ext cx="5303520" cy="658368"/>
           </a:xfrm>
           <a:prstGeom prst="roundRect">
@@ -10296,7 +10254,7 @@
         </p:nvSpPr>
         <p:spPr>
           <a:xfrm>
-            <a:off x="6492240" y="1920240"/>
+            <a:off x="6492240" y="1901952"/>
             <a:ext cx="548640" cy="658368"/>
           </a:xfrm>
           <a:prstGeom prst="roundRect">
@@ -10341,7 +10299,7 @@
         </p:nvSpPr>
         <p:spPr>
           <a:xfrm>
-            <a:off x="6537960" y="2011680"/>
+            <a:off x="6537960" y="1993392"/>
             <a:ext cx="457200" cy="475488"/>
           </a:xfrm>
           <a:prstGeom prst="rect">
@@ -10375,8 +10333,8 @@
         </p:nvSpPr>
         <p:spPr>
           <a:xfrm>
-            <a:off x="7114032" y="1975104"/>
-            <a:ext cx="3474720" cy="347472"/>
+            <a:off x="7114032" y="1956816"/>
+            <a:ext cx="4389120" cy="347472"/>
           </a:xfrm>
           <a:prstGeom prst="rect">
             <a:avLst/>
@@ -10396,7 +10354,7 @@
                   <a:srgbClr val="FFFFFF"/>
                 </a:solidFill>
               </a:rPr>
-              <a:t>مقدمة اختبار الأداء</a:t>
+              <a:t>Introduction to Performance Testing</a:t>
             </a:r>
           </a:p>
         </p:txBody>
@@ -10409,8 +10367,8 @@
         </p:nvSpPr>
         <p:spPr>
           <a:xfrm>
-            <a:off x="7114032" y="2304288"/>
-            <a:ext cx="3474720" cy="256032"/>
+            <a:off x="7114032" y="2286000"/>
+            <a:ext cx="4389120" cy="256032"/>
           </a:xfrm>
           <a:prstGeom prst="rect">
             <a:avLst/>
@@ -10430,7 +10388,7 @@
                   <a:srgbClr val="9CA3AF"/>
                 </a:solidFill>
               </a:rPr>
-              <a:t>Performance Testing Intro</a:t>
+              <a:t>Load, Stress, Spike Testing</a:t>
             </a:r>
           </a:p>
         </p:txBody>
@@ -10443,7 +10401,7 @@
         </p:nvSpPr>
         <p:spPr>
           <a:xfrm>
-            <a:off x="6492240" y="2670048"/>
+            <a:off x="6492240" y="2651760"/>
             <a:ext cx="5303520" cy="658368"/>
           </a:xfrm>
           <a:prstGeom prst="roundRect">
@@ -10488,7 +10446,7 @@
         </p:nvSpPr>
         <p:spPr>
           <a:xfrm>
-            <a:off x="6492240" y="2670048"/>
+            <a:off x="6492240" y="2651760"/>
             <a:ext cx="548640" cy="658368"/>
           </a:xfrm>
           <a:prstGeom prst="roundRect">
@@ -10533,7 +10491,7 @@
         </p:nvSpPr>
         <p:spPr>
           <a:xfrm>
-            <a:off x="6537960" y="2761488"/>
+            <a:off x="6537960" y="2743200"/>
             <a:ext cx="457200" cy="475488"/>
           </a:xfrm>
           <a:prstGeom prst="rect">
@@ -10567,8 +10525,8 @@
         </p:nvSpPr>
         <p:spPr>
           <a:xfrm>
-            <a:off x="7114032" y="2724912"/>
-            <a:ext cx="3474720" cy="347472"/>
+            <a:off x="7114032" y="2706624"/>
+            <a:ext cx="4389120" cy="347472"/>
           </a:xfrm>
           <a:prstGeom prst="rect">
             <a:avLst/>
@@ -10588,7 +10546,7 @@
                   <a:srgbClr val="FFFFFF"/>
                 </a:solidFill>
               </a:rPr>
-              <a:t>JMeter — بناء خطط الاختبار</a:t>
+              <a:t>JMeter — Building Test Plans</a:t>
             </a:r>
           </a:p>
         </p:txBody>
@@ -10601,8 +10559,8 @@
         </p:nvSpPr>
         <p:spPr>
           <a:xfrm>
-            <a:off x="7114032" y="3054096"/>
-            <a:ext cx="3474720" cy="256032"/>
+            <a:off x="7114032" y="3035808"/>
+            <a:ext cx="4389120" cy="256032"/>
           </a:xfrm>
           <a:prstGeom prst="rect">
             <a:avLst/>
@@ -10622,7 +10580,7 @@
                   <a:srgbClr val="9CA3AF"/>
                 </a:solidFill>
               </a:rPr>
-              <a:t>JMeter Test Plans</a:t>
+              <a:t>Thread Groups, Samplers, Reports</a:t>
             </a:r>
           </a:p>
         </p:txBody>
@@ -10635,7 +10593,7 @@
         </p:nvSpPr>
         <p:spPr>
           <a:xfrm>
-            <a:off x="6492240" y="3419856"/>
+            <a:off x="6492240" y="3401568"/>
             <a:ext cx="5303520" cy="658368"/>
           </a:xfrm>
           <a:prstGeom prst="roundRect">
@@ -10680,7 +10638,7 @@
         </p:nvSpPr>
         <p:spPr>
           <a:xfrm>
-            <a:off x="6492240" y="3419856"/>
+            <a:off x="6492240" y="3401568"/>
             <a:ext cx="548640" cy="658368"/>
           </a:xfrm>
           <a:prstGeom prst="roundRect">
@@ -10725,7 +10683,7 @@
         </p:nvSpPr>
         <p:spPr>
           <a:xfrm>
-            <a:off x="6537960" y="3511296"/>
+            <a:off x="6537960" y="3493008"/>
             <a:ext cx="457200" cy="475488"/>
           </a:xfrm>
           <a:prstGeom prst="rect">
@@ -10759,8 +10717,8 @@
         </p:nvSpPr>
         <p:spPr>
           <a:xfrm>
-            <a:off x="7114032" y="3474720"/>
-            <a:ext cx="3474720" cy="347472"/>
+            <a:off x="7114032" y="3456432"/>
+            <a:ext cx="4389120" cy="347472"/>
           </a:xfrm>
           <a:prstGeom prst="rect">
             <a:avLst/>
@@ -10780,7 +10738,7 @@
                   <a:srgbClr val="FFFFFF"/>
                 </a:solidFill>
               </a:rPr>
-              <a:t>مقدمة أتمتة الاختبار</a:t>
+              <a:t>Introduction to Test Automation</a:t>
             </a:r>
           </a:p>
         </p:txBody>
@@ -10793,8 +10751,8 @@
         </p:nvSpPr>
         <p:spPr>
           <a:xfrm>
-            <a:off x="7114032" y="3803904"/>
-            <a:ext cx="3474720" cy="256032"/>
+            <a:off x="7114032" y="3785616"/>
+            <a:ext cx="4389120" cy="256032"/>
           </a:xfrm>
           <a:prstGeom prst="rect">
             <a:avLst/>
@@ -10814,7 +10772,7 @@
                   <a:srgbClr val="9CA3AF"/>
                 </a:solidFill>
               </a:rPr>
-              <a:t>Test Automation Intro</a:t>
+              <a:t>POM, Frameworks, Strategy</a:t>
             </a:r>
           </a:p>
         </p:txBody>
@@ -10827,7 +10785,7 @@
         </p:nvSpPr>
         <p:spPr>
           <a:xfrm>
-            <a:off x="6492240" y="4169664"/>
+            <a:off x="6492240" y="4151376"/>
             <a:ext cx="5303520" cy="658368"/>
           </a:xfrm>
           <a:prstGeom prst="roundRect">
@@ -10872,7 +10830,7 @@
         </p:nvSpPr>
         <p:spPr>
           <a:xfrm>
-            <a:off x="6492240" y="4169664"/>
+            <a:off x="6492240" y="4151376"/>
             <a:ext cx="548640" cy="658368"/>
           </a:xfrm>
           <a:prstGeom prst="roundRect">
@@ -10917,7 +10875,7 @@
         </p:nvSpPr>
         <p:spPr>
           <a:xfrm>
-            <a:off x="6537960" y="4261104"/>
+            <a:off x="6537960" y="4242816"/>
             <a:ext cx="457200" cy="475488"/>
           </a:xfrm>
           <a:prstGeom prst="rect">
@@ -10951,8 +10909,8 @@
         </p:nvSpPr>
         <p:spPr>
           <a:xfrm>
-            <a:off x="7114032" y="4224528"/>
-            <a:ext cx="3474720" cy="347472"/>
+            <a:off x="7114032" y="4206240"/>
+            <a:ext cx="4389120" cy="347472"/>
           </a:xfrm>
           <a:prstGeom prst="rect">
             <a:avLst/>
@@ -10972,7 +10930,7 @@
                   <a:srgbClr val="FFFFFF"/>
                 </a:solidFill>
               </a:rPr>
-              <a:t>Selenium WebDriver مع Python</a:t>
+              <a:t>Selenium WebDriver with Python</a:t>
             </a:r>
           </a:p>
         </p:txBody>
@@ -10985,8 +10943,8 @@
         </p:nvSpPr>
         <p:spPr>
           <a:xfrm>
-            <a:off x="7114032" y="4553712"/>
-            <a:ext cx="3474720" cy="256032"/>
+            <a:off x="7114032" y="4535424"/>
+            <a:ext cx="4389120" cy="256032"/>
           </a:xfrm>
           <a:prstGeom prst="rect">
             <a:avLst/>
@@ -11006,7 +10964,7 @@
                   <a:srgbClr val="9CA3AF"/>
                 </a:solidFill>
               </a:rPr>
-              <a:t>Selenium Automation</a:t>
+              <a:t>Locators, Actions, Waits, Suites</a:t>
             </a:r>
           </a:p>
         </p:txBody>
@@ -11019,7 +10977,7 @@
         </p:nvSpPr>
         <p:spPr>
           <a:xfrm>
-            <a:off x="6492240" y="4919472"/>
+            <a:off x="6492240" y="4901184"/>
             <a:ext cx="5303520" cy="658368"/>
           </a:xfrm>
           <a:prstGeom prst="roundRect">
@@ -11064,7 +11022,7 @@
         </p:nvSpPr>
         <p:spPr>
           <a:xfrm>
-            <a:off x="6492240" y="4919472"/>
+            <a:off x="6492240" y="4901184"/>
             <a:ext cx="548640" cy="658368"/>
           </a:xfrm>
           <a:prstGeom prst="roundRect">
@@ -11109,7 +11067,7 @@
         </p:nvSpPr>
         <p:spPr>
           <a:xfrm>
-            <a:off x="6537960" y="5010912"/>
+            <a:off x="6537960" y="4992624"/>
             <a:ext cx="457200" cy="475488"/>
           </a:xfrm>
           <a:prstGeom prst="rect">
@@ -11143,8 +11101,8 @@
         </p:nvSpPr>
         <p:spPr>
           <a:xfrm>
-            <a:off x="7114032" y="4974336"/>
-            <a:ext cx="3474720" cy="347472"/>
+            <a:off x="7114032" y="4956048"/>
+            <a:ext cx="4389120" cy="347472"/>
           </a:xfrm>
           <a:prstGeom prst="rect">
             <a:avLst/>
@@ -11164,7 +11122,7 @@
                   <a:srgbClr val="FFFFFF"/>
                 </a:solidFill>
               </a:rPr>
-              <a:t>CI/CD والاختبار المستمر</a:t>
+              <a:t>CI/CD &amp; Continuous Testing</a:t>
             </a:r>
           </a:p>
         </p:txBody>
@@ -11177,8 +11135,8 @@
         </p:nvSpPr>
         <p:spPr>
           <a:xfrm>
-            <a:off x="7114032" y="5303520"/>
-            <a:ext cx="3474720" cy="256032"/>
+            <a:off x="7114032" y="5285232"/>
+            <a:ext cx="4389120" cy="256032"/>
           </a:xfrm>
           <a:prstGeom prst="rect">
             <a:avLst/>
@@ -11198,7 +11156,7 @@
                   <a:srgbClr val="9CA3AF"/>
                 </a:solidFill>
               </a:rPr>
-              <a:t>CI/CD &amp; DevOps Testing</a:t>
+              <a:t>GitHub Actions, Agile, Reporting</a:t>
             </a:r>
           </a:p>
         </p:txBody>
@@ -11211,7 +11169,7 @@
         </p:nvSpPr>
         <p:spPr>
           <a:xfrm>
-            <a:off x="6492240" y="5669280"/>
+            <a:off x="6492240" y="5650992"/>
             <a:ext cx="5303520" cy="658368"/>
           </a:xfrm>
           <a:prstGeom prst="roundRect">
@@ -11256,7 +11214,7 @@
         </p:nvSpPr>
         <p:spPr>
           <a:xfrm>
-            <a:off x="6492240" y="5669280"/>
+            <a:off x="6492240" y="5650992"/>
             <a:ext cx="548640" cy="658368"/>
           </a:xfrm>
           <a:prstGeom prst="roundRect">
@@ -11301,7 +11259,7 @@
         </p:nvSpPr>
         <p:spPr>
           <a:xfrm>
-            <a:off x="6537960" y="5760720"/>
+            <a:off x="6537960" y="5742432"/>
             <a:ext cx="457200" cy="475488"/>
           </a:xfrm>
           <a:prstGeom prst="rect">
@@ -11335,8 +11293,8 @@
         </p:nvSpPr>
         <p:spPr>
           <a:xfrm>
-            <a:off x="7114032" y="5724144"/>
-            <a:ext cx="3474720" cy="347472"/>
+            <a:off x="7114032" y="5705856"/>
+            <a:ext cx="4389120" cy="347472"/>
           </a:xfrm>
           <a:prstGeom prst="rect">
             <a:avLst/>
@@ -11356,7 +11314,7 @@
                   <a:srgbClr val="FFFFFF"/>
                 </a:solidFill>
               </a:rPr>
-              <a:t>مشروع التخرج والتوجيه الوظيفي</a:t>
+              <a:t>Capstone Project &amp; Career Preparation</a:t>
             </a:r>
           </a:p>
         </p:txBody>
@@ -11369,8 +11327,8 @@
         </p:nvSpPr>
         <p:spPr>
           <a:xfrm>
-            <a:off x="7114032" y="6053328"/>
-            <a:ext cx="3474720" cy="256032"/>
+            <a:off x="7114032" y="6035040"/>
+            <a:ext cx="4389120" cy="256032"/>
           </a:xfrm>
           <a:prstGeom prst="rect">
             <a:avLst/>
@@ -11390,7 +11348,7 @@
                   <a:srgbClr val="9CA3AF"/>
                 </a:solidFill>
               </a:rPr>
-              <a:t>Capstone &amp; Career Prep</a:t>
+              <a:t>Portfolio, CV, ISTQB, Interviews</a:t>
             </a:r>
           </a:p>
         </p:txBody>
@@ -11585,7 +11543,7 @@
         <p:spPr>
           <a:xfrm>
             <a:off x="365760" y="137160"/>
-            <a:ext cx="4572000" cy="594360"/>
+            <a:ext cx="9144000" cy="594360"/>
           </a:xfrm>
           <a:prstGeom prst="rect">
             <a:avLst/>
@@ -11600,12 +11558,12 @@
           <a:p>
             <a:pPr algn="l"/>
             <a:r>
-              <a:rPr sz="3200" b="1" i="0">
+              <a:rPr sz="3000" b="1" i="0">
                 <a:solidFill>
                   <a:srgbClr val="FFFFFF"/>
                 </a:solidFill>
               </a:rPr>
-              <a:t>الشهر الأول</a:t>
+              <a:t>Month 1 — Foundation Track</a:t>
             </a:r>
           </a:p>
         </p:txBody>
@@ -11639,7 +11597,7 @@
                   <a:srgbClr val="DBEAFF"/>
                 </a:solidFill>
               </a:rPr>
-              <a:t>Foundation Track — الأسس والمهارات الأساسية  (Lectures 1–6)</a:t>
+              <a:t>Core Skills &amp; Fundamentals  (Lectures 1 – 6)</a:t>
             </a:r>
           </a:p>
         </p:txBody>
@@ -11869,12 +11827,12 @@
           <a:p>
             <a:pPr algn="l"/>
             <a:r>
-              <a:rPr sz="1300" b="1" i="0">
+              <a:rPr sz="1250" b="1" i="0">
                 <a:solidFill>
                   <a:srgbClr val="0A1F44"/>
                 </a:solidFill>
               </a:rPr>
-              <a:t>مقدمة في اختبار البرمجيات</a:t>
+              <a:t>Introduction to Software Testing</a:t>
             </a:r>
           </a:p>
         </p:txBody>
@@ -11951,7 +11909,7 @@
                   <a:srgbClr val="1F2937"/>
                 </a:solidFill>
               </a:rPr>
-              <a:t>▸  ما هو اختبار البرمجيات؟</a:t>
+              <a:t>▸  What is Software Testing?</a:t>
             </a:r>
           </a:p>
         </p:txBody>
@@ -11985,7 +11943,7 @@
                   <a:srgbClr val="1F2937"/>
                 </a:solidFill>
               </a:rPr>
-              <a:t>▸  دورة حياة التطوير SDLC</a:t>
+              <a:t>▸  SDLC — Development Life Cycle</a:t>
             </a:r>
           </a:p>
         </p:txBody>
@@ -12019,7 +11977,7 @@
                   <a:srgbClr val="1F2937"/>
                 </a:solidFill>
               </a:rPr>
-              <a:t>▸  دورة حياة الاختبار STLC</a:t>
+              <a:t>▸  STLC — Testing Life Cycle</a:t>
             </a:r>
           </a:p>
         </p:txBody>
@@ -12053,7 +12011,7 @@
                   <a:srgbClr val="1F2937"/>
                 </a:solidFill>
               </a:rPr>
-              <a:t>▸  مبادئ الاختبار السبعة</a:t>
+              <a:t>▸  The 7 Principles of Testing</a:t>
             </a:r>
           </a:p>
         </p:txBody>
@@ -12132,7 +12090,7 @@
                   <a:srgbClr val="FFFFFF"/>
                 </a:solidFill>
               </a:rPr>
-              <a:t>📊 دورة حياة تطوير البرمجيات</a:t>
+              <a:t>📊 SDLC &amp; STLC Lifecycle Diagram</a:t>
             </a:r>
           </a:p>
         </p:txBody>
@@ -12362,12 +12320,12 @@
           <a:p>
             <a:pPr algn="l"/>
             <a:r>
-              <a:rPr sz="1300" b="1" i="0">
+              <a:rPr sz="1250" b="1" i="0">
                 <a:solidFill>
                   <a:srgbClr val="0A1F44"/>
                 </a:solidFill>
               </a:rPr>
-              <a:t>أنواع ومستويات الاختبار</a:t>
+              <a:t>Testing Types &amp; Levels</a:t>
             </a:r>
           </a:p>
         </p:txBody>
@@ -12512,7 +12470,7 @@
                   <a:srgbClr val="1F2937"/>
                 </a:solidFill>
               </a:rPr>
-              <a:t>▸  Black Box &amp; White Box</a:t>
+              <a:t>▸  Black Box &amp; White Box Testing</a:t>
             </a:r>
           </a:p>
         </p:txBody>
@@ -12546,7 +12504,7 @@
                   <a:srgbClr val="1F2937"/>
                 </a:solidFill>
               </a:rPr>
-              <a:t>▸  Static vs Dynamic</a:t>
+              <a:t>▸  Static vs Dynamic Testing</a:t>
             </a:r>
           </a:p>
         </p:txBody>
@@ -12625,7 +12583,7 @@
                   <a:srgbClr val="FFFFFF"/>
                 </a:solidFill>
               </a:rPr>
-              <a:t>📊 هرم مستويات الاختبار</a:t>
+              <a:t>📊 Testing Pyramid Visual</a:t>
             </a:r>
           </a:p>
         </p:txBody>
@@ -12855,12 +12813,12 @@
           <a:p>
             <a:pPr algn="l"/>
             <a:r>
-              <a:rPr sz="1300" b="1" i="0">
+              <a:rPr sz="1250" b="1" i="0">
                 <a:solidFill>
                   <a:srgbClr val="0A1F44"/>
                 </a:solidFill>
               </a:rPr>
-              <a:t>تصميم حالات الاختبار</a:t>
+              <a:t>Test Case Design Techniques</a:t>
             </a:r>
           </a:p>
         </p:txBody>
@@ -13118,7 +13076,7 @@
                   <a:srgbClr val="FFFFFF"/>
                 </a:solidFill>
               </a:rPr>
-              <a:t>📊 جدول تقسيم الحدود</a:t>
+              <a:t>📊 BVA Boundary Partition Chart</a:t>
             </a:r>
           </a:p>
         </p:txBody>
@@ -13348,12 +13306,12 @@
           <a:p>
             <a:pPr algn="l"/>
             <a:r>
-              <a:rPr sz="1300" b="1" i="0">
+              <a:rPr sz="1250" b="1" i="0">
                 <a:solidFill>
                   <a:srgbClr val="0A1F44"/>
                 </a:solidFill>
               </a:rPr>
-              <a:t>الاختبار اليدوي الوظيفي</a:t>
+              <a:t>Manual Functional Testing</a:t>
             </a:r>
           </a:p>
         </p:txBody>
@@ -13430,7 +13388,7 @@
                   <a:srgbClr val="1F2937"/>
                 </a:solidFill>
               </a:rPr>
-              <a:t>▸  كتابة Test Plan احترافي</a:t>
+              <a:t>▸  Writing a Professional Test Plan</a:t>
             </a:r>
           </a:p>
         </p:txBody>
@@ -13464,7 +13422,7 @@
                   <a:srgbClr val="1F2937"/>
                 </a:solidFill>
               </a:rPr>
-              <a:t>▸  Smoke / Sanity Testing</a:t>
+              <a:t>▸  Smoke &amp; Sanity Testing</a:t>
             </a:r>
           </a:p>
         </p:txBody>
@@ -13498,7 +13456,7 @@
                   <a:srgbClr val="1F2937"/>
                 </a:solidFill>
               </a:rPr>
-              <a:t>▸  Regression Testing</a:t>
+              <a:t>▸  Regression Testing Strategies</a:t>
             </a:r>
           </a:p>
         </p:txBody>
@@ -13532,7 +13490,7 @@
                   <a:srgbClr val="1F2937"/>
                 </a:solidFill>
               </a:rPr>
-              <a:t>▸  تنفيذ وتوثيق الاختبارات</a:t>
+              <a:t>▸  Execution &amp; Documentation</a:t>
             </a:r>
           </a:p>
         </p:txBody>
@@ -13611,7 +13569,7 @@
                   <a:srgbClr val="FFFFFF"/>
                 </a:solidFill>
               </a:rPr>
-              <a:t>📊 تدفق تنفيذ الاختبار</a:t>
+              <a:t>📊 Test Execution Flow Diagram</a:t>
             </a:r>
           </a:p>
         </p:txBody>
@@ -13841,12 +13799,12 @@
           <a:p>
             <a:pPr algn="l"/>
             <a:r>
-              <a:rPr sz="1300" b="1" i="0">
+              <a:rPr sz="1250" b="1" i="0">
                 <a:solidFill>
                   <a:srgbClr val="0A1F44"/>
                 </a:solidFill>
               </a:rPr>
-              <a:t>اختبار الـ API باستخدام Postman</a:t>
+              <a:t>API Testing with Postman</a:t>
             </a:r>
           </a:p>
         </p:txBody>
@@ -13991,7 +13949,7 @@
                   <a:srgbClr val="1F2937"/>
                 </a:solidFill>
               </a:rPr>
-              <a:t>▸  كتابة Assertions في Postman</a:t>
+              <a:t>▸  Writing Assertions in Postman</a:t>
             </a:r>
           </a:p>
         </p:txBody>
@@ -14025,7 +13983,7 @@
                   <a:srgbClr val="1F2937"/>
                 </a:solidFill>
               </a:rPr>
-              <a:t>▸  تشغيل Collection Runner</a:t>
+              <a:t>▸  Running Collection Runner</a:t>
             </a:r>
           </a:p>
         </p:txBody>
@@ -14104,7 +14062,7 @@
                   <a:srgbClr val="FFFFFF"/>
                 </a:solidFill>
               </a:rPr>
-              <a:t>📊 تدفق طلب API</a:t>
+              <a:t>📊 API Request/Response Flow</a:t>
             </a:r>
           </a:p>
         </p:txBody>
@@ -14334,12 +14292,12 @@
           <a:p>
             <a:pPr algn="l"/>
             <a:r>
-              <a:rPr sz="1300" b="1" i="0">
+              <a:rPr sz="1250" b="1" i="0">
                 <a:solidFill>
                   <a:srgbClr val="0A1F44"/>
                 </a:solidFill>
               </a:rPr>
-              <a:t>إدارة العيوب والتقارير</a:t>
+              <a:t>Defect Management &amp; Reporting</a:t>
             </a:r>
           </a:p>
         </p:txBody>
@@ -14450,7 +14408,7 @@
                   <a:srgbClr val="1F2937"/>
                 </a:solidFill>
               </a:rPr>
-              <a:t>▸  كتابة Bug Report احترافي</a:t>
+              <a:t>▸  Writing a Professional Bug Report</a:t>
             </a:r>
           </a:p>
         </p:txBody>
@@ -14518,7 +14476,7 @@
                   <a:srgbClr val="1F2937"/>
                 </a:solidFill>
               </a:rPr>
-              <a:t>▸  إدارة الاختبارات في Jira</a:t>
+              <a:t>▸  Managing Tests in Jira</a:t>
             </a:r>
           </a:p>
         </p:txBody>
@@ -14597,7 +14555,7 @@
                   <a:srgbClr val="FFFFFF"/>
                 </a:solidFill>
               </a:rPr>
-              <a:t>📊 دورة حياة العيوب</a:t>
+              <a:t>📊 Bug Life Cycle Flow</a:t>
             </a:r>
           </a:p>
         </p:txBody>
@@ -14758,7 +14716,7 @@
         <p:spPr>
           <a:xfrm>
             <a:off x="365760" y="137160"/>
-            <a:ext cx="4572000" cy="594360"/>
+            <a:ext cx="9144000" cy="594360"/>
           </a:xfrm>
           <a:prstGeom prst="rect">
             <a:avLst/>
@@ -14773,12 +14731,12 @@
           <a:p>
             <a:pPr algn="l"/>
             <a:r>
-              <a:rPr sz="3200" b="1" i="0">
+              <a:rPr sz="3000" b="1" i="0">
                 <a:solidFill>
                   <a:srgbClr val="FFFFFF"/>
                 </a:solidFill>
               </a:rPr>
-              <a:t>الشهر الثاني</a:t>
+              <a:t>Month 2 — Professional Track</a:t>
             </a:r>
           </a:p>
         </p:txBody>
@@ -14812,7 +14770,7 @@
                   <a:srgbClr val="06B6D4"/>
                 </a:solidFill>
               </a:rPr>
-              <a:t>Professional Track — الأدوات والمهارات المتقدمة  (Lectures 7–12)</a:t>
+              <a:t>Advanced Tools &amp; Industry Skills  (Lectures 7 – 12)</a:t>
             </a:r>
           </a:p>
         </p:txBody>
@@ -15042,12 +15000,12 @@
           <a:p>
             <a:pPr algn="l"/>
             <a:r>
-              <a:rPr sz="1300" b="1" i="0">
+              <a:rPr sz="1250" b="1" i="0">
                 <a:solidFill>
                   <a:srgbClr val="0A1F44"/>
                 </a:solidFill>
               </a:rPr>
-              <a:t>مقدمة اختبار الأداء</a:t>
+              <a:t>Introduction to Performance Testing</a:t>
             </a:r>
           </a:p>
         </p:txBody>
@@ -15124,7 +15082,7 @@
                   <a:srgbClr val="1F2937"/>
                 </a:solidFill>
               </a:rPr>
-              <a:t>▸  ما هو Performance Testing؟</a:t>
+              <a:t>▸  What is Performance Testing?</a:t>
             </a:r>
           </a:p>
         </p:txBody>
@@ -15192,7 +15150,7 @@
                   <a:srgbClr val="1F2937"/>
                 </a:solidFill>
               </a:rPr>
-              <a:t>▸  مقاييس الأداء الأساسية</a:t>
+              <a:t>▸  Key Performance Metrics</a:t>
             </a:r>
           </a:p>
         </p:txBody>
@@ -15226,7 +15184,7 @@
                   <a:srgbClr val="1F2937"/>
                 </a:solidFill>
               </a:rPr>
-              <a:t>▸  أدوات اختبار الأداء</a:t>
+              <a:t>▸  Performance Testing Tools Overview</a:t>
             </a:r>
           </a:p>
         </p:txBody>
@@ -15305,7 +15263,7 @@
                   <a:srgbClr val="FFFFFF"/>
                 </a:solidFill>
               </a:rPr>
-              <a:t>📊 منحنى الحمل والأداء</a:t>
+              <a:t>📊 Load vs Response Time Curve</a:t>
             </a:r>
           </a:p>
         </p:txBody>
@@ -15535,12 +15493,12 @@
           <a:p>
             <a:pPr algn="l"/>
             <a:r>
-              <a:rPr sz="1300" b="1" i="0">
+              <a:rPr sz="1250" b="1" i="0">
                 <a:solidFill>
                   <a:srgbClr val="0A1F44"/>
                 </a:solidFill>
               </a:rPr>
-              <a:t>JMeter — بناء خطط الاختبار</a:t>
+              <a:t>JMeter — Building Test Plans</a:t>
             </a:r>
           </a:p>
         </p:txBody>
@@ -15617,7 +15575,7 @@
                   <a:srgbClr val="1F2937"/>
                 </a:solidFill>
               </a:rPr>
-              <a:t>▸  واجهة JMeter وعناصرها</a:t>
+              <a:t>▸  JMeter Interface &amp; Components</a:t>
             </a:r>
           </a:p>
         </p:txBody>
@@ -15685,7 +15643,7 @@
                   <a:srgbClr val="1F2937"/>
                 </a:solidFill>
               </a:rPr>
-              <a:t>▸  Listeners &amp; Reports</a:t>
+              <a:t>▸  Listeners &amp; Result Analysis</a:t>
             </a:r>
           </a:p>
         </p:txBody>
@@ -15719,7 +15677,7 @@
                   <a:srgbClr val="1F2937"/>
                 </a:solidFill>
               </a:rPr>
-              <a:t>▸  تشغيل اختبار حمل كامل</a:t>
+              <a:t>▸  Running a Full Load Test</a:t>
             </a:r>
           </a:p>
         </p:txBody>
@@ -15798,7 +15756,7 @@
                   <a:srgbClr val="FFFFFF"/>
                 </a:solidFill>
               </a:rPr>
-              <a:t>📊 مخطط نتائج JMeter</a:t>
+              <a:t>📊 JMeter Results Dashboard</a:t>
             </a:r>
           </a:p>
         </p:txBody>
@@ -16028,12 +15986,12 @@
           <a:p>
             <a:pPr algn="l"/>
             <a:r>
-              <a:rPr sz="1300" b="1" i="0">
+              <a:rPr sz="1250" b="1" i="0">
                 <a:solidFill>
                   <a:srgbClr val="0A1F44"/>
                 </a:solidFill>
               </a:rPr>
-              <a:t>مقدمة أتمتة الاختبار</a:t>
+              <a:t>Introduction to Test Automation</a:t>
             </a:r>
           </a:p>
         </p:txBody>
@@ -16110,7 +16068,7 @@
                   <a:srgbClr val="1F2937"/>
                 </a:solidFill>
               </a:rPr>
-              <a:t>▸  متى تؤتمت؟ الأطر والمفاهيم</a:t>
+              <a:t>▸  When to Automate? Frameworks &amp; Concepts</a:t>
             </a:r>
           </a:p>
         </p:txBody>
@@ -16178,7 +16136,7 @@
                   <a:srgbClr val="1F2937"/>
                 </a:solidFill>
               </a:rPr>
-              <a:t>▸  Selenium + Python أساسيات</a:t>
+              <a:t>▸  Selenium + Python Basics</a:t>
             </a:r>
           </a:p>
         </p:txBody>
@@ -16212,7 +16170,7 @@
                   <a:srgbClr val="1F2937"/>
                 </a:solidFill>
               </a:rPr>
-              <a:t>▸  تشغيل أول اختبار آلي</a:t>
+              <a:t>▸  Running Your First Automated Test</a:t>
             </a:r>
           </a:p>
         </p:txBody>
@@ -16291,7 +16249,7 @@
                   <a:srgbClr val="FFFFFF"/>
                 </a:solidFill>
               </a:rPr>
-              <a:t>📊 هيكلية POM</a:t>
+              <a:t>📊 POM Architecture Diagram</a:t>
             </a:r>
           </a:p>
         </p:txBody>
@@ -16521,12 +16479,12 @@
           <a:p>
             <a:pPr algn="l"/>
             <a:r>
-              <a:rPr sz="1300" b="1" i="0">
+              <a:rPr sz="1250" b="1" i="0">
                 <a:solidFill>
                   <a:srgbClr val="0A1F44"/>
                 </a:solidFill>
               </a:rPr>
-              <a:t>Selenium WebDriver مع Python</a:t>
+              <a:t>Selenium WebDriver with Python</a:t>
             </a:r>
           </a:p>
         </p:txBody>
@@ -16603,7 +16561,7 @@
                   <a:srgbClr val="1F2937"/>
                 </a:solidFill>
               </a:rPr>
-              <a:t>▸  Locators: ID / XPath / CSS</a:t>
+              <a:t>▸  Locators: ID / XPath / CSS Selector</a:t>
             </a:r>
           </a:p>
         </p:txBody>
@@ -16705,7 +16663,7 @@
                   <a:srgbClr val="1F2937"/>
                 </a:solidFill>
               </a:rPr>
-              <a:t>▸  تشغيل Test Suite كاملة</a:t>
+              <a:t>▸  Running a Full Test Suite</a:t>
             </a:r>
           </a:p>
         </p:txBody>
@@ -16784,7 +16742,7 @@
                   <a:srgbClr val="FFFFFF"/>
                 </a:solidFill>
               </a:rPr>
-              <a:t>📊 تدفق اختبار Selenium</a:t>
+              <a:t>📊 Selenium Test Execution Flow</a:t>
             </a:r>
           </a:p>
         </p:txBody>
@@ -17014,12 +16972,12 @@
           <a:p>
             <a:pPr algn="l"/>
             <a:r>
-              <a:rPr sz="1300" b="1" i="0">
+              <a:rPr sz="1250" b="1" i="0">
                 <a:solidFill>
                   <a:srgbClr val="0A1F44"/>
                 </a:solidFill>
               </a:rPr>
-              <a:t>CI/CD والاختبار المستمر</a:t>
+              <a:t>CI/CD &amp; Continuous Testing</a:t>
             </a:r>
           </a:p>
         </p:txBody>
@@ -17096,7 +17054,7 @@
                   <a:srgbClr val="1F2937"/>
                 </a:solidFill>
               </a:rPr>
-              <a:t>▸  مفهوم CI/CD في عالم QA</a:t>
+              <a:t>▸  CI/CD Concepts for QA Engineers</a:t>
             </a:r>
           </a:p>
         </p:txBody>
@@ -17130,7 +17088,7 @@
                   <a:srgbClr val="1F2937"/>
                 </a:solidFill>
               </a:rPr>
-              <a:t>▸  GitHub Actions للاختبار</a:t>
+              <a:t>▸  GitHub Actions for Testing</a:t>
             </a:r>
           </a:p>
         </p:txBody>
@@ -17164,7 +17122,7 @@
                   <a:srgbClr val="1F2937"/>
                 </a:solidFill>
               </a:rPr>
-              <a:t>▸  تقارير الاختبار الآلية</a:t>
+              <a:t>▸  Automated Test Reporting</a:t>
             </a:r>
           </a:p>
         </p:txBody>
@@ -17198,7 +17156,7 @@
                   <a:srgbClr val="1F2937"/>
                 </a:solidFill>
               </a:rPr>
-              <a:t>▸  Agile &amp; Scrum Testing</a:t>
+              <a:t>▸  Agile &amp; Scrum Testing Practices</a:t>
             </a:r>
           </a:p>
         </p:txBody>
@@ -17277,7 +17235,7 @@
                   <a:srgbClr val="FFFFFF"/>
                 </a:solidFill>
               </a:rPr>
-              <a:t>📊 خط أنابيب CI/CD</a:t>
+              <a:t>📊 CI/CD Pipeline Diagram</a:t>
             </a:r>
           </a:p>
         </p:txBody>
@@ -17507,12 +17465,12 @@
           <a:p>
             <a:pPr algn="l"/>
             <a:r>
-              <a:rPr sz="1300" b="1" i="0">
+              <a:rPr sz="1250" b="1" i="0">
                 <a:solidFill>
                   <a:srgbClr val="0A1F44"/>
                 </a:solidFill>
               </a:rPr>
-              <a:t>مشروع التخرج والتوجيه الوظيفي</a:t>
+              <a:t>Capstone Project &amp; Career Prep</a:t>
             </a:r>
           </a:p>
         </p:txBody>
@@ -17589,7 +17547,7 @@
                   <a:srgbClr val="1F2937"/>
                 </a:solidFill>
               </a:rPr>
-              <a:t>▸  مشروع تخرج شامل</a:t>
+              <a:t>▸  End-to-End Capstone Project</a:t>
             </a:r>
           </a:p>
         </p:txBody>
@@ -17623,7 +17581,7 @@
                   <a:srgbClr val="1F2937"/>
                 </a:solidFill>
               </a:rPr>
-              <a:t>▸  ISTQB Foundation مراجعة</a:t>
+              <a:t>▸  ISTQB Foundation Level Review</a:t>
             </a:r>
           </a:p>
         </p:txBody>
@@ -17657,7 +17615,7 @@
                   <a:srgbClr val="1F2937"/>
                 </a:solidFill>
               </a:rPr>
-              <a:t>▸  بناء CV لـ QA Engineer</a:t>
+              <a:t>▸  Building a QA Engineer CV</a:t>
             </a:r>
           </a:p>
         </p:txBody>
@@ -17691,7 +17649,7 @@
                   <a:srgbClr val="1F2937"/>
                 </a:solidFill>
               </a:rPr>
-              <a:t>▸  التحضير لمقابلات العمل</a:t>
+              <a:t>▸  Job Interview Preparation</a:t>
             </a:r>
           </a:p>
         </p:txBody>
@@ -17770,7 +17728,7 @@
                   <a:srgbClr val="FFFFFF"/>
                 </a:solidFill>
               </a:rPr>
-              <a:t>📊 مشروع تخرج تطبيقي</a:t>
+              <a:t>📊 Capstone Project Walkthrough</a:t>
             </a:r>
           </a:p>
         </p:txBody>
@@ -17973,7 +17931,7 @@
         </p:nvSpPr>
         <p:spPr>
           <a:xfrm>
-            <a:off x="365760" y="182880"/>
+            <a:off x="365760" y="164592"/>
             <a:ext cx="10972800" cy="594360"/>
           </a:xfrm>
           <a:prstGeom prst="rect">
@@ -17989,12 +17947,12 @@
           <a:p>
             <a:pPr algn="l"/>
             <a:r>
-              <a:rPr sz="2800" b="1" i="0">
+              <a:rPr sz="2600" b="1" i="0">
                 <a:solidFill>
                   <a:srgbClr val="FFFFFF"/>
                 </a:solidFill>
               </a:rPr>
-              <a:t>��️  الأدوات التي ستتقنها</a:t>
+              <a:t>🛠️  Tools &amp; Technologies You Will Master</a:t>
             </a:r>
           </a:p>
         </p:txBody>
@@ -18007,7 +17965,7 @@
         </p:nvSpPr>
         <p:spPr>
           <a:xfrm>
-            <a:off x="365760" y="777240"/>
+            <a:off x="365760" y="749808"/>
             <a:ext cx="10972800" cy="347472"/>
           </a:xfrm>
           <a:prstGeom prst="rect">
@@ -18028,7 +17986,7 @@
                   <a:srgbClr val="9CA3AF"/>
                 </a:solidFill>
               </a:rPr>
-              <a:t>Tools &amp; Technologies You Will Master</a:t>
+              <a:t>Gain hands-on experience with the industry's leading QA and testing tools</a:t>
             </a:r>
           </a:p>
         </p:txBody>
@@ -18383,7 +18341,7 @@
                   <a:srgbClr val="1A56DB"/>
                 </a:solidFill>
               </a:rPr>
-              <a:t>��</a:t>
+              <a:t>📊</a:t>
             </a:r>
           </a:p>
         </p:txBody>
@@ -18417,7 +18375,7 @@
                   <a:srgbClr val="FFFFFF"/>
                 </a:solidFill>
               </a:rPr>
-              <a:t>JMeter</a:t>
+              <a:t>Apache JMeter</a:t>
             </a:r>
           </a:p>
         </p:txBody>
@@ -18684,7 +18642,7 @@
                   <a:srgbClr val="9CA3AF"/>
                 </a:solidFill>
               </a:rPr>
-              <a:t>UI Automation</a:t>
+              <a:t>UI Test Automation</a:t>
             </a:r>
           </a:p>
         </p:txBody>
@@ -19383,7 +19341,7 @@
                   <a:srgbClr val="9CA3AF"/>
                 </a:solidFill>
               </a:rPr>
-              <a:t>CI/CD Pipeline</a:t>
+              <a:t>CI/CD Pipelines</a:t>
             </a:r>
           </a:p>
         </p:txBody>
@@ -19548,7 +19506,7 @@
                   <a:srgbClr val="F97316"/>
                 </a:solidFill>
               </a:rPr>
-              <a:t>��</a:t>
+              <a:t>📁</a:t>
             </a:r>
           </a:p>
         </p:txBody>
@@ -20068,12 +20026,12 @@
           <a:p>
             <a:pPr algn="l"/>
             <a:r>
-              <a:rPr sz="2600" b="1" i="0">
+              <a:rPr sz="2400" b="1" i="0">
                 <a:solidFill>
                   <a:srgbClr val="0A1F44"/>
                 </a:solidFill>
               </a:rPr>
-              <a:t>🗺️  رحلة التعلم — من المبتدئ إلى المحترف</a:t>
+              <a:t>🗺️  Learning Journey — From Beginner to QA Professional</a:t>
             </a:r>
           </a:p>
         </p:txBody>
@@ -20107,7 +20065,7 @@
                   <a:srgbClr val="9CA3AF"/>
                 </a:solidFill>
               </a:rPr>
-              <a:t>Learning Journey — Step by Step Progress Path</a:t>
+              <a:t>Step-by-step weekly progress path across the 2-month program</a:t>
             </a:r>
           </a:p>
         </p:txBody>
@@ -20315,7 +20273,7 @@
                   <a:srgbClr val="FFFFFF"/>
                 </a:solidFill>
               </a:rPr>
-              <a:t>Week 1-2</a:t>
+              <a:t>Week 1–2</a:t>
             </a:r>
           </a:p>
         </p:txBody>
@@ -20349,8 +20307,8 @@
                   <a:srgbClr val="0A1F44"/>
                 </a:solidFill>
               </a:rPr>
-              <a:t>المفاهيم الأساسية
-وبيئة العمل</a:t>
+              <a:t>Testing Basics
+&amp; Environment Setup</a:t>
             </a:r>
           </a:p>
         </p:txBody>
@@ -20515,7 +20473,7 @@
                   <a:srgbClr val="FFFFFF"/>
                 </a:solidFill>
               </a:rPr>
-              <a:t>Week 3-4</a:t>
+              <a:t>Week 3–4</a:t>
             </a:r>
           </a:p>
         </p:txBody>
@@ -20549,8 +20507,8 @@
                   <a:srgbClr val="0A1F44"/>
                 </a:solidFill>
               </a:rPr>
-              <a:t>تصميم
-حالات الاختبار</a:t>
+              <a:t>Test Design
+Techniques</a:t>
             </a:r>
           </a:p>
         </p:txBody>
@@ -20715,7 +20673,7 @@
                   <a:srgbClr val="FFFFFF"/>
                 </a:solidFill>
               </a:rPr>
-              <a:t>Week 5-6</a:t>
+              <a:t>Week 5–6</a:t>
             </a:r>
           </a:p>
         </p:txBody>
@@ -20749,8 +20707,8 @@
                   <a:srgbClr val="0A1F44"/>
                 </a:solidFill>
               </a:rPr>
-              <a:t>الاختبار اليدوي
-واختبار API</a:t>
+              <a:t>Manual Testing
+&amp; API Testing</a:t>
             </a:r>
           </a:p>
         </p:txBody>
@@ -20915,7 +20873,7 @@
                   <a:srgbClr val="FFFFFF"/>
                 </a:solidFill>
               </a:rPr>
-              <a:t>Week 7-8</a:t>
+              <a:t>Week 7–8</a:t>
             </a:r>
           </a:p>
         </p:txBody>
@@ -20949,8 +20907,8 @@
                   <a:srgbClr val="0A1F44"/>
                 </a:solidFill>
               </a:rPr>
-              <a:t>اختبار الأداء
-باستخدام JMeter</a:t>
+              <a:t>Performance Testing
+with JMeter</a:t>
             </a:r>
           </a:p>
         </p:txBody>
@@ -21115,7 +21073,7 @@
                   <a:srgbClr val="FFFFFF"/>
                 </a:solidFill>
               </a:rPr>
-              <a:t>Week 9-10</a:t>
+              <a:t>Week 9–10</a:t>
             </a:r>
           </a:p>
         </p:txBody>
@@ -21149,7 +21107,7 @@
                   <a:srgbClr val="0A1F44"/>
                 </a:solidFill>
               </a:rPr>
-              <a:t>أتمتة الاختبار
+              <a:t>Test Automation
 Selenium + Python</a:t>
             </a:r>
           </a:p>
@@ -21315,7 +21273,7 @@
                   <a:srgbClr val="FFFFFF"/>
                 </a:solidFill>
               </a:rPr>
-              <a:t>Week 11-12</a:t>
+              <a:t>Week 11–12</a:t>
             </a:r>
           </a:p>
         </p:txBody>
@@ -21349,8 +21307,8 @@
                   <a:srgbClr val="0A1F44"/>
                 </a:solidFill>
               </a:rPr>
-              <a:t>مشروع التخرج
-والوظيفة</a:t>
+              <a:t>Capstone Project
+&amp; Career Prep</a:t>
             </a:r>
           </a:p>
         </p:txBody>
@@ -21496,7 +21454,7 @@
                   <a:srgbClr val="06B6D4"/>
                 </a:solidFill>
               </a:rPr>
-              <a:t>✅  بعد 8 أسابيع ستكون مؤهلاً لوظيفة Junior QA Engineer وجاهزاً لشهادة ISTQB Foundation Level</a:t>
+              <a:t>✅  After 8 weeks you will be qualified to apply for Junior QA Engineer roles and sit the ISTQB Foundation Level exam</a:t>
             </a:r>
           </a:p>
         </p:txBody>
@@ -21677,7 +21635,7 @@
                   <a:srgbClr val="FFFFFF"/>
                 </a:solidFill>
               </a:rPr>
-              <a:t>👥  لمن هذا البرنامج؟</a:t>
+              <a:t>👥  Who Is This Program For?</a:t>
             </a:r>
           </a:p>
         </p:txBody>
@@ -21910,7 +21868,7 @@
                   <a:srgbClr val="0A1F44"/>
                 </a:solidFill>
               </a:rPr>
-              <a:t>خريجو تقنية المعلومات</a:t>
+              <a:t>IT &amp; CS Graduates</a:t>
             </a:r>
           </a:p>
         </p:txBody>
@@ -21944,7 +21902,7 @@
                   <a:srgbClr val="1F2937"/>
                 </a:solidFill>
               </a:rPr>
-              <a:t>حديثو التخرج في IT أو علوم الحاسب الراغبون في دخول سوق العمل</a:t>
+              <a:t>Recent IT or Computer Science graduates looking to enter the job market</a:t>
             </a:r>
           </a:p>
         </p:txBody>
@@ -22143,7 +22101,7 @@
                   <a:srgbClr val="0A1F44"/>
                 </a:solidFill>
               </a:rPr>
-              <a:t>المحولون للتقنية</a:t>
+              <a:t>Career Changers</a:t>
             </a:r>
           </a:p>
         </p:txBody>
@@ -22177,7 +22135,7 @@
                   <a:srgbClr val="1F2937"/>
                 </a:solidFill>
               </a:rPr>
-              <a:t>أفراد من مجالات أخرى يرغبون في التحول إلى مجال ضمان الجودة</a:t>
+              <a:t>Professionals from other fields seeking to transition into QA engineering</a:t>
             </a:r>
           </a:p>
         </p:txBody>
@@ -22376,7 +22334,7 @@
                   <a:srgbClr val="0A1F44"/>
                 </a:solidFill>
               </a:rPr>
-              <a:t>المطورون المبتدئون</a:t>
+              <a:t>Junior Developers</a:t>
             </a:r>
           </a:p>
         </p:txBody>
@@ -22410,7 +22368,7 @@
                   <a:srgbClr val="1F2937"/>
                 </a:solidFill>
               </a:rPr>
-              <a:t>مطورو برامج يريدون فهم الاختبار لتحسين جودة كودهم</a:t>
+              <a:t>Software developers wanting to understand testing and improve code quality</a:t>
             </a:r>
           </a:p>
         </p:txBody>
@@ -22609,7 +22567,7 @@
                   <a:srgbClr val="0A1F44"/>
                 </a:solidFill>
               </a:rPr>
-              <a:t>مديرو المشاريع</a:t>
+              <a:t>Project Managers</a:t>
             </a:r>
           </a:p>
         </p:txBody>
@@ -22643,7 +22601,7 @@
                   <a:srgbClr val="1F2937"/>
                 </a:solidFill>
               </a:rPr>
-              <a:t>أفراد يعملون في إدارة المشاريع ويريدون فهم عمليات QA</a:t>
+              <a:t>Professionals in project management who want to understand QA processes</a:t>
             </a:r>
           </a:p>
         </p:txBody>
@@ -22677,7 +22635,7 @@
                   <a:srgbClr val="0A1F44"/>
                 </a:solidFill>
               </a:rPr>
-              <a:t>المتطلبات الأساسية للانضمام:</a:t>
+              <a:t>Basic Enrollment Requirements:</a:t>
             </a:r>
           </a:p>
         </p:txBody>
@@ -22711,7 +22669,7 @@
                   <a:srgbClr val="1F2937"/>
                 </a:solidFill>
               </a:rPr>
-              <a:t>✅  لا يشترط خبرة مسبقة في اختبار البرمجيات</a:t>
+              <a:t>✅  No prior software testing experience required</a:t>
             </a:r>
           </a:p>
         </p:txBody>
@@ -22745,7 +22703,7 @@
                   <a:srgbClr val="1F2937"/>
                 </a:solidFill>
               </a:rPr>
-              <a:t>✅  معرفة أساسية باستخدام الحاسب والإنترنت</a:t>
+              <a:t>✅  Basic familiarity with computers and the internet</a:t>
             </a:r>
           </a:p>
         </p:txBody>
@@ -22779,7 +22737,7 @@
                   <a:srgbClr val="1F2937"/>
                 </a:solidFill>
               </a:rPr>
-              <a:t>✅  رغبة صادقة في التعلم والتطور المهني</a:t>
+              <a:t>✅  Genuine motivation to learn and grow professionally</a:t>
             </a:r>
           </a:p>
         </p:txBody>
@@ -22813,7 +22771,7 @@
                   <a:srgbClr val="1F2937"/>
                 </a:solidFill>
               </a:rPr>
-              <a:t>✅  حاسب شخصي (Windows / Mac / Linux) مع اتصال إنترنت</a:t>
+              <a:t>✅  A personal computer (Windows / Mac / Linux) with internet access</a:t>
             </a:r>
           </a:p>
         </p:txBody>

</xml_diff>

<commit_message>
Add pricing slide (Slide 15): 3-tier Early Bird/Standard/VIP pricing in SAR
Co-authored-by: Razan-Eldaif <183640167+Razan-Eldaif@users.noreply.github.com>
</commit_message>
<xml_diff>
--- a/Software_Testing_Diploma_Beginners.pptx
+++ b/Software_Testing_Diploma_Beginners.pptx
@@ -19,6 +19,7 @@
     <p:sldId id="267" r:id="rId18"/>
     <p:sldId id="268" r:id="rId19"/>
     <p:sldId id="269" r:id="rId20"/>
+    <p:sldId id="271" r:id="rId22"/>
     <p:sldId id="270" r:id="rId21"/>
   </p:sldIdLst>
   <p:sldSz cx="12188952" cy="6858000" type="screen4x3"/>
@@ -14754,6 +14755,2133 @@
                 </a:solidFill>
               </a:rPr>
               <a:t>info@example.com  |  www.example.com</a:t>
+            </a:r>
+          </a:p>
+        </p:txBody>
+      </p:sp>
+    </p:spTree>
+  </p:cSld>
+  <p:clrMapOvr>
+    <a:masterClrMapping/>
+  </p:clrMapOvr>
+</p:sld>
+</file>
+
+<file path=ppt/slides/slide16.xml><?xml version="1.0" encoding="utf-8"?>
+<p:sld xmlns:a="http://schemas.openxmlformats.org/drawingml/2006/main" xmlns:p="http://schemas.openxmlformats.org/presentationml/2006/main" xmlns:r="http://schemas.openxmlformats.org/officeDocument/2006/relationships">
+  <p:cSld>
+    <p:spTree>
+      <p:nvGrpSpPr>
+        <p:cNvPr id="1" name=""/>
+        <p:cNvGrpSpPr/>
+        <p:nvPr/>
+      </p:nvGrpSpPr>
+      <p:grpSpPr/>
+      <p:sp>
+        <p:nvSpPr>
+          <p:cNvPr id="2" name="Rectangle 1"/>
+          <p:cNvSpPr/>
+          <p:nvPr/>
+        </p:nvSpPr>
+        <p:spPr>
+          <a:xfrm>
+            <a:off x="0" y="0"/>
+            <a:ext cx="12188952" cy="6858000"/>
+          </a:xfrm>
+          <a:prstGeom prst="rect">
+            <a:avLst/>
+          </a:prstGeom>
+          <a:solidFill>
+            <a:srgbClr val="FFFFFF"/>
+          </a:solidFill>
+          <a:ln>
+            <a:noFill/>
+          </a:ln>
+        </p:spPr>
+        <p:style>
+          <a:lnRef idx="1">
+            <a:schemeClr val="accent1"/>
+          </a:lnRef>
+          <a:fillRef idx="3">
+            <a:schemeClr val="accent1"/>
+          </a:fillRef>
+          <a:effectRef idx="2">
+            <a:schemeClr val="accent1"/>
+          </a:effectRef>
+          <a:fontRef idx="minor">
+            <a:schemeClr val="lt1"/>
+          </a:fontRef>
+        </p:style>
+        <p:txBody>
+          <a:bodyPr rtlCol="0" anchor="ctr"/>
+          <a:lstStyle/>
+          <a:p>
+            <a:pPr algn="ctr"/>
+          </a:p>
+        </p:txBody>
+      </p:sp>
+      <p:sp>
+        <p:nvSpPr>
+          <p:cNvPr id="3" name="Rectangle 2"/>
+          <p:cNvSpPr/>
+          <p:nvPr/>
+        </p:nvSpPr>
+        <p:spPr>
+          <a:xfrm>
+            <a:off x="0" y="0"/>
+            <a:ext cx="12188952" cy="1115568"/>
+          </a:xfrm>
+          <a:prstGeom prst="rect">
+            <a:avLst/>
+          </a:prstGeom>
+          <a:solidFill>
+            <a:srgbClr val="0A1F44"/>
+          </a:solidFill>
+          <a:ln>
+            <a:noFill/>
+          </a:ln>
+        </p:spPr>
+        <p:style>
+          <a:lnRef idx="1">
+            <a:schemeClr val="accent1"/>
+          </a:lnRef>
+          <a:fillRef idx="3">
+            <a:schemeClr val="accent1"/>
+          </a:fillRef>
+          <a:effectRef idx="2">
+            <a:schemeClr val="accent1"/>
+          </a:effectRef>
+          <a:fontRef idx="minor">
+            <a:schemeClr val="lt1"/>
+          </a:fontRef>
+        </p:style>
+        <p:txBody>
+          <a:bodyPr rtlCol="0" anchor="ctr"/>
+          <a:lstStyle/>
+          <a:p>
+            <a:pPr algn="ctr"/>
+          </a:p>
+        </p:txBody>
+      </p:sp>
+      <p:sp>
+        <p:nvSpPr>
+          <p:cNvPr id="4" name="Rectangle 3"/>
+          <p:cNvSpPr/>
+          <p:nvPr/>
+        </p:nvSpPr>
+        <p:spPr>
+          <a:xfrm>
+            <a:off x="0" y="0"/>
+            <a:ext cx="109728" cy="6858000"/>
+          </a:xfrm>
+          <a:prstGeom prst="rect">
+            <a:avLst/>
+          </a:prstGeom>
+          <a:solidFill>
+            <a:srgbClr val="06B6D4"/>
+          </a:solidFill>
+          <a:ln>
+            <a:noFill/>
+          </a:ln>
+        </p:spPr>
+        <p:style>
+          <a:lnRef idx="1">
+            <a:schemeClr val="accent1"/>
+          </a:lnRef>
+          <a:fillRef idx="3">
+            <a:schemeClr val="accent1"/>
+          </a:fillRef>
+          <a:effectRef idx="2">
+            <a:schemeClr val="accent1"/>
+          </a:effectRef>
+          <a:fontRef idx="minor">
+            <a:schemeClr val="lt1"/>
+          </a:fontRef>
+        </p:style>
+        <p:txBody>
+          <a:bodyPr rtlCol="0" anchor="ctr"/>
+          <a:lstStyle/>
+          <a:p>
+            <a:pPr algn="ctr"/>
+          </a:p>
+        </p:txBody>
+      </p:sp>
+      <p:sp>
+        <p:nvSpPr>
+          <p:cNvPr id="5" name="TextBox 4"/>
+          <p:cNvSpPr txBox="1"/>
+          <p:nvPr/>
+        </p:nvSpPr>
+        <p:spPr>
+          <a:xfrm>
+            <a:off x="256032" y="201168"/>
+            <a:ext cx="10972800" cy="329184"/>
+          </a:xfrm>
+          <a:prstGeom prst="rect">
+            <a:avLst/>
+          </a:prstGeom>
+          <a:noFill/>
+        </p:spPr>
+        <p:txBody>
+          <a:bodyPr wrap="square">
+            <a:spAutoFit/>
+          </a:bodyPr>
+          <a:lstStyle/>
+          <a:p>
+            <a:pPr algn="l"/>
+            <a:r>
+              <a:rPr sz="1000" b="1" i="0">
+                <a:solidFill>
+                  <a:srgbClr val="06B6D4"/>
+                </a:solidFill>
+              </a:rPr>
+              <a:t>PRICING</a:t>
+            </a:r>
+          </a:p>
+        </p:txBody>
+      </p:sp>
+      <p:sp>
+        <p:nvSpPr>
+          <p:cNvPr id="6" name="TextBox 5"/>
+          <p:cNvSpPr txBox="1"/>
+          <p:nvPr/>
+        </p:nvSpPr>
+        <p:spPr>
+          <a:xfrm>
+            <a:off x="256032" y="512064"/>
+            <a:ext cx="11430000" cy="566928"/>
+          </a:xfrm>
+          <a:prstGeom prst="rect">
+            <a:avLst/>
+          </a:prstGeom>
+          <a:noFill/>
+        </p:spPr>
+        <p:txBody>
+          <a:bodyPr wrap="square">
+            <a:spAutoFit/>
+          </a:bodyPr>
+          <a:lstStyle/>
+          <a:p>
+            <a:pPr algn="l"/>
+            <a:r>
+              <a:rPr sz="2400" b="1" i="0">
+                <a:solidFill>
+                  <a:srgbClr val="FFFFFF"/>
+                </a:solidFill>
+              </a:rPr>
+              <a:t>Program Pricing — Choose Your Plan</a:t>
+            </a:r>
+          </a:p>
+        </p:txBody>
+      </p:sp>
+      <p:sp>
+        <p:nvSpPr>
+          <p:cNvPr id="7" name="TextBox 6"/>
+          <p:cNvSpPr txBox="1"/>
+          <p:nvPr/>
+        </p:nvSpPr>
+        <p:spPr>
+          <a:xfrm>
+            <a:off x="256032" y="987552"/>
+            <a:ext cx="11430000" cy="329184"/>
+          </a:xfrm>
+          <a:prstGeom prst="rect">
+            <a:avLst/>
+          </a:prstGeom>
+          <a:noFill/>
+        </p:spPr>
+        <p:txBody>
+          <a:bodyPr wrap="square">
+            <a:spAutoFit/>
+          </a:bodyPr>
+          <a:lstStyle/>
+          <a:p>
+            <a:pPr algn="l"/>
+            <a:r>
+              <a:rPr sz="1200" b="0" i="0">
+                <a:solidFill>
+                  <a:srgbClr val="DBEAFF"/>
+                </a:solidFill>
+              </a:rPr>
+              <a:t>2-month Software Testing Diploma · All prices in SAR · Adjust to suit your market</a:t>
+            </a:r>
+          </a:p>
+        </p:txBody>
+      </p:sp>
+      <p:sp>
+        <p:nvSpPr>
+          <p:cNvPr id="8" name="Rectangle 7"/>
+          <p:cNvSpPr/>
+          <p:nvPr/>
+        </p:nvSpPr>
+        <p:spPr>
+          <a:xfrm>
+            <a:off x="461772" y="1417320"/>
+            <a:ext cx="3474720" cy="4389120"/>
+          </a:xfrm>
+          <a:prstGeom prst="rect">
+            <a:avLst/>
+          </a:prstGeom>
+          <a:solidFill>
+            <a:srgbClr val="0A1F44"/>
+          </a:solidFill>
+          <a:ln>
+            <a:noFill/>
+          </a:ln>
+        </p:spPr>
+        <p:style>
+          <a:lnRef idx="1">
+            <a:schemeClr val="accent1"/>
+          </a:lnRef>
+          <a:fillRef idx="3">
+            <a:schemeClr val="accent1"/>
+          </a:fillRef>
+          <a:effectRef idx="2">
+            <a:schemeClr val="accent1"/>
+          </a:effectRef>
+          <a:fontRef idx="minor">
+            <a:schemeClr val="lt1"/>
+          </a:fontRef>
+        </p:style>
+        <p:txBody>
+          <a:bodyPr rtlCol="0" anchor="ctr"/>
+          <a:lstStyle/>
+          <a:p>
+            <a:pPr algn="ctr"/>
+          </a:p>
+        </p:txBody>
+      </p:sp>
+      <p:sp>
+        <p:nvSpPr>
+          <p:cNvPr id="9" name="Rectangle 8"/>
+          <p:cNvSpPr/>
+          <p:nvPr/>
+        </p:nvSpPr>
+        <p:spPr>
+          <a:xfrm>
+            <a:off x="461772" y="1417320"/>
+            <a:ext cx="3474720" cy="73152"/>
+          </a:xfrm>
+          <a:prstGeom prst="rect">
+            <a:avLst/>
+          </a:prstGeom>
+          <a:solidFill>
+            <a:srgbClr val="1A56DB"/>
+          </a:solidFill>
+          <a:ln>
+            <a:noFill/>
+          </a:ln>
+        </p:spPr>
+        <p:style>
+          <a:lnRef idx="1">
+            <a:schemeClr val="accent1"/>
+          </a:lnRef>
+          <a:fillRef idx="3">
+            <a:schemeClr val="accent1"/>
+          </a:fillRef>
+          <a:effectRef idx="2">
+            <a:schemeClr val="accent1"/>
+          </a:effectRef>
+          <a:fontRef idx="minor">
+            <a:schemeClr val="lt1"/>
+          </a:fontRef>
+        </p:style>
+        <p:txBody>
+          <a:bodyPr rtlCol="0" anchor="ctr"/>
+          <a:lstStyle/>
+          <a:p>
+            <a:pPr algn="ctr"/>
+          </a:p>
+        </p:txBody>
+      </p:sp>
+      <p:sp>
+        <p:nvSpPr>
+          <p:cNvPr id="10" name="Rectangle 9"/>
+          <p:cNvSpPr/>
+          <p:nvPr/>
+        </p:nvSpPr>
+        <p:spPr>
+          <a:xfrm>
+            <a:off x="1056132" y="1618488"/>
+            <a:ext cx="2286000" cy="292608"/>
+          </a:xfrm>
+          <a:prstGeom prst="rect">
+            <a:avLst/>
+          </a:prstGeom>
+          <a:solidFill>
+            <a:srgbClr val="1A56DB"/>
+          </a:solidFill>
+          <a:ln>
+            <a:noFill/>
+          </a:ln>
+        </p:spPr>
+        <p:style>
+          <a:lnRef idx="1">
+            <a:schemeClr val="accent1"/>
+          </a:lnRef>
+          <a:fillRef idx="3">
+            <a:schemeClr val="accent1"/>
+          </a:fillRef>
+          <a:effectRef idx="2">
+            <a:schemeClr val="accent1"/>
+          </a:effectRef>
+          <a:fontRef idx="minor">
+            <a:schemeClr val="lt1"/>
+          </a:fontRef>
+        </p:style>
+        <p:txBody>
+          <a:bodyPr rtlCol="0" anchor="ctr"/>
+          <a:lstStyle/>
+          <a:p>
+            <a:pPr algn="ctr"/>
+          </a:p>
+        </p:txBody>
+      </p:sp>
+      <p:sp>
+        <p:nvSpPr>
+          <p:cNvPr id="11" name="TextBox 10"/>
+          <p:cNvSpPr txBox="1"/>
+          <p:nvPr/>
+        </p:nvSpPr>
+        <p:spPr>
+          <a:xfrm>
+            <a:off x="1056132" y="1618488"/>
+            <a:ext cx="2286000" cy="292608"/>
+          </a:xfrm>
+          <a:prstGeom prst="rect">
+            <a:avLst/>
+          </a:prstGeom>
+          <a:noFill/>
+        </p:spPr>
+        <p:txBody>
+          <a:bodyPr wrap="square">
+            <a:spAutoFit/>
+          </a:bodyPr>
+          <a:lstStyle/>
+          <a:p>
+            <a:pPr algn="ctr"/>
+            <a:r>
+              <a:rPr sz="1000" b="1" i="0">
+                <a:solidFill>
+                  <a:srgbClr val="FFFFFF"/>
+                </a:solidFill>
+              </a:rPr>
+              <a:t>Limited Seats</a:t>
+            </a:r>
+          </a:p>
+        </p:txBody>
+      </p:sp>
+      <p:sp>
+        <p:nvSpPr>
+          <p:cNvPr id="12" name="TextBox 11"/>
+          <p:cNvSpPr txBox="1"/>
+          <p:nvPr/>
+        </p:nvSpPr>
+        <p:spPr>
+          <a:xfrm>
+            <a:off x="644652" y="2075688"/>
+            <a:ext cx="3108960" cy="457200"/>
+          </a:xfrm>
+          <a:prstGeom prst="rect">
+            <a:avLst/>
+          </a:prstGeom>
+          <a:noFill/>
+        </p:spPr>
+        <p:txBody>
+          <a:bodyPr wrap="square">
+            <a:spAutoFit/>
+          </a:bodyPr>
+          <a:lstStyle/>
+          <a:p>
+            <a:pPr algn="ctr"/>
+            <a:r>
+              <a:rPr sz="1800" b="1" i="0">
+                <a:solidFill>
+                  <a:srgbClr val="1A56DB"/>
+                </a:solidFill>
+              </a:rPr>
+              <a:t>Early Bird</a:t>
+            </a:r>
+          </a:p>
+        </p:txBody>
+      </p:sp>
+      <p:sp>
+        <p:nvSpPr>
+          <p:cNvPr id="13" name="TextBox 12"/>
+          <p:cNvSpPr txBox="1"/>
+          <p:nvPr/>
+        </p:nvSpPr>
+        <p:spPr>
+          <a:xfrm>
+            <a:off x="644652" y="2551176"/>
+            <a:ext cx="3108960" cy="658368"/>
+          </a:xfrm>
+          <a:prstGeom prst="rect">
+            <a:avLst/>
+          </a:prstGeom>
+          <a:noFill/>
+        </p:spPr>
+        <p:txBody>
+          <a:bodyPr wrap="square">
+            <a:spAutoFit/>
+          </a:bodyPr>
+          <a:lstStyle/>
+          <a:p>
+            <a:pPr algn="ctr"/>
+            <a:r>
+              <a:rPr sz="4200" b="1" i="0">
+                <a:solidFill>
+                  <a:srgbClr val="FFFFFF"/>
+                </a:solidFill>
+              </a:rPr>
+              <a:t>299</a:t>
+            </a:r>
+          </a:p>
+        </p:txBody>
+      </p:sp>
+      <p:sp>
+        <p:nvSpPr>
+          <p:cNvPr id="14" name="TextBox 13"/>
+          <p:cNvSpPr txBox="1"/>
+          <p:nvPr/>
+        </p:nvSpPr>
+        <p:spPr>
+          <a:xfrm>
+            <a:off x="644652" y="3209544"/>
+            <a:ext cx="3108960" cy="274320"/>
+          </a:xfrm>
+          <a:prstGeom prst="rect">
+            <a:avLst/>
+          </a:prstGeom>
+          <a:noFill/>
+        </p:spPr>
+        <p:txBody>
+          <a:bodyPr wrap="square">
+            <a:spAutoFit/>
+          </a:bodyPr>
+          <a:lstStyle/>
+          <a:p>
+            <a:pPr algn="ctr"/>
+            <a:r>
+              <a:rPr sz="1100" b="0" i="0">
+                <a:solidFill>
+                  <a:srgbClr val="9CA3AF"/>
+                </a:solidFill>
+              </a:rPr>
+              <a:t>SAR  ·  one-time</a:t>
+            </a:r>
+          </a:p>
+        </p:txBody>
+      </p:sp>
+      <p:sp>
+        <p:nvSpPr>
+          <p:cNvPr id="15" name="Rectangle 14"/>
+          <p:cNvSpPr/>
+          <p:nvPr/>
+        </p:nvSpPr>
+        <p:spPr>
+          <a:xfrm>
+            <a:off x="736092" y="3538728"/>
+            <a:ext cx="2926080" cy="12700"/>
+          </a:xfrm>
+          <a:prstGeom prst="rect">
+            <a:avLst/>
+          </a:prstGeom>
+          <a:solidFill>
+            <a:srgbClr val="1A56DB"/>
+          </a:solidFill>
+          <a:ln>
+            <a:noFill/>
+          </a:ln>
+        </p:spPr>
+        <p:style>
+          <a:lnRef idx="1">
+            <a:schemeClr val="accent1"/>
+          </a:lnRef>
+          <a:fillRef idx="3">
+            <a:schemeClr val="accent1"/>
+          </a:fillRef>
+          <a:effectRef idx="2">
+            <a:schemeClr val="accent1"/>
+          </a:effectRef>
+          <a:fontRef idx="minor">
+            <a:schemeClr val="lt1"/>
+          </a:fontRef>
+        </p:style>
+        <p:txBody>
+          <a:bodyPr rtlCol="0" anchor="ctr"/>
+          <a:lstStyle/>
+          <a:p>
+            <a:pPr algn="ctr"/>
+          </a:p>
+        </p:txBody>
+      </p:sp>
+      <p:sp>
+        <p:nvSpPr>
+          <p:cNvPr id="16" name="TextBox 15"/>
+          <p:cNvSpPr txBox="1"/>
+          <p:nvPr/>
+        </p:nvSpPr>
+        <p:spPr>
+          <a:xfrm>
+            <a:off x="662940" y="3703320"/>
+            <a:ext cx="3108960" cy="301752"/>
+          </a:xfrm>
+          <a:prstGeom prst="rect">
+            <a:avLst/>
+          </a:prstGeom>
+          <a:noFill/>
+        </p:spPr>
+        <p:txBody>
+          <a:bodyPr wrap="square">
+            <a:spAutoFit/>
+          </a:bodyPr>
+          <a:lstStyle/>
+          <a:p>
+            <a:pPr algn="l"/>
+            <a:r>
+              <a:rPr sz="1050" b="0" i="0">
+                <a:solidFill>
+                  <a:srgbClr val="FFFFFF"/>
+                </a:solidFill>
+              </a:rPr>
+              <a:t>✓  Full 12-lecture curriculum</a:t>
+            </a:r>
+          </a:p>
+        </p:txBody>
+      </p:sp>
+      <p:sp>
+        <p:nvSpPr>
+          <p:cNvPr id="17" name="TextBox 16"/>
+          <p:cNvSpPr txBox="1"/>
+          <p:nvPr/>
+        </p:nvSpPr>
+        <p:spPr>
+          <a:xfrm>
+            <a:off x="662940" y="4032504"/>
+            <a:ext cx="3108960" cy="301752"/>
+          </a:xfrm>
+          <a:prstGeom prst="rect">
+            <a:avLst/>
+          </a:prstGeom>
+          <a:noFill/>
+        </p:spPr>
+        <p:txBody>
+          <a:bodyPr wrap="square">
+            <a:spAutoFit/>
+          </a:bodyPr>
+          <a:lstStyle/>
+          <a:p>
+            <a:pPr algn="l"/>
+            <a:r>
+              <a:rPr sz="1050" b="0" i="0">
+                <a:solidFill>
+                  <a:srgbClr val="9CA3AF"/>
+                </a:solidFill>
+              </a:rPr>
+              <a:t>✓  Playwright + JS examples</a:t>
+            </a:r>
+          </a:p>
+        </p:txBody>
+      </p:sp>
+      <p:sp>
+        <p:nvSpPr>
+          <p:cNvPr id="18" name="TextBox 17"/>
+          <p:cNvSpPr txBox="1"/>
+          <p:nvPr/>
+        </p:nvSpPr>
+        <p:spPr>
+          <a:xfrm>
+            <a:off x="662940" y="4361688"/>
+            <a:ext cx="3108960" cy="301752"/>
+          </a:xfrm>
+          <a:prstGeom prst="rect">
+            <a:avLst/>
+          </a:prstGeom>
+          <a:noFill/>
+        </p:spPr>
+        <p:txBody>
+          <a:bodyPr wrap="square">
+            <a:spAutoFit/>
+          </a:bodyPr>
+          <a:lstStyle/>
+          <a:p>
+            <a:pPr algn="l"/>
+            <a:r>
+              <a:rPr sz="1050" b="0" i="0">
+                <a:solidFill>
+                  <a:srgbClr val="FFFFFF"/>
+                </a:solidFill>
+              </a:rPr>
+              <a:t>✓  Jira test cases &amp; bug reports</a:t>
+            </a:r>
+          </a:p>
+        </p:txBody>
+      </p:sp>
+      <p:sp>
+        <p:nvSpPr>
+          <p:cNvPr id="19" name="TextBox 18"/>
+          <p:cNvSpPr txBox="1"/>
+          <p:nvPr/>
+        </p:nvSpPr>
+        <p:spPr>
+          <a:xfrm>
+            <a:off x="662940" y="4690872"/>
+            <a:ext cx="3108960" cy="301752"/>
+          </a:xfrm>
+          <a:prstGeom prst="rect">
+            <a:avLst/>
+          </a:prstGeom>
+          <a:noFill/>
+        </p:spPr>
+        <p:txBody>
+          <a:bodyPr wrap="square">
+            <a:spAutoFit/>
+          </a:bodyPr>
+          <a:lstStyle/>
+          <a:p>
+            <a:pPr algn="l"/>
+            <a:r>
+              <a:rPr sz="1050" b="0" i="0">
+                <a:solidFill>
+                  <a:srgbClr val="9CA3AF"/>
+                </a:solidFill>
+              </a:rPr>
+              <a:t>✓  GitHub portfolio guidance</a:t>
+            </a:r>
+          </a:p>
+        </p:txBody>
+      </p:sp>
+      <p:sp>
+        <p:nvSpPr>
+          <p:cNvPr id="20" name="TextBox 19"/>
+          <p:cNvSpPr txBox="1"/>
+          <p:nvPr/>
+        </p:nvSpPr>
+        <p:spPr>
+          <a:xfrm>
+            <a:off x="662940" y="5020056"/>
+            <a:ext cx="3108960" cy="301752"/>
+          </a:xfrm>
+          <a:prstGeom prst="rect">
+            <a:avLst/>
+          </a:prstGeom>
+          <a:noFill/>
+        </p:spPr>
+        <p:txBody>
+          <a:bodyPr wrap="square">
+            <a:spAutoFit/>
+          </a:bodyPr>
+          <a:lstStyle/>
+          <a:p>
+            <a:pPr algn="l"/>
+            <a:r>
+              <a:rPr sz="1050" b="0" i="0">
+                <a:solidFill>
+                  <a:srgbClr val="FFFFFF"/>
+                </a:solidFill>
+              </a:rPr>
+              <a:t>✓  Course certificate</a:t>
+            </a:r>
+          </a:p>
+        </p:txBody>
+      </p:sp>
+      <p:sp>
+        <p:nvSpPr>
+          <p:cNvPr id="21" name="TextBox 20"/>
+          <p:cNvSpPr txBox="1"/>
+          <p:nvPr/>
+        </p:nvSpPr>
+        <p:spPr>
+          <a:xfrm>
+            <a:off x="662940" y="5349240"/>
+            <a:ext cx="3108960" cy="301752"/>
+          </a:xfrm>
+          <a:prstGeom prst="rect">
+            <a:avLst/>
+          </a:prstGeom>
+          <a:noFill/>
+        </p:spPr>
+        <p:txBody>
+          <a:bodyPr wrap="square">
+            <a:spAutoFit/>
+          </a:bodyPr>
+          <a:lstStyle/>
+          <a:p>
+            <a:pPr algn="l"/>
+            <a:r>
+              <a:rPr sz="1050" b="0" i="0">
+                <a:solidFill>
+                  <a:srgbClr val="9CA3AF"/>
+                </a:solidFill>
+              </a:rPr>
+              <a:t>✓  Community support (chat)</a:t>
+            </a:r>
+          </a:p>
+        </p:txBody>
+      </p:sp>
+      <p:sp>
+        <p:nvSpPr>
+          <p:cNvPr id="22" name="Rectangle 21"/>
+          <p:cNvSpPr/>
+          <p:nvPr/>
+        </p:nvSpPr>
+        <p:spPr>
+          <a:xfrm>
+            <a:off x="918972" y="5239512"/>
+            <a:ext cx="2560320" cy="438912"/>
+          </a:xfrm>
+          <a:prstGeom prst="rect">
+            <a:avLst/>
+          </a:prstGeom>
+          <a:solidFill>
+            <a:srgbClr val="1A56DB"/>
+          </a:solidFill>
+          <a:ln>
+            <a:noFill/>
+          </a:ln>
+        </p:spPr>
+        <p:style>
+          <a:lnRef idx="1">
+            <a:schemeClr val="accent1"/>
+          </a:lnRef>
+          <a:fillRef idx="3">
+            <a:schemeClr val="accent1"/>
+          </a:fillRef>
+          <a:effectRef idx="2">
+            <a:schemeClr val="accent1"/>
+          </a:effectRef>
+          <a:fontRef idx="minor">
+            <a:schemeClr val="lt1"/>
+          </a:fontRef>
+        </p:style>
+        <p:txBody>
+          <a:bodyPr rtlCol="0" anchor="ctr"/>
+          <a:lstStyle/>
+          <a:p>
+            <a:pPr algn="ctr"/>
+          </a:p>
+        </p:txBody>
+      </p:sp>
+      <p:sp>
+        <p:nvSpPr>
+          <p:cNvPr id="23" name="TextBox 22"/>
+          <p:cNvSpPr txBox="1"/>
+          <p:nvPr/>
+        </p:nvSpPr>
+        <p:spPr>
+          <a:xfrm>
+            <a:off x="918972" y="5239512"/>
+            <a:ext cx="2560320" cy="438912"/>
+          </a:xfrm>
+          <a:prstGeom prst="rect">
+            <a:avLst/>
+          </a:prstGeom>
+          <a:noFill/>
+        </p:spPr>
+        <p:txBody>
+          <a:bodyPr wrap="square">
+            <a:spAutoFit/>
+          </a:bodyPr>
+          <a:lstStyle/>
+          <a:p>
+            <a:pPr algn="ctr"/>
+            <a:r>
+              <a:rPr sz="1300" b="1" i="0">
+                <a:solidFill>
+                  <a:srgbClr val="FFFFFF"/>
+                </a:solidFill>
+              </a:rPr>
+              <a:t>Register Early</a:t>
+            </a:r>
+          </a:p>
+        </p:txBody>
+      </p:sp>
+      <p:sp>
+        <p:nvSpPr>
+          <p:cNvPr id="24" name="Rectangle 23"/>
+          <p:cNvSpPr/>
+          <p:nvPr/>
+        </p:nvSpPr>
+        <p:spPr>
+          <a:xfrm>
+            <a:off x="4357116" y="1216152"/>
+            <a:ext cx="3474720" cy="4791456"/>
+          </a:xfrm>
+          <a:prstGeom prst="rect">
+            <a:avLst/>
+          </a:prstGeom>
+          <a:solidFill>
+            <a:srgbClr val="042A38"/>
+          </a:solidFill>
+          <a:ln>
+            <a:noFill/>
+          </a:ln>
+        </p:spPr>
+        <p:style>
+          <a:lnRef idx="1">
+            <a:schemeClr val="accent1"/>
+          </a:lnRef>
+          <a:fillRef idx="3">
+            <a:schemeClr val="accent1"/>
+          </a:fillRef>
+          <a:effectRef idx="2">
+            <a:schemeClr val="accent1"/>
+          </a:effectRef>
+          <a:fontRef idx="minor">
+            <a:schemeClr val="lt1"/>
+          </a:fontRef>
+        </p:style>
+        <p:txBody>
+          <a:bodyPr rtlCol="0" anchor="ctr"/>
+          <a:lstStyle/>
+          <a:p>
+            <a:pPr algn="ctr"/>
+          </a:p>
+        </p:txBody>
+      </p:sp>
+      <p:sp>
+        <p:nvSpPr>
+          <p:cNvPr id="25" name="Rectangle 24"/>
+          <p:cNvSpPr/>
+          <p:nvPr/>
+        </p:nvSpPr>
+        <p:spPr>
+          <a:xfrm>
+            <a:off x="4357116" y="1216152"/>
+            <a:ext cx="3474720" cy="109728"/>
+          </a:xfrm>
+          <a:prstGeom prst="rect">
+            <a:avLst/>
+          </a:prstGeom>
+          <a:solidFill>
+            <a:srgbClr val="06B6D4"/>
+          </a:solidFill>
+          <a:ln>
+            <a:noFill/>
+          </a:ln>
+        </p:spPr>
+        <p:style>
+          <a:lnRef idx="1">
+            <a:schemeClr val="accent1"/>
+          </a:lnRef>
+          <a:fillRef idx="3">
+            <a:schemeClr val="accent1"/>
+          </a:fillRef>
+          <a:effectRef idx="2">
+            <a:schemeClr val="accent1"/>
+          </a:effectRef>
+          <a:fontRef idx="minor">
+            <a:schemeClr val="lt1"/>
+          </a:fontRef>
+        </p:style>
+        <p:txBody>
+          <a:bodyPr rtlCol="0" anchor="ctr"/>
+          <a:lstStyle/>
+          <a:p>
+            <a:pPr algn="ctr"/>
+          </a:p>
+        </p:txBody>
+      </p:sp>
+      <p:sp>
+        <p:nvSpPr>
+          <p:cNvPr id="26" name="Rectangle 25"/>
+          <p:cNvSpPr/>
+          <p:nvPr/>
+        </p:nvSpPr>
+        <p:spPr>
+          <a:xfrm>
+            <a:off x="4951476" y="1453896"/>
+            <a:ext cx="2286000" cy="292608"/>
+          </a:xfrm>
+          <a:prstGeom prst="rect">
+            <a:avLst/>
+          </a:prstGeom>
+          <a:solidFill>
+            <a:srgbClr val="06B6D4"/>
+          </a:solidFill>
+          <a:ln>
+            <a:noFill/>
+          </a:ln>
+        </p:spPr>
+        <p:style>
+          <a:lnRef idx="1">
+            <a:schemeClr val="accent1"/>
+          </a:lnRef>
+          <a:fillRef idx="3">
+            <a:schemeClr val="accent1"/>
+          </a:fillRef>
+          <a:effectRef idx="2">
+            <a:schemeClr val="accent1"/>
+          </a:effectRef>
+          <a:fontRef idx="minor">
+            <a:schemeClr val="lt1"/>
+          </a:fontRef>
+        </p:style>
+        <p:txBody>
+          <a:bodyPr rtlCol="0" anchor="ctr"/>
+          <a:lstStyle/>
+          <a:p>
+            <a:pPr algn="ctr"/>
+          </a:p>
+        </p:txBody>
+      </p:sp>
+      <p:sp>
+        <p:nvSpPr>
+          <p:cNvPr id="27" name="TextBox 26"/>
+          <p:cNvSpPr txBox="1"/>
+          <p:nvPr/>
+        </p:nvSpPr>
+        <p:spPr>
+          <a:xfrm>
+            <a:off x="4951476" y="1453896"/>
+            <a:ext cx="2286000" cy="292608"/>
+          </a:xfrm>
+          <a:prstGeom prst="rect">
+            <a:avLst/>
+          </a:prstGeom>
+          <a:noFill/>
+        </p:spPr>
+        <p:txBody>
+          <a:bodyPr wrap="square">
+            <a:spAutoFit/>
+          </a:bodyPr>
+          <a:lstStyle/>
+          <a:p>
+            <a:pPr algn="ctr"/>
+            <a:r>
+              <a:rPr sz="1000" b="1" i="0">
+                <a:solidFill>
+                  <a:srgbClr val="0A1F44"/>
+                </a:solidFill>
+              </a:rPr>
+              <a:t>Most Popular</a:t>
+            </a:r>
+          </a:p>
+        </p:txBody>
+      </p:sp>
+      <p:sp>
+        <p:nvSpPr>
+          <p:cNvPr id="28" name="TextBox 27"/>
+          <p:cNvSpPr txBox="1"/>
+          <p:nvPr/>
+        </p:nvSpPr>
+        <p:spPr>
+          <a:xfrm>
+            <a:off x="4539996" y="1911096"/>
+            <a:ext cx="3108960" cy="457200"/>
+          </a:xfrm>
+          <a:prstGeom prst="rect">
+            <a:avLst/>
+          </a:prstGeom>
+          <a:noFill/>
+        </p:spPr>
+        <p:txBody>
+          <a:bodyPr wrap="square">
+            <a:spAutoFit/>
+          </a:bodyPr>
+          <a:lstStyle/>
+          <a:p>
+            <a:pPr algn="ctr"/>
+            <a:r>
+              <a:rPr sz="1800" b="1" i="0">
+                <a:solidFill>
+                  <a:srgbClr val="06B6D4"/>
+                </a:solidFill>
+              </a:rPr>
+              <a:t>Standard</a:t>
+            </a:r>
+          </a:p>
+        </p:txBody>
+      </p:sp>
+      <p:sp>
+        <p:nvSpPr>
+          <p:cNvPr id="29" name="TextBox 28"/>
+          <p:cNvSpPr txBox="1"/>
+          <p:nvPr/>
+        </p:nvSpPr>
+        <p:spPr>
+          <a:xfrm>
+            <a:off x="4539996" y="2386584"/>
+            <a:ext cx="3108960" cy="658368"/>
+          </a:xfrm>
+          <a:prstGeom prst="rect">
+            <a:avLst/>
+          </a:prstGeom>
+          <a:noFill/>
+        </p:spPr>
+        <p:txBody>
+          <a:bodyPr wrap="square">
+            <a:spAutoFit/>
+          </a:bodyPr>
+          <a:lstStyle/>
+          <a:p>
+            <a:pPr algn="ctr"/>
+            <a:r>
+              <a:rPr sz="4200" b="1" i="0">
+                <a:solidFill>
+                  <a:srgbClr val="FFFFFF"/>
+                </a:solidFill>
+              </a:rPr>
+              <a:t>449</a:t>
+            </a:r>
+          </a:p>
+        </p:txBody>
+      </p:sp>
+      <p:sp>
+        <p:nvSpPr>
+          <p:cNvPr id="30" name="TextBox 29"/>
+          <p:cNvSpPr txBox="1"/>
+          <p:nvPr/>
+        </p:nvSpPr>
+        <p:spPr>
+          <a:xfrm>
+            <a:off x="4539996" y="3044952"/>
+            <a:ext cx="3108960" cy="274320"/>
+          </a:xfrm>
+          <a:prstGeom prst="rect">
+            <a:avLst/>
+          </a:prstGeom>
+          <a:noFill/>
+        </p:spPr>
+        <p:txBody>
+          <a:bodyPr wrap="square">
+            <a:spAutoFit/>
+          </a:bodyPr>
+          <a:lstStyle/>
+          <a:p>
+            <a:pPr algn="ctr"/>
+            <a:r>
+              <a:rPr sz="1100" b="0" i="0">
+                <a:solidFill>
+                  <a:srgbClr val="9CA3AF"/>
+                </a:solidFill>
+              </a:rPr>
+              <a:t>SAR  ·  one-time</a:t>
+            </a:r>
+          </a:p>
+        </p:txBody>
+      </p:sp>
+      <p:sp>
+        <p:nvSpPr>
+          <p:cNvPr id="31" name="Rectangle 30"/>
+          <p:cNvSpPr/>
+          <p:nvPr/>
+        </p:nvSpPr>
+        <p:spPr>
+          <a:xfrm>
+            <a:off x="4631436" y="3374136"/>
+            <a:ext cx="2926080" cy="12700"/>
+          </a:xfrm>
+          <a:prstGeom prst="rect">
+            <a:avLst/>
+          </a:prstGeom>
+          <a:solidFill>
+            <a:srgbClr val="06B6D4"/>
+          </a:solidFill>
+          <a:ln>
+            <a:noFill/>
+          </a:ln>
+        </p:spPr>
+        <p:style>
+          <a:lnRef idx="1">
+            <a:schemeClr val="accent1"/>
+          </a:lnRef>
+          <a:fillRef idx="3">
+            <a:schemeClr val="accent1"/>
+          </a:fillRef>
+          <a:effectRef idx="2">
+            <a:schemeClr val="accent1"/>
+          </a:effectRef>
+          <a:fontRef idx="minor">
+            <a:schemeClr val="lt1"/>
+          </a:fontRef>
+        </p:style>
+        <p:txBody>
+          <a:bodyPr rtlCol="0" anchor="ctr"/>
+          <a:lstStyle/>
+          <a:p>
+            <a:pPr algn="ctr"/>
+          </a:p>
+        </p:txBody>
+      </p:sp>
+      <p:sp>
+        <p:nvSpPr>
+          <p:cNvPr id="32" name="TextBox 31"/>
+          <p:cNvSpPr txBox="1"/>
+          <p:nvPr/>
+        </p:nvSpPr>
+        <p:spPr>
+          <a:xfrm>
+            <a:off x="4558284" y="3538728"/>
+            <a:ext cx="3108960" cy="301752"/>
+          </a:xfrm>
+          <a:prstGeom prst="rect">
+            <a:avLst/>
+          </a:prstGeom>
+          <a:noFill/>
+        </p:spPr>
+        <p:txBody>
+          <a:bodyPr wrap="square">
+            <a:spAutoFit/>
+          </a:bodyPr>
+          <a:lstStyle/>
+          <a:p>
+            <a:pPr algn="l"/>
+            <a:r>
+              <a:rPr sz="1050" b="0" i="0">
+                <a:solidFill>
+                  <a:srgbClr val="FFFFFF"/>
+                </a:solidFill>
+              </a:rPr>
+              <a:t>✓  Everything in Early Bird</a:t>
+            </a:r>
+          </a:p>
+        </p:txBody>
+      </p:sp>
+      <p:sp>
+        <p:nvSpPr>
+          <p:cNvPr id="33" name="TextBox 32"/>
+          <p:cNvSpPr txBox="1"/>
+          <p:nvPr/>
+        </p:nvSpPr>
+        <p:spPr>
+          <a:xfrm>
+            <a:off x="4558284" y="3867912"/>
+            <a:ext cx="3108960" cy="301752"/>
+          </a:xfrm>
+          <a:prstGeom prst="rect">
+            <a:avLst/>
+          </a:prstGeom>
+          <a:noFill/>
+        </p:spPr>
+        <p:txBody>
+          <a:bodyPr wrap="square">
+            <a:spAutoFit/>
+          </a:bodyPr>
+          <a:lstStyle/>
+          <a:p>
+            <a:pPr algn="l"/>
+            <a:r>
+              <a:rPr sz="1050" b="0" i="0">
+                <a:solidFill>
+                  <a:srgbClr val="9CA3AF"/>
+                </a:solidFill>
+              </a:rPr>
+              <a:t>✓  Recorded session replays</a:t>
+            </a:r>
+          </a:p>
+        </p:txBody>
+      </p:sp>
+      <p:sp>
+        <p:nvSpPr>
+          <p:cNvPr id="34" name="TextBox 33"/>
+          <p:cNvSpPr txBox="1"/>
+          <p:nvPr/>
+        </p:nvSpPr>
+        <p:spPr>
+          <a:xfrm>
+            <a:off x="4558284" y="4197096"/>
+            <a:ext cx="3108960" cy="301752"/>
+          </a:xfrm>
+          <a:prstGeom prst="rect">
+            <a:avLst/>
+          </a:prstGeom>
+          <a:noFill/>
+        </p:spPr>
+        <p:txBody>
+          <a:bodyPr wrap="square">
+            <a:spAutoFit/>
+          </a:bodyPr>
+          <a:lstStyle/>
+          <a:p>
+            <a:pPr algn="l"/>
+            <a:r>
+              <a:rPr sz="1050" b="0" i="0">
+                <a:solidFill>
+                  <a:srgbClr val="FFFFFF"/>
+                </a:solidFill>
+              </a:rPr>
+              <a:t>✓  Extra practice exercises</a:t>
+            </a:r>
+          </a:p>
+        </p:txBody>
+      </p:sp>
+      <p:sp>
+        <p:nvSpPr>
+          <p:cNvPr id="35" name="TextBox 34"/>
+          <p:cNvSpPr txBox="1"/>
+          <p:nvPr/>
+        </p:nvSpPr>
+        <p:spPr>
+          <a:xfrm>
+            <a:off x="4558284" y="4526280"/>
+            <a:ext cx="3108960" cy="301752"/>
+          </a:xfrm>
+          <a:prstGeom prst="rect">
+            <a:avLst/>
+          </a:prstGeom>
+          <a:noFill/>
+        </p:spPr>
+        <p:txBody>
+          <a:bodyPr wrap="square">
+            <a:spAutoFit/>
+          </a:bodyPr>
+          <a:lstStyle/>
+          <a:p>
+            <a:pPr algn="l"/>
+            <a:r>
+              <a:rPr sz="1050" b="0" i="0">
+                <a:solidFill>
+                  <a:srgbClr val="9CA3AF"/>
+                </a:solidFill>
+              </a:rPr>
+              <a:t>✓  2 live Q&amp;A sessions</a:t>
+            </a:r>
+          </a:p>
+        </p:txBody>
+      </p:sp>
+      <p:sp>
+        <p:nvSpPr>
+          <p:cNvPr id="36" name="TextBox 35"/>
+          <p:cNvSpPr txBox="1"/>
+          <p:nvPr/>
+        </p:nvSpPr>
+        <p:spPr>
+          <a:xfrm>
+            <a:off x="4558284" y="4855464"/>
+            <a:ext cx="3108960" cy="301752"/>
+          </a:xfrm>
+          <a:prstGeom prst="rect">
+            <a:avLst/>
+          </a:prstGeom>
+          <a:noFill/>
+        </p:spPr>
+        <p:txBody>
+          <a:bodyPr wrap="square">
+            <a:spAutoFit/>
+          </a:bodyPr>
+          <a:lstStyle/>
+          <a:p>
+            <a:pPr algn="l"/>
+            <a:r>
+              <a:rPr sz="1050" b="0" i="0">
+                <a:solidFill>
+                  <a:srgbClr val="FFFFFF"/>
+                </a:solidFill>
+              </a:rPr>
+              <a:t>✓  LinkedIn profile review</a:t>
+            </a:r>
+          </a:p>
+        </p:txBody>
+      </p:sp>
+      <p:sp>
+        <p:nvSpPr>
+          <p:cNvPr id="37" name="TextBox 36"/>
+          <p:cNvSpPr txBox="1"/>
+          <p:nvPr/>
+        </p:nvSpPr>
+        <p:spPr>
+          <a:xfrm>
+            <a:off x="4558284" y="5184648"/>
+            <a:ext cx="3108960" cy="301752"/>
+          </a:xfrm>
+          <a:prstGeom prst="rect">
+            <a:avLst/>
+          </a:prstGeom>
+          <a:noFill/>
+        </p:spPr>
+        <p:txBody>
+          <a:bodyPr wrap="square">
+            <a:spAutoFit/>
+          </a:bodyPr>
+          <a:lstStyle/>
+          <a:p>
+            <a:pPr algn="l"/>
+            <a:r>
+              <a:rPr sz="1050" b="0" i="0">
+                <a:solidFill>
+                  <a:srgbClr val="9CA3AF"/>
+                </a:solidFill>
+              </a:rPr>
+              <a:t>✓  Priority community support</a:t>
+            </a:r>
+          </a:p>
+        </p:txBody>
+      </p:sp>
+      <p:sp>
+        <p:nvSpPr>
+          <p:cNvPr id="38" name="Rectangle 37"/>
+          <p:cNvSpPr/>
+          <p:nvPr/>
+        </p:nvSpPr>
+        <p:spPr>
+          <a:xfrm>
+            <a:off x="4814316" y="5440680"/>
+            <a:ext cx="2560320" cy="438912"/>
+          </a:xfrm>
+          <a:prstGeom prst="rect">
+            <a:avLst/>
+          </a:prstGeom>
+          <a:solidFill>
+            <a:srgbClr val="06B6D4"/>
+          </a:solidFill>
+          <a:ln>
+            <a:noFill/>
+          </a:ln>
+        </p:spPr>
+        <p:style>
+          <a:lnRef idx="1">
+            <a:schemeClr val="accent1"/>
+          </a:lnRef>
+          <a:fillRef idx="3">
+            <a:schemeClr val="accent1"/>
+          </a:fillRef>
+          <a:effectRef idx="2">
+            <a:schemeClr val="accent1"/>
+          </a:effectRef>
+          <a:fontRef idx="minor">
+            <a:schemeClr val="lt1"/>
+          </a:fontRef>
+        </p:style>
+        <p:txBody>
+          <a:bodyPr rtlCol="0" anchor="ctr"/>
+          <a:lstStyle/>
+          <a:p>
+            <a:pPr algn="ctr"/>
+          </a:p>
+        </p:txBody>
+      </p:sp>
+      <p:sp>
+        <p:nvSpPr>
+          <p:cNvPr id="39" name="TextBox 38"/>
+          <p:cNvSpPr txBox="1"/>
+          <p:nvPr/>
+        </p:nvSpPr>
+        <p:spPr>
+          <a:xfrm>
+            <a:off x="4814316" y="5440680"/>
+            <a:ext cx="2560320" cy="438912"/>
+          </a:xfrm>
+          <a:prstGeom prst="rect">
+            <a:avLst/>
+          </a:prstGeom>
+          <a:noFill/>
+        </p:spPr>
+        <p:txBody>
+          <a:bodyPr wrap="square">
+            <a:spAutoFit/>
+          </a:bodyPr>
+          <a:lstStyle/>
+          <a:p>
+            <a:pPr algn="ctr"/>
+            <a:r>
+              <a:rPr sz="1300" b="1" i="0">
+                <a:solidFill>
+                  <a:srgbClr val="0A1F44"/>
+                </a:solidFill>
+              </a:rPr>
+              <a:t>Enroll Now</a:t>
+            </a:r>
+          </a:p>
+        </p:txBody>
+      </p:sp>
+      <p:sp>
+        <p:nvSpPr>
+          <p:cNvPr id="40" name="Rectangle 39"/>
+          <p:cNvSpPr/>
+          <p:nvPr/>
+        </p:nvSpPr>
+        <p:spPr>
+          <a:xfrm>
+            <a:off x="8252460" y="1417320"/>
+            <a:ext cx="3474720" cy="4389120"/>
+          </a:xfrm>
+          <a:prstGeom prst="rect">
+            <a:avLst/>
+          </a:prstGeom>
+          <a:solidFill>
+            <a:srgbClr val="1A1404"/>
+          </a:solidFill>
+          <a:ln>
+            <a:noFill/>
+          </a:ln>
+        </p:spPr>
+        <p:style>
+          <a:lnRef idx="1">
+            <a:schemeClr val="accent1"/>
+          </a:lnRef>
+          <a:fillRef idx="3">
+            <a:schemeClr val="accent1"/>
+          </a:fillRef>
+          <a:effectRef idx="2">
+            <a:schemeClr val="accent1"/>
+          </a:effectRef>
+          <a:fontRef idx="minor">
+            <a:schemeClr val="lt1"/>
+          </a:fontRef>
+        </p:style>
+        <p:txBody>
+          <a:bodyPr rtlCol="0" anchor="ctr"/>
+          <a:lstStyle/>
+          <a:p>
+            <a:pPr algn="ctr"/>
+          </a:p>
+        </p:txBody>
+      </p:sp>
+      <p:sp>
+        <p:nvSpPr>
+          <p:cNvPr id="41" name="Rectangle 40"/>
+          <p:cNvSpPr/>
+          <p:nvPr/>
+        </p:nvSpPr>
+        <p:spPr>
+          <a:xfrm>
+            <a:off x="8252460" y="1417320"/>
+            <a:ext cx="3474720" cy="73152"/>
+          </a:xfrm>
+          <a:prstGeom prst="rect">
+            <a:avLst/>
+          </a:prstGeom>
+          <a:solidFill>
+            <a:srgbClr val="D4AF37"/>
+          </a:solidFill>
+          <a:ln>
+            <a:noFill/>
+          </a:ln>
+        </p:spPr>
+        <p:style>
+          <a:lnRef idx="1">
+            <a:schemeClr val="accent1"/>
+          </a:lnRef>
+          <a:fillRef idx="3">
+            <a:schemeClr val="accent1"/>
+          </a:fillRef>
+          <a:effectRef idx="2">
+            <a:schemeClr val="accent1"/>
+          </a:effectRef>
+          <a:fontRef idx="minor">
+            <a:schemeClr val="lt1"/>
+          </a:fontRef>
+        </p:style>
+        <p:txBody>
+          <a:bodyPr rtlCol="0" anchor="ctr"/>
+          <a:lstStyle/>
+          <a:p>
+            <a:pPr algn="ctr"/>
+          </a:p>
+        </p:txBody>
+      </p:sp>
+      <p:sp>
+        <p:nvSpPr>
+          <p:cNvPr id="42" name="Rectangle 41"/>
+          <p:cNvSpPr/>
+          <p:nvPr/>
+        </p:nvSpPr>
+        <p:spPr>
+          <a:xfrm>
+            <a:off x="8846820" y="1618488"/>
+            <a:ext cx="2286000" cy="292608"/>
+          </a:xfrm>
+          <a:prstGeom prst="rect">
+            <a:avLst/>
+          </a:prstGeom>
+          <a:solidFill>
+            <a:srgbClr val="D4AF37"/>
+          </a:solidFill>
+          <a:ln>
+            <a:noFill/>
+          </a:ln>
+        </p:spPr>
+        <p:style>
+          <a:lnRef idx="1">
+            <a:schemeClr val="accent1"/>
+          </a:lnRef>
+          <a:fillRef idx="3">
+            <a:schemeClr val="accent1"/>
+          </a:fillRef>
+          <a:effectRef idx="2">
+            <a:schemeClr val="accent1"/>
+          </a:effectRef>
+          <a:fontRef idx="minor">
+            <a:schemeClr val="lt1"/>
+          </a:fontRef>
+        </p:style>
+        <p:txBody>
+          <a:bodyPr rtlCol="0" anchor="ctr"/>
+          <a:lstStyle/>
+          <a:p>
+            <a:pPr algn="ctr"/>
+          </a:p>
+        </p:txBody>
+      </p:sp>
+      <p:sp>
+        <p:nvSpPr>
+          <p:cNvPr id="43" name="TextBox 42"/>
+          <p:cNvSpPr txBox="1"/>
+          <p:nvPr/>
+        </p:nvSpPr>
+        <p:spPr>
+          <a:xfrm>
+            <a:off x="8846820" y="1618488"/>
+            <a:ext cx="2286000" cy="292608"/>
+          </a:xfrm>
+          <a:prstGeom prst="rect">
+            <a:avLst/>
+          </a:prstGeom>
+          <a:noFill/>
+        </p:spPr>
+        <p:txBody>
+          <a:bodyPr wrap="square">
+            <a:spAutoFit/>
+          </a:bodyPr>
+          <a:lstStyle/>
+          <a:p>
+            <a:pPr algn="ctr"/>
+            <a:r>
+              <a:rPr sz="1000" b="1" i="0">
+                <a:solidFill>
+                  <a:srgbClr val="0A1F44"/>
+                </a:solidFill>
+              </a:rPr>
+              <a:t>Max 5 Students</a:t>
+            </a:r>
+          </a:p>
+        </p:txBody>
+      </p:sp>
+      <p:sp>
+        <p:nvSpPr>
+          <p:cNvPr id="44" name="TextBox 43"/>
+          <p:cNvSpPr txBox="1"/>
+          <p:nvPr/>
+        </p:nvSpPr>
+        <p:spPr>
+          <a:xfrm>
+            <a:off x="8435340" y="2075688"/>
+            <a:ext cx="3108960" cy="457200"/>
+          </a:xfrm>
+          <a:prstGeom prst="rect">
+            <a:avLst/>
+          </a:prstGeom>
+          <a:noFill/>
+        </p:spPr>
+        <p:txBody>
+          <a:bodyPr wrap="square">
+            <a:spAutoFit/>
+          </a:bodyPr>
+          <a:lstStyle/>
+          <a:p>
+            <a:pPr algn="ctr"/>
+            <a:r>
+              <a:rPr sz="1800" b="1" i="0">
+                <a:solidFill>
+                  <a:srgbClr val="D4AF37"/>
+                </a:solidFill>
+              </a:rPr>
+              <a:t>VIP Mentoring</a:t>
+            </a:r>
+          </a:p>
+        </p:txBody>
+      </p:sp>
+      <p:sp>
+        <p:nvSpPr>
+          <p:cNvPr id="45" name="TextBox 44"/>
+          <p:cNvSpPr txBox="1"/>
+          <p:nvPr/>
+        </p:nvSpPr>
+        <p:spPr>
+          <a:xfrm>
+            <a:off x="8435340" y="2551176"/>
+            <a:ext cx="3108960" cy="658368"/>
+          </a:xfrm>
+          <a:prstGeom prst="rect">
+            <a:avLst/>
+          </a:prstGeom>
+          <a:noFill/>
+        </p:spPr>
+        <p:txBody>
+          <a:bodyPr wrap="square">
+            <a:spAutoFit/>
+          </a:bodyPr>
+          <a:lstStyle/>
+          <a:p>
+            <a:pPr algn="ctr"/>
+            <a:r>
+              <a:rPr sz="4200" b="1" i="0">
+                <a:solidFill>
+                  <a:srgbClr val="FFFFFF"/>
+                </a:solidFill>
+              </a:rPr>
+              <a:t>699</a:t>
+            </a:r>
+          </a:p>
+        </p:txBody>
+      </p:sp>
+      <p:sp>
+        <p:nvSpPr>
+          <p:cNvPr id="46" name="TextBox 45"/>
+          <p:cNvSpPr txBox="1"/>
+          <p:nvPr/>
+        </p:nvSpPr>
+        <p:spPr>
+          <a:xfrm>
+            <a:off x="8435340" y="3209544"/>
+            <a:ext cx="3108960" cy="274320"/>
+          </a:xfrm>
+          <a:prstGeom prst="rect">
+            <a:avLst/>
+          </a:prstGeom>
+          <a:noFill/>
+        </p:spPr>
+        <p:txBody>
+          <a:bodyPr wrap="square">
+            <a:spAutoFit/>
+          </a:bodyPr>
+          <a:lstStyle/>
+          <a:p>
+            <a:pPr algn="ctr"/>
+            <a:r>
+              <a:rPr sz="1100" b="0" i="0">
+                <a:solidFill>
+                  <a:srgbClr val="9CA3AF"/>
+                </a:solidFill>
+              </a:rPr>
+              <a:t>SAR  ·  one-time</a:t>
+            </a:r>
+          </a:p>
+        </p:txBody>
+      </p:sp>
+      <p:sp>
+        <p:nvSpPr>
+          <p:cNvPr id="47" name="Rectangle 46"/>
+          <p:cNvSpPr/>
+          <p:nvPr/>
+        </p:nvSpPr>
+        <p:spPr>
+          <a:xfrm>
+            <a:off x="8526780" y="3538728"/>
+            <a:ext cx="2926080" cy="12700"/>
+          </a:xfrm>
+          <a:prstGeom prst="rect">
+            <a:avLst/>
+          </a:prstGeom>
+          <a:solidFill>
+            <a:srgbClr val="D4AF37"/>
+          </a:solidFill>
+          <a:ln>
+            <a:noFill/>
+          </a:ln>
+        </p:spPr>
+        <p:style>
+          <a:lnRef idx="1">
+            <a:schemeClr val="accent1"/>
+          </a:lnRef>
+          <a:fillRef idx="3">
+            <a:schemeClr val="accent1"/>
+          </a:fillRef>
+          <a:effectRef idx="2">
+            <a:schemeClr val="accent1"/>
+          </a:effectRef>
+          <a:fontRef idx="minor">
+            <a:schemeClr val="lt1"/>
+          </a:fontRef>
+        </p:style>
+        <p:txBody>
+          <a:bodyPr rtlCol="0" anchor="ctr"/>
+          <a:lstStyle/>
+          <a:p>
+            <a:pPr algn="ctr"/>
+          </a:p>
+        </p:txBody>
+      </p:sp>
+      <p:sp>
+        <p:nvSpPr>
+          <p:cNvPr id="48" name="TextBox 47"/>
+          <p:cNvSpPr txBox="1"/>
+          <p:nvPr/>
+        </p:nvSpPr>
+        <p:spPr>
+          <a:xfrm>
+            <a:off x="8453628" y="3703320"/>
+            <a:ext cx="3108960" cy="301752"/>
+          </a:xfrm>
+          <a:prstGeom prst="rect">
+            <a:avLst/>
+          </a:prstGeom>
+          <a:noFill/>
+        </p:spPr>
+        <p:txBody>
+          <a:bodyPr wrap="square">
+            <a:spAutoFit/>
+          </a:bodyPr>
+          <a:lstStyle/>
+          <a:p>
+            <a:pPr algn="l"/>
+            <a:r>
+              <a:rPr sz="1050" b="0" i="0">
+                <a:solidFill>
+                  <a:srgbClr val="FFFFFF"/>
+                </a:solidFill>
+              </a:rPr>
+              <a:t>✓  Everything in Standard</a:t>
+            </a:r>
+          </a:p>
+        </p:txBody>
+      </p:sp>
+      <p:sp>
+        <p:nvSpPr>
+          <p:cNvPr id="49" name="TextBox 48"/>
+          <p:cNvSpPr txBox="1"/>
+          <p:nvPr/>
+        </p:nvSpPr>
+        <p:spPr>
+          <a:xfrm>
+            <a:off x="8453628" y="4032504"/>
+            <a:ext cx="3108960" cy="301752"/>
+          </a:xfrm>
+          <a:prstGeom prst="rect">
+            <a:avLst/>
+          </a:prstGeom>
+          <a:noFill/>
+        </p:spPr>
+        <p:txBody>
+          <a:bodyPr wrap="square">
+            <a:spAutoFit/>
+          </a:bodyPr>
+          <a:lstStyle/>
+          <a:p>
+            <a:pPr algn="l"/>
+            <a:r>
+              <a:rPr sz="1050" b="0" i="0">
+                <a:solidFill>
+                  <a:srgbClr val="9CA3AF"/>
+                </a:solidFill>
+              </a:rPr>
+              <a:t>✓  1-on-1 weekly sessions</a:t>
+            </a:r>
+          </a:p>
+        </p:txBody>
+      </p:sp>
+      <p:sp>
+        <p:nvSpPr>
+          <p:cNvPr id="50" name="TextBox 49"/>
+          <p:cNvSpPr txBox="1"/>
+          <p:nvPr/>
+        </p:nvSpPr>
+        <p:spPr>
+          <a:xfrm>
+            <a:off x="8453628" y="4361688"/>
+            <a:ext cx="3108960" cy="301752"/>
+          </a:xfrm>
+          <a:prstGeom prst="rect">
+            <a:avLst/>
+          </a:prstGeom>
+          <a:noFill/>
+        </p:spPr>
+        <p:txBody>
+          <a:bodyPr wrap="square">
+            <a:spAutoFit/>
+          </a:bodyPr>
+          <a:lstStyle/>
+          <a:p>
+            <a:pPr algn="l"/>
+            <a:r>
+              <a:rPr sz="1050" b="0" i="0">
+                <a:solidFill>
+                  <a:srgbClr val="FFFFFF"/>
+                </a:solidFill>
+              </a:rPr>
+              <a:t>✓  Personal project review</a:t>
+            </a:r>
+          </a:p>
+        </p:txBody>
+      </p:sp>
+      <p:sp>
+        <p:nvSpPr>
+          <p:cNvPr id="51" name="TextBox 50"/>
+          <p:cNvSpPr txBox="1"/>
+          <p:nvPr/>
+        </p:nvSpPr>
+        <p:spPr>
+          <a:xfrm>
+            <a:off x="8453628" y="4690872"/>
+            <a:ext cx="3108960" cy="301752"/>
+          </a:xfrm>
+          <a:prstGeom prst="rect">
+            <a:avLst/>
+          </a:prstGeom>
+          <a:noFill/>
+        </p:spPr>
+        <p:txBody>
+          <a:bodyPr wrap="square">
+            <a:spAutoFit/>
+          </a:bodyPr>
+          <a:lstStyle/>
+          <a:p>
+            <a:pPr algn="l"/>
+            <a:r>
+              <a:rPr sz="1050" b="0" i="0">
+                <a:solidFill>
+                  <a:srgbClr val="9CA3AF"/>
+                </a:solidFill>
+              </a:rPr>
+              <a:t>✓  CV &amp; portfolio review</a:t>
+            </a:r>
+          </a:p>
+        </p:txBody>
+      </p:sp>
+      <p:sp>
+        <p:nvSpPr>
+          <p:cNvPr id="52" name="TextBox 51"/>
+          <p:cNvSpPr txBox="1"/>
+          <p:nvPr/>
+        </p:nvSpPr>
+        <p:spPr>
+          <a:xfrm>
+            <a:off x="8453628" y="5020056"/>
+            <a:ext cx="3108960" cy="301752"/>
+          </a:xfrm>
+          <a:prstGeom prst="rect">
+            <a:avLst/>
+          </a:prstGeom>
+          <a:noFill/>
+        </p:spPr>
+        <p:txBody>
+          <a:bodyPr wrap="square">
+            <a:spAutoFit/>
+          </a:bodyPr>
+          <a:lstStyle/>
+          <a:p>
+            <a:pPr algn="l"/>
+            <a:r>
+              <a:rPr sz="1050" b="0" i="0">
+                <a:solidFill>
+                  <a:srgbClr val="FFFFFF"/>
+                </a:solidFill>
+              </a:rPr>
+              <a:t>✓  Job application guidance</a:t>
+            </a:r>
+          </a:p>
+        </p:txBody>
+      </p:sp>
+      <p:sp>
+        <p:nvSpPr>
+          <p:cNvPr id="53" name="TextBox 52"/>
+          <p:cNvSpPr txBox="1"/>
+          <p:nvPr/>
+        </p:nvSpPr>
+        <p:spPr>
+          <a:xfrm>
+            <a:off x="8453628" y="5349240"/>
+            <a:ext cx="3108960" cy="301752"/>
+          </a:xfrm>
+          <a:prstGeom prst="rect">
+            <a:avLst/>
+          </a:prstGeom>
+          <a:noFill/>
+        </p:spPr>
+        <p:txBody>
+          <a:bodyPr wrap="square">
+            <a:spAutoFit/>
+          </a:bodyPr>
+          <a:lstStyle/>
+          <a:p>
+            <a:pPr algn="l"/>
+            <a:r>
+              <a:rPr sz="1050" b="0" i="0">
+                <a:solidFill>
+                  <a:srgbClr val="9CA3AF"/>
+                </a:solidFill>
+              </a:rPr>
+              <a:t>✓  WhatsApp direct access</a:t>
+            </a:r>
+          </a:p>
+        </p:txBody>
+      </p:sp>
+      <p:sp>
+        <p:nvSpPr>
+          <p:cNvPr id="54" name="Rectangle 53"/>
+          <p:cNvSpPr/>
+          <p:nvPr/>
+        </p:nvSpPr>
+        <p:spPr>
+          <a:xfrm>
+            <a:off x="8709660" y="5239512"/>
+            <a:ext cx="2560320" cy="438912"/>
+          </a:xfrm>
+          <a:prstGeom prst="rect">
+            <a:avLst/>
+          </a:prstGeom>
+          <a:solidFill>
+            <a:srgbClr val="D4AF37"/>
+          </a:solidFill>
+          <a:ln>
+            <a:noFill/>
+          </a:ln>
+        </p:spPr>
+        <p:style>
+          <a:lnRef idx="1">
+            <a:schemeClr val="accent1"/>
+          </a:lnRef>
+          <a:fillRef idx="3">
+            <a:schemeClr val="accent1"/>
+          </a:fillRef>
+          <a:effectRef idx="2">
+            <a:schemeClr val="accent1"/>
+          </a:effectRef>
+          <a:fontRef idx="minor">
+            <a:schemeClr val="lt1"/>
+          </a:fontRef>
+        </p:style>
+        <p:txBody>
+          <a:bodyPr rtlCol="0" anchor="ctr"/>
+          <a:lstStyle/>
+          <a:p>
+            <a:pPr algn="ctr"/>
+          </a:p>
+        </p:txBody>
+      </p:sp>
+      <p:sp>
+        <p:nvSpPr>
+          <p:cNvPr id="55" name="TextBox 54"/>
+          <p:cNvSpPr txBox="1"/>
+          <p:nvPr/>
+        </p:nvSpPr>
+        <p:spPr>
+          <a:xfrm>
+            <a:off x="8709660" y="5239512"/>
+            <a:ext cx="2560320" cy="438912"/>
+          </a:xfrm>
+          <a:prstGeom prst="rect">
+            <a:avLst/>
+          </a:prstGeom>
+          <a:noFill/>
+        </p:spPr>
+        <p:txBody>
+          <a:bodyPr wrap="square">
+            <a:spAutoFit/>
+          </a:bodyPr>
+          <a:lstStyle/>
+          <a:p>
+            <a:pPr algn="ctr"/>
+            <a:r>
+              <a:rPr sz="1300" b="1" i="0">
+                <a:solidFill>
+                  <a:srgbClr val="0A1F44"/>
+                </a:solidFill>
+              </a:rPr>
+              <a:t>Apply for VIP</a:t>
+            </a:r>
+          </a:p>
+        </p:txBody>
+      </p:sp>
+      <p:sp>
+        <p:nvSpPr>
+          <p:cNvPr id="56" name="Rectangle 55"/>
+          <p:cNvSpPr/>
+          <p:nvPr/>
+        </p:nvSpPr>
+        <p:spPr>
+          <a:xfrm>
+            <a:off x="256032" y="5998464"/>
+            <a:ext cx="11676888" cy="19050"/>
+          </a:xfrm>
+          <a:prstGeom prst="rect">
+            <a:avLst/>
+          </a:prstGeom>
+          <a:solidFill>
+            <a:srgbClr val="9CA3AF"/>
+          </a:solidFill>
+          <a:ln>
+            <a:noFill/>
+          </a:ln>
+        </p:spPr>
+        <p:style>
+          <a:lnRef idx="1">
+            <a:schemeClr val="accent1"/>
+          </a:lnRef>
+          <a:fillRef idx="3">
+            <a:schemeClr val="accent1"/>
+          </a:fillRef>
+          <a:effectRef idx="2">
+            <a:schemeClr val="accent1"/>
+          </a:effectRef>
+          <a:fontRef idx="minor">
+            <a:schemeClr val="lt1"/>
+          </a:fontRef>
+        </p:style>
+        <p:txBody>
+          <a:bodyPr rtlCol="0" anchor="ctr"/>
+          <a:lstStyle/>
+          <a:p>
+            <a:pPr algn="ctr"/>
+          </a:p>
+        </p:txBody>
+      </p:sp>
+      <p:sp>
+        <p:nvSpPr>
+          <p:cNvPr id="57" name="TextBox 56"/>
+          <p:cNvSpPr txBox="1"/>
+          <p:nvPr/>
+        </p:nvSpPr>
+        <p:spPr>
+          <a:xfrm>
+            <a:off x="256032" y="6071616"/>
+            <a:ext cx="11676888" cy="256032"/>
+          </a:xfrm>
+          <a:prstGeom prst="rect">
+            <a:avLst/>
+          </a:prstGeom>
+          <a:noFill/>
+        </p:spPr>
+        <p:txBody>
+          <a:bodyPr wrap="square">
+            <a:spAutoFit/>
+          </a:bodyPr>
+          <a:lstStyle/>
+          <a:p>
+            <a:pPr algn="ctr"/>
+            <a:r>
+              <a:rPr sz="1000" b="0" i="1">
+                <a:solidFill>
+                  <a:srgbClr val="9CA3AF"/>
+                </a:solidFill>
+              </a:rPr>
+              <a:t>All plans include lifetime access to course materials  •  Certificate issued upon project completion</a:t>
+            </a:r>
+          </a:p>
+        </p:txBody>
+      </p:sp>
+      <p:sp>
+        <p:nvSpPr>
+          <p:cNvPr id="58" name="TextBox 57"/>
+          <p:cNvSpPr txBox="1"/>
+          <p:nvPr/>
+        </p:nvSpPr>
+        <p:spPr>
+          <a:xfrm>
+            <a:off x="256032" y="6364224"/>
+            <a:ext cx="11676888" cy="256032"/>
+          </a:xfrm>
+          <a:prstGeom prst="rect">
+            <a:avLst/>
+          </a:prstGeom>
+          <a:noFill/>
+        </p:spPr>
+        <p:txBody>
+          <a:bodyPr wrap="square">
+            <a:spAutoFit/>
+          </a:bodyPr>
+          <a:lstStyle/>
+          <a:p>
+            <a:pPr algn="ctr"/>
+            <a:r>
+              <a:rPr sz="1000" b="0" i="1">
+                <a:solidFill>
+                  <a:srgbClr val="9CA3AF"/>
+                </a:solidFill>
+              </a:rPr>
+              <a:t>Group discounts available for 3+ enrollments  •  Installment payment available on request</a:t>
             </a:r>
           </a:p>
         </p:txBody>

</xml_diff>